<commit_message>
Finalize public submission artifacts
</commit_message>
<xml_diff>
--- a/artifacts/VELQIRIS_Open_Agent_2026_Pitch_Deck.pptx
+++ b/artifacts/VELQIRIS_Open_Agent_2026_Pitch_Deck.pptx
@@ -2,19 +2,19 @@
 <file path=ppt/presentation.xml><?xml version="1.0" encoding="utf-8"?>
 <p:presentation xmlns:p="http://schemas.openxmlformats.org/presentationml/2006/main">
   <p:sldMasterIdLst>
-    <p:sldMasterId xmlns:r="http://schemas.openxmlformats.org/officeDocument/2006/relationships" id="2147483648" r:id="R12bf2451f22347c4"/>
+    <p:sldMasterId xmlns:r="http://schemas.openxmlformats.org/officeDocument/2006/relationships" id="2147483648" r:id="R5662be0c75324f50"/>
   </p:sldMasterIdLst>
   <p:notesMasterIdLst>
-    <p:notesMasterId xmlns:r="http://schemas.openxmlformats.org/officeDocument/2006/relationships" r:id="Rf9e6ff0995a54070"/>
+    <p:notesMasterId xmlns:r="http://schemas.openxmlformats.org/officeDocument/2006/relationships" r:id="R0a246cb6b95d44bd"/>
   </p:notesMasterIdLst>
   <p:sldIdLst>
-    <p:sldId xmlns:r="http://schemas.openxmlformats.org/officeDocument/2006/relationships" id="256" r:id="R302f4068aaa54068"/>
-    <p:sldId xmlns:r="http://schemas.openxmlformats.org/officeDocument/2006/relationships" id="257" r:id="Rb33d8cf0e43644f9"/>
-    <p:sldId xmlns:r="http://schemas.openxmlformats.org/officeDocument/2006/relationships" id="258" r:id="R8760c351b74e424c"/>
-    <p:sldId xmlns:r="http://schemas.openxmlformats.org/officeDocument/2006/relationships" id="259" r:id="R687d57965f884827"/>
-    <p:sldId xmlns:r="http://schemas.openxmlformats.org/officeDocument/2006/relationships" id="260" r:id="R84801fc8f06d42fc"/>
-    <p:sldId xmlns:r="http://schemas.openxmlformats.org/officeDocument/2006/relationships" id="261" r:id="R966720d2f84e4475"/>
-    <p:sldId xmlns:r="http://schemas.openxmlformats.org/officeDocument/2006/relationships" id="262" r:id="Rd94a7f951e0a4d2d"/>
+    <p:sldId xmlns:r="http://schemas.openxmlformats.org/officeDocument/2006/relationships" id="256" r:id="R80410d1795244d1e"/>
+    <p:sldId xmlns:r="http://schemas.openxmlformats.org/officeDocument/2006/relationships" id="257" r:id="R81fbb5ea2d7044c4"/>
+    <p:sldId xmlns:r="http://schemas.openxmlformats.org/officeDocument/2006/relationships" id="258" r:id="Rd4a3558d0efc4da4"/>
+    <p:sldId xmlns:r="http://schemas.openxmlformats.org/officeDocument/2006/relationships" id="259" r:id="Re6f52a76fb864298"/>
+    <p:sldId xmlns:r="http://schemas.openxmlformats.org/officeDocument/2006/relationships" id="260" r:id="Rf93c89fba634484d"/>
+    <p:sldId xmlns:r="http://schemas.openxmlformats.org/officeDocument/2006/relationships" id="261" r:id="Rf5c52263829b4bff"/>
+    <p:sldId xmlns:r="http://schemas.openxmlformats.org/officeDocument/2006/relationships" id="262" r:id="R439eb525f6434feb"/>
   </p:sldIdLst>
   <p:sldSz cx="12192000" cy="6858000"/>
   <p:notesSz cx="6858000" cy="9144000"/>
@@ -879,7 +879,7 @@
           <a:lstStyle xmlns:a="http://schemas.openxmlformats.org/drawingml/2006/main"/>
           <a:p xmlns:a="http://schemas.openxmlformats.org/drawingml/2006/main">
             <a:r>
-              <a:t>The repository line is the intended release URL. Replace the pending badge only after the public remote is verified.</a:t>
+              <a:t>Public repository verified: https://github.com/genesiscode2026/velqiris-open-agent-2026</a:t>
             </a:r>
           </a:p>
         </p:txBody>
@@ -926,7 +926,7 @@
           <p:cNvPr id="3" name="Title">
             <a:extLst xmlns:a="http://schemas.openxmlformats.org/drawingml/2006/main">
               <a:ext uri="{FF2B5EF4-FFF2-40B4-BE49-F238E27FC236}">
-                <a16:creationId xmlns:a16="http://schemas.microsoft.com/office/drawing/2014/main" id="{D40CDF91-2EAC-4BA9-8A22-121ADF44A3F9}"/>
+                <a16:creationId xmlns:a16="http://schemas.microsoft.com/office/drawing/2014/main" id="{A800BE37-B2DB-4636-B132-948C5B8142B0}"/>
               </a:ext>
             </a:extLst>
           </p:cNvPr>
@@ -1155,7 +1155,7 @@
           <p:cNvPr id="2" name="Subtitle">
             <a:extLst xmlns:a="http://schemas.openxmlformats.org/drawingml/2006/main">
               <a:ext uri="{FF2B5EF4-FFF2-40B4-BE49-F238E27FC236}">
-                <a16:creationId xmlns:a16="http://schemas.microsoft.com/office/drawing/2014/main" id="{460053DC-175B-477C-B424-8A1D4A2724FD}"/>
+                <a16:creationId xmlns:a16="http://schemas.microsoft.com/office/drawing/2014/main" id="{E87CC832-DF11-4E26-9361-139689E463BD}"/>
               </a:ext>
             </a:extLst>
           </p:cNvPr>
@@ -1401,7 +1401,7 @@
           <p:cNvPr id="2" name="Section title">
             <a:extLst xmlns:a="http://schemas.openxmlformats.org/drawingml/2006/main">
               <a:ext uri="{FF2B5EF4-FFF2-40B4-BE49-F238E27FC236}">
-                <a16:creationId xmlns:a16="http://schemas.microsoft.com/office/drawing/2014/main" id="{6B8C18BB-68ED-4D3B-A69F-1FA6A760539C}"/>
+                <a16:creationId xmlns:a16="http://schemas.microsoft.com/office/drawing/2014/main" id="{DE93B5EE-6066-427B-B0B0-E202F04335B7}"/>
               </a:ext>
             </a:extLst>
           </p:cNvPr>
@@ -1647,7 +1647,7 @@
           <p:cNvPr id="3" name="Title">
             <a:extLst xmlns:a="http://schemas.openxmlformats.org/drawingml/2006/main">
               <a:ext uri="{FF2B5EF4-FFF2-40B4-BE49-F238E27FC236}">
-                <a16:creationId xmlns:a16="http://schemas.microsoft.com/office/drawing/2014/main" id="{690B0234-1081-4ACE-A42F-0C55E85F5F21}"/>
+                <a16:creationId xmlns:a16="http://schemas.microsoft.com/office/drawing/2014/main" id="{13629D85-5F04-4343-ACF8-C5A7CE85C7B4}"/>
               </a:ext>
             </a:extLst>
           </p:cNvPr>
@@ -1876,7 +1876,7 @@
           <p:cNvPr id="2" name="Body">
             <a:extLst xmlns:a="http://schemas.openxmlformats.org/drawingml/2006/main">
               <a:ext uri="{FF2B5EF4-FFF2-40B4-BE49-F238E27FC236}">
-                <a16:creationId xmlns:a16="http://schemas.microsoft.com/office/drawing/2014/main" id="{4A844F47-949C-4C21-BE92-8E13614200D8}"/>
+                <a16:creationId xmlns:a16="http://schemas.microsoft.com/office/drawing/2014/main" id="{6D0C6A05-3399-4E2A-AFAB-1BB8FA3F5968}"/>
               </a:ext>
             </a:extLst>
           </p:cNvPr>
@@ -2122,7 +2122,7 @@
           <p:cNvPr id="4" name="Title">
             <a:extLst xmlns:a="http://schemas.openxmlformats.org/drawingml/2006/main">
               <a:ext uri="{FF2B5EF4-FFF2-40B4-BE49-F238E27FC236}">
-                <a16:creationId xmlns:a16="http://schemas.microsoft.com/office/drawing/2014/main" id="{2A521EDF-6034-4B3F-BC18-20487F64E22D}"/>
+                <a16:creationId xmlns:a16="http://schemas.microsoft.com/office/drawing/2014/main" id="{923E4C61-5C78-46BE-9F58-E26A730E9B06}"/>
               </a:ext>
             </a:extLst>
           </p:cNvPr>
@@ -2351,7 +2351,7 @@
           <p:cNvPr id="2" name="Left column">
             <a:extLst xmlns:a="http://schemas.openxmlformats.org/drawingml/2006/main">
               <a:ext uri="{FF2B5EF4-FFF2-40B4-BE49-F238E27FC236}">
-                <a16:creationId xmlns:a16="http://schemas.microsoft.com/office/drawing/2014/main" id="{FC359AB0-E150-4E03-9D42-48FA1016D9AB}"/>
+                <a16:creationId xmlns:a16="http://schemas.microsoft.com/office/drawing/2014/main" id="{FC7FAFD0-CC44-426D-BF25-5EBF4554A7A7}"/>
               </a:ext>
             </a:extLst>
           </p:cNvPr>
@@ -2580,7 +2580,7 @@
           <p:cNvPr id="3" name="Right column">
             <a:extLst xmlns:a="http://schemas.openxmlformats.org/drawingml/2006/main">
               <a:ext uri="{FF2B5EF4-FFF2-40B4-BE49-F238E27FC236}">
-                <a16:creationId xmlns:a16="http://schemas.microsoft.com/office/drawing/2014/main" id="{59EF8179-BA9F-4B26-92AB-65CD741363E4}"/>
+                <a16:creationId xmlns:a16="http://schemas.microsoft.com/office/drawing/2014/main" id="{E814325F-8B26-4AF7-8639-D3AE01348E81}"/>
               </a:ext>
             </a:extLst>
           </p:cNvPr>
@@ -2826,7 +2826,7 @@
           <p:cNvPr id="3" name="Title">
             <a:extLst xmlns:a="http://schemas.openxmlformats.org/drawingml/2006/main">
               <a:ext uri="{FF2B5EF4-FFF2-40B4-BE49-F238E27FC236}">
-                <a16:creationId xmlns:a16="http://schemas.microsoft.com/office/drawing/2014/main" id="{D7EA22B8-77B8-46F1-BCEB-2285EEEBC2DC}"/>
+                <a16:creationId xmlns:a16="http://schemas.microsoft.com/office/drawing/2014/main" id="{BC1ADE70-BDFA-4CF1-B675-8CD7792870A4}"/>
               </a:ext>
             </a:extLst>
           </p:cNvPr>
@@ -3055,7 +3055,7 @@
           <p:cNvPr id="2" name="Left column">
             <a:extLst xmlns:a="http://schemas.openxmlformats.org/drawingml/2006/main">
               <a:ext uri="{FF2B5EF4-FFF2-40B4-BE49-F238E27FC236}">
-                <a16:creationId xmlns:a16="http://schemas.microsoft.com/office/drawing/2014/main" id="{05B9F6DD-F1F0-44FA-9241-B1A43600B080}"/>
+                <a16:creationId xmlns:a16="http://schemas.microsoft.com/office/drawing/2014/main" id="{9B581BED-64D8-4879-A006-ACC4110DF075}"/>
               </a:ext>
             </a:extLst>
           </p:cNvPr>
@@ -3322,12 +3322,12 @@
   </p:cSld>
   <p:clrMap bg1="lt1" tx1="dk1" bg2="lt2" tx2="dk2" accent1="accent1" accent2="accent2" accent3="accent3" accent4="accent4" accent5="accent5" accent6="accent6" hlink="hlink" folHlink="folHlink"/>
   <p:sldLayoutIdLst>
-    <p:sldLayoutId xmlns:r="http://schemas.openxmlformats.org/officeDocument/2006/relationships" id="2147483649" r:id="R4b5cdc75fe1b4d7d"/>
-    <p:sldLayoutId xmlns:r="http://schemas.openxmlformats.org/officeDocument/2006/relationships" id="2147483650" r:id="R4785d35c9eea41ea"/>
-    <p:sldLayoutId xmlns:r="http://schemas.openxmlformats.org/officeDocument/2006/relationships" id="2147483651" r:id="R2be726b3974f409f"/>
-    <p:sldLayoutId xmlns:r="http://schemas.openxmlformats.org/officeDocument/2006/relationships" id="2147483652" r:id="Rf2ca2b372c504e69"/>
-    <p:sldLayoutId xmlns:r="http://schemas.openxmlformats.org/officeDocument/2006/relationships" id="2147483653" r:id="R9d7b3fbd92fa4504"/>
-    <p:sldLayoutId xmlns:r="http://schemas.openxmlformats.org/officeDocument/2006/relationships" id="2147483654" r:id="R0fc2fd42913d4d36"/>
+    <p:sldLayoutId xmlns:r="http://schemas.openxmlformats.org/officeDocument/2006/relationships" id="2147483649" r:id="R4a8e1e8a04d4403b"/>
+    <p:sldLayoutId xmlns:r="http://schemas.openxmlformats.org/officeDocument/2006/relationships" id="2147483650" r:id="Ref6112a5d33c48ab"/>
+    <p:sldLayoutId xmlns:r="http://schemas.openxmlformats.org/officeDocument/2006/relationships" id="2147483651" r:id="R8166c91abb214f2f"/>
+    <p:sldLayoutId xmlns:r="http://schemas.openxmlformats.org/officeDocument/2006/relationships" id="2147483652" r:id="R56304c85b51f48e3"/>
+    <p:sldLayoutId xmlns:r="http://schemas.openxmlformats.org/officeDocument/2006/relationships" id="2147483653" r:id="R15f85f3097ce4ce2"/>
+    <p:sldLayoutId xmlns:r="http://schemas.openxmlformats.org/officeDocument/2006/relationships" id="2147483654" r:id="R88ac0d1be3c7499b"/>
   </p:sldLayoutIdLst>
   <p:txStyles>
     <p:titleStyle>
@@ -3878,7 +3878,7 @@
           <p:cNvPr id="21" name="">
             <a:extLst xmlns:a="http://schemas.openxmlformats.org/drawingml/2006/main">
               <a:ext uri="{FF2B5EF4-FFF2-40B4-BE49-F238E27FC236}">
-                <a16:creationId xmlns:a16="http://schemas.microsoft.com/office/drawing/2014/main" id="{63C57A3B-5B4A-476A-A82C-3367EA52C129}"/>
+                <a16:creationId xmlns:a16="http://schemas.microsoft.com/office/drawing/2014/main" id="{AD934376-4068-4C4D-9730-3D5C717E1DB7}"/>
               </a:ext>
             </a:extLst>
           </p:cNvPr>
@@ -3913,7 +3913,7 @@
           <p:cNvPr id="2" name="">
             <a:extLst xmlns:a="http://schemas.openxmlformats.org/drawingml/2006/main">
               <a:ext uri="{FF2B5EF4-FFF2-40B4-BE49-F238E27FC236}">
-                <a16:creationId xmlns:a16="http://schemas.microsoft.com/office/drawing/2014/main" id="{8A3197F0-3788-4375-8CBA-E12064734EC3}"/>
+                <a16:creationId xmlns:a16="http://schemas.microsoft.com/office/drawing/2014/main" id="{E67998BE-A6B2-4442-8D0A-D43FC703CC93}"/>
               </a:ext>
             </a:extLst>
           </p:cNvPr>
@@ -4070,7 +4070,7 @@
           <p:cNvPr id="3" name="">
             <a:extLst xmlns:a="http://schemas.openxmlformats.org/drawingml/2006/main">
               <a:ext uri="{FF2B5EF4-FFF2-40B4-BE49-F238E27FC236}">
-                <a16:creationId xmlns:a16="http://schemas.microsoft.com/office/drawing/2014/main" id="{37AD149A-30FB-4017-A6B1-BE9CD30FEE37}"/>
+                <a16:creationId xmlns:a16="http://schemas.microsoft.com/office/drawing/2014/main" id="{C5B3E089-BEDC-4367-A5C6-288F8357F430}"/>
               </a:ext>
             </a:extLst>
           </p:cNvPr>
@@ -4227,7 +4227,7 @@
           <p:cNvPr id="4" name="">
             <a:extLst xmlns:a="http://schemas.openxmlformats.org/drawingml/2006/main">
               <a:ext uri="{FF2B5EF4-FFF2-40B4-BE49-F238E27FC236}">
-                <a16:creationId xmlns:a16="http://schemas.microsoft.com/office/drawing/2014/main" id="{96A76056-CF9D-4EB9-9A15-6C7E2C807D20}"/>
+                <a16:creationId xmlns:a16="http://schemas.microsoft.com/office/drawing/2014/main" id="{9847006B-8D73-40D0-A0A3-89DDD1B2AF6B}"/>
               </a:ext>
             </a:extLst>
           </p:cNvPr>
@@ -4384,7 +4384,7 @@
           <p:cNvPr id="5" name="">
             <a:extLst xmlns:a="http://schemas.openxmlformats.org/drawingml/2006/main">
               <a:ext uri="{FF2B5EF4-FFF2-40B4-BE49-F238E27FC236}">
-                <a16:creationId xmlns:a16="http://schemas.microsoft.com/office/drawing/2014/main" id="{388ADDE8-9605-4F01-ACB3-CDE85F4A2F3B}"/>
+                <a16:creationId xmlns:a16="http://schemas.microsoft.com/office/drawing/2014/main" id="{C0752433-E01A-4574-B3F4-C4E68A1935E9}"/>
               </a:ext>
             </a:extLst>
           </p:cNvPr>
@@ -4541,7 +4541,7 @@
           <p:cNvPr id="6" name="">
             <a:extLst xmlns:a="http://schemas.openxmlformats.org/drawingml/2006/main">
               <a:ext uri="{FF2B5EF4-FFF2-40B4-BE49-F238E27FC236}">
-                <a16:creationId xmlns:a16="http://schemas.microsoft.com/office/drawing/2014/main" id="{DEA8259A-305D-4903-9DAD-33FD08E83EEF}"/>
+                <a16:creationId xmlns:a16="http://schemas.microsoft.com/office/drawing/2014/main" id="{7EA36B5D-6F64-4E5B-8E6D-58E9F6CEBBEB}"/>
               </a:ext>
             </a:extLst>
           </p:cNvPr>
@@ -4576,7 +4576,7 @@
           <p:cNvPr id="7" name="">
             <a:extLst xmlns:a="http://schemas.openxmlformats.org/drawingml/2006/main">
               <a:ext uri="{FF2B5EF4-FFF2-40B4-BE49-F238E27FC236}">
-                <a16:creationId xmlns:a16="http://schemas.microsoft.com/office/drawing/2014/main" id="{C0A23162-9F23-4416-9196-25F9FD4757E6}"/>
+                <a16:creationId xmlns:a16="http://schemas.microsoft.com/office/drawing/2014/main" id="{E247370E-BA29-49FC-865A-E4BE313A6E2F}"/>
               </a:ext>
             </a:extLst>
           </p:cNvPr>
@@ -4733,7 +4733,7 @@
           <p:cNvPr id="8" name="">
             <a:extLst xmlns:a="http://schemas.openxmlformats.org/drawingml/2006/main">
               <a:ext uri="{FF2B5EF4-FFF2-40B4-BE49-F238E27FC236}">
-                <a16:creationId xmlns:a16="http://schemas.microsoft.com/office/drawing/2014/main" id="{30D0D448-F540-4079-88D4-79D682F654A2}"/>
+                <a16:creationId xmlns:a16="http://schemas.microsoft.com/office/drawing/2014/main" id="{3E263983-FBF2-4BC7-8D2E-EFB76E32AFA8}"/>
               </a:ext>
             </a:extLst>
           </p:cNvPr>
@@ -4890,7 +4890,7 @@
           <p:cNvPr id="9" name="">
             <a:extLst xmlns:a="http://schemas.openxmlformats.org/drawingml/2006/main">
               <a:ext uri="{FF2B5EF4-FFF2-40B4-BE49-F238E27FC236}">
-                <a16:creationId xmlns:a16="http://schemas.microsoft.com/office/drawing/2014/main" id="{E872B92F-D1E4-4D70-871E-7C71F66CFD4F}"/>
+                <a16:creationId xmlns:a16="http://schemas.microsoft.com/office/drawing/2014/main" id="{4F7F0468-CCA0-4029-B19D-4FE416021D9C}"/>
               </a:ext>
             </a:extLst>
           </p:cNvPr>
@@ -4925,7 +4925,7 @@
           <p:cNvPr id="10" name="">
             <a:extLst xmlns:a="http://schemas.openxmlformats.org/drawingml/2006/main">
               <a:ext uri="{FF2B5EF4-FFF2-40B4-BE49-F238E27FC236}">
-                <a16:creationId xmlns:a16="http://schemas.microsoft.com/office/drawing/2014/main" id="{0501CBFC-20CD-456F-8819-8D4487A1E2CE}"/>
+                <a16:creationId xmlns:a16="http://schemas.microsoft.com/office/drawing/2014/main" id="{192E1469-6235-469F-84AC-ED4B0B50E179}"/>
               </a:ext>
             </a:extLst>
           </p:cNvPr>
@@ -5082,7 +5082,7 @@
           <p:cNvPr id="11" name="">
             <a:extLst xmlns:a="http://schemas.openxmlformats.org/drawingml/2006/main">
               <a:ext uri="{FF2B5EF4-FFF2-40B4-BE49-F238E27FC236}">
-                <a16:creationId xmlns:a16="http://schemas.microsoft.com/office/drawing/2014/main" id="{0AE949D0-6A77-4882-A62D-FE2FC7745125}"/>
+                <a16:creationId xmlns:a16="http://schemas.microsoft.com/office/drawing/2014/main" id="{C30A6404-4FFB-496F-8A8B-BD935AEA3E23}"/>
               </a:ext>
             </a:extLst>
           </p:cNvPr>
@@ -5239,7 +5239,7 @@
           <p:cNvPr id="12" name="">
             <a:extLst xmlns:a="http://schemas.openxmlformats.org/drawingml/2006/main">
               <a:ext uri="{FF2B5EF4-FFF2-40B4-BE49-F238E27FC236}">
-                <a16:creationId xmlns:a16="http://schemas.microsoft.com/office/drawing/2014/main" id="{65C10B1F-F72A-4AD9-9464-64EDB3D41184}"/>
+                <a16:creationId xmlns:a16="http://schemas.microsoft.com/office/drawing/2014/main" id="{50C059CB-551D-4B64-B14D-014E7FCC9A79}"/>
               </a:ext>
             </a:extLst>
           </p:cNvPr>
@@ -5274,7 +5274,7 @@
           <p:cNvPr id="13" name="">
             <a:extLst xmlns:a="http://schemas.openxmlformats.org/drawingml/2006/main">
               <a:ext uri="{FF2B5EF4-FFF2-40B4-BE49-F238E27FC236}">
-                <a16:creationId xmlns:a16="http://schemas.microsoft.com/office/drawing/2014/main" id="{4CEC8E2E-3380-4C43-9FBC-188DEECA11BB}"/>
+                <a16:creationId xmlns:a16="http://schemas.microsoft.com/office/drawing/2014/main" id="{1752097B-248A-4ABB-9E42-326E271185CA}"/>
               </a:ext>
             </a:extLst>
           </p:cNvPr>
@@ -5431,7 +5431,7 @@
           <p:cNvPr id="14" name="">
             <a:extLst xmlns:a="http://schemas.openxmlformats.org/drawingml/2006/main">
               <a:ext uri="{FF2B5EF4-FFF2-40B4-BE49-F238E27FC236}">
-                <a16:creationId xmlns:a16="http://schemas.microsoft.com/office/drawing/2014/main" id="{F0C07576-F5EE-45C5-BBC6-4FA4F0E77695}"/>
+                <a16:creationId xmlns:a16="http://schemas.microsoft.com/office/drawing/2014/main" id="{80530867-3E1F-420C-90B2-FC180C8C644D}"/>
               </a:ext>
             </a:extLst>
           </p:cNvPr>
@@ -5588,7 +5588,7 @@
           <p:cNvPr id="15" name="">
             <a:extLst xmlns:a="http://schemas.openxmlformats.org/drawingml/2006/main">
               <a:ext uri="{FF2B5EF4-FFF2-40B4-BE49-F238E27FC236}">
-                <a16:creationId xmlns:a16="http://schemas.microsoft.com/office/drawing/2014/main" id="{35C336C0-4862-4269-B91E-FB558F2EF0F2}"/>
+                <a16:creationId xmlns:a16="http://schemas.microsoft.com/office/drawing/2014/main" id="{37EADBB1-F92A-4ADE-829E-D21D59373F66}"/>
               </a:ext>
             </a:extLst>
           </p:cNvPr>
@@ -5623,7 +5623,7 @@
           <p:cNvPr id="16" name="">
             <a:extLst xmlns:a="http://schemas.openxmlformats.org/drawingml/2006/main">
               <a:ext uri="{FF2B5EF4-FFF2-40B4-BE49-F238E27FC236}">
-                <a16:creationId xmlns:a16="http://schemas.microsoft.com/office/drawing/2014/main" id="{2F387D76-92F3-4AAB-9D71-89D3D2F71D80}"/>
+                <a16:creationId xmlns:a16="http://schemas.microsoft.com/office/drawing/2014/main" id="{AEAD4873-1774-41DC-A8C8-1E8DE4EF1610}"/>
               </a:ext>
             </a:extLst>
           </p:cNvPr>
@@ -5780,7 +5780,7 @@
           <p:cNvPr id="17" name="">
             <a:extLst xmlns:a="http://schemas.openxmlformats.org/drawingml/2006/main">
               <a:ext uri="{FF2B5EF4-FFF2-40B4-BE49-F238E27FC236}">
-                <a16:creationId xmlns:a16="http://schemas.microsoft.com/office/drawing/2014/main" id="{3E154DF3-97E2-49B2-A861-556103A7FDCD}"/>
+                <a16:creationId xmlns:a16="http://schemas.microsoft.com/office/drawing/2014/main" id="{D291CDB7-8C10-4468-B950-9D7A977FF556}"/>
               </a:ext>
             </a:extLst>
           </p:cNvPr>
@@ -5937,7 +5937,7 @@
           <p:cNvPr id="18" name="">
             <a:extLst xmlns:a="http://schemas.openxmlformats.org/drawingml/2006/main">
               <a:ext uri="{FF2B5EF4-FFF2-40B4-BE49-F238E27FC236}">
-                <a16:creationId xmlns:a16="http://schemas.microsoft.com/office/drawing/2014/main" id="{E3E2B228-DADE-4288-A838-C43988AF0D3F}"/>
+                <a16:creationId xmlns:a16="http://schemas.microsoft.com/office/drawing/2014/main" id="{6AC9E051-19F0-47C9-9A6E-C9F13579DA58}"/>
               </a:ext>
             </a:extLst>
           </p:cNvPr>
@@ -5968,7 +5968,7 @@
           <p:cNvPr id="19" name="">
             <a:extLst xmlns:a="http://schemas.openxmlformats.org/drawingml/2006/main">
               <a:ext uri="{FF2B5EF4-FFF2-40B4-BE49-F238E27FC236}">
-                <a16:creationId xmlns:a16="http://schemas.microsoft.com/office/drawing/2014/main" id="{6AB5BE3E-DFB6-48E1-A5B3-00E30BB4CD54}"/>
+                <a16:creationId xmlns:a16="http://schemas.microsoft.com/office/drawing/2014/main" id="{F8E379D6-1D07-4041-B456-398B470BEB6D}"/>
               </a:ext>
             </a:extLst>
           </p:cNvPr>
@@ -6125,7 +6125,7 @@
           <p:cNvPr id="20" name="">
             <a:extLst xmlns:a="http://schemas.openxmlformats.org/drawingml/2006/main">
               <a:ext uri="{FF2B5EF4-FFF2-40B4-BE49-F238E27FC236}">
-                <a16:creationId xmlns:a16="http://schemas.microsoft.com/office/drawing/2014/main" id="{802E2255-256A-44B5-ABAC-E30B8B6FC97C}"/>
+                <a16:creationId xmlns:a16="http://schemas.microsoft.com/office/drawing/2014/main" id="{57F45369-E398-42B0-AE89-8F33C383B4B6}"/>
               </a:ext>
             </a:extLst>
           </p:cNvPr>
@@ -6280,7 +6280,7 @@
     </p:spTree>
     <p:extLst>
       <p:ext uri="{BB962C8B-B14F-4D97-AF65-F5344CB8AC3E}">
-        <p14:creationId xmlns:p14="http://schemas.microsoft.com/office/powerpoint/2010/main" val="2082741028"/>
+        <p14:creationId xmlns:p14="http://schemas.microsoft.com/office/powerpoint/2010/main" val="872457276"/>
       </p:ext>
     </p:extLst>
   </p:cSld>
@@ -6311,7 +6311,7 @@
           <p:cNvPr id="22" name="">
             <a:extLst xmlns:a="http://schemas.openxmlformats.org/drawingml/2006/main">
               <a:ext uri="{FF2B5EF4-FFF2-40B4-BE49-F238E27FC236}">
-                <a16:creationId xmlns:a16="http://schemas.microsoft.com/office/drawing/2014/main" id="{3908EF8D-F659-41CD-978C-C5A2F1C6CD1C}"/>
+                <a16:creationId xmlns:a16="http://schemas.microsoft.com/office/drawing/2014/main" id="{A8C54EF5-CF8F-4910-BA13-B2F59D3965FD}"/>
               </a:ext>
             </a:extLst>
           </p:cNvPr>
@@ -6468,7 +6468,7 @@
           <p:cNvPr id="2" name="">
             <a:extLst xmlns:a="http://schemas.openxmlformats.org/drawingml/2006/main">
               <a:ext uri="{FF2B5EF4-FFF2-40B4-BE49-F238E27FC236}">
-                <a16:creationId xmlns:a16="http://schemas.microsoft.com/office/drawing/2014/main" id="{F2399F63-7686-409D-9F9E-B6237BEED673}"/>
+                <a16:creationId xmlns:a16="http://schemas.microsoft.com/office/drawing/2014/main" id="{2398169D-B9E0-4D49-B39A-BD81AF13D648}"/>
               </a:ext>
             </a:extLst>
           </p:cNvPr>
@@ -6625,7 +6625,7 @@
           <p:cNvPr id="3" name="">
             <a:extLst xmlns:a="http://schemas.openxmlformats.org/drawingml/2006/main">
               <a:ext uri="{FF2B5EF4-FFF2-40B4-BE49-F238E27FC236}">
-                <a16:creationId xmlns:a16="http://schemas.microsoft.com/office/drawing/2014/main" id="{5761B2FD-16D9-406A-93DE-84A1DF668E74}"/>
+                <a16:creationId xmlns:a16="http://schemas.microsoft.com/office/drawing/2014/main" id="{7AF5E633-70DC-40A2-B191-E4909F175DC8}"/>
               </a:ext>
             </a:extLst>
           </p:cNvPr>
@@ -6782,7 +6782,7 @@
           <p:cNvPr id="4" name="">
             <a:extLst xmlns:a="http://schemas.openxmlformats.org/drawingml/2006/main">
               <a:ext uri="{FF2B5EF4-FFF2-40B4-BE49-F238E27FC236}">
-                <a16:creationId xmlns:a16="http://schemas.microsoft.com/office/drawing/2014/main" id="{B6A26ED5-E0D7-44BA-A607-A562A77789BF}"/>
+                <a16:creationId xmlns:a16="http://schemas.microsoft.com/office/drawing/2014/main" id="{10301787-9EB3-41A8-B9F2-ED57CD8CEC57}"/>
               </a:ext>
             </a:extLst>
           </p:cNvPr>
@@ -6817,7 +6817,7 @@
           <p:cNvPr id="5" name="">
             <a:extLst xmlns:a="http://schemas.openxmlformats.org/drawingml/2006/main">
               <a:ext uri="{FF2B5EF4-FFF2-40B4-BE49-F238E27FC236}">
-                <a16:creationId xmlns:a16="http://schemas.microsoft.com/office/drawing/2014/main" id="{2224D446-137E-48F9-BAD0-D0CE4428B062}"/>
+                <a16:creationId xmlns:a16="http://schemas.microsoft.com/office/drawing/2014/main" id="{5768B169-90A2-4C76-A922-BC237C3BEB63}"/>
               </a:ext>
             </a:extLst>
           </p:cNvPr>
@@ -6974,7 +6974,7 @@
           <p:cNvPr id="6" name="">
             <a:extLst xmlns:a="http://schemas.openxmlformats.org/drawingml/2006/main">
               <a:ext uri="{FF2B5EF4-FFF2-40B4-BE49-F238E27FC236}">
-                <a16:creationId xmlns:a16="http://schemas.microsoft.com/office/drawing/2014/main" id="{CB4625BE-F27C-4661-88D9-B4A963DCA77F}"/>
+                <a16:creationId xmlns:a16="http://schemas.microsoft.com/office/drawing/2014/main" id="{7BAAEA83-55B4-4480-95BC-96694802CA01}"/>
               </a:ext>
             </a:extLst>
           </p:cNvPr>
@@ -7131,7 +7131,7 @@
           <p:cNvPr id="7" name="">
             <a:extLst xmlns:a="http://schemas.openxmlformats.org/drawingml/2006/main">
               <a:ext uri="{FF2B5EF4-FFF2-40B4-BE49-F238E27FC236}">
-                <a16:creationId xmlns:a16="http://schemas.microsoft.com/office/drawing/2014/main" id="{EF3FE41B-8CA4-4766-9066-72EED4EBCF04}"/>
+                <a16:creationId xmlns:a16="http://schemas.microsoft.com/office/drawing/2014/main" id="{CD4F6A1A-FE1A-4D62-A88A-47B9EE63E40C}"/>
               </a:ext>
             </a:extLst>
           </p:cNvPr>
@@ -7288,7 +7288,7 @@
           <p:cNvPr id="8" name="">
             <a:extLst xmlns:a="http://schemas.openxmlformats.org/drawingml/2006/main">
               <a:ext uri="{FF2B5EF4-FFF2-40B4-BE49-F238E27FC236}">
-                <a16:creationId xmlns:a16="http://schemas.microsoft.com/office/drawing/2014/main" id="{14567B80-54C8-4FC2-B077-CBD650C2E031}"/>
+                <a16:creationId xmlns:a16="http://schemas.microsoft.com/office/drawing/2014/main" id="{66400C33-ACB7-44EE-B16D-EBCF971F570F}"/>
               </a:ext>
             </a:extLst>
           </p:cNvPr>
@@ -7323,7 +7323,7 @@
           <p:cNvPr id="9" name="">
             <a:extLst xmlns:a="http://schemas.openxmlformats.org/drawingml/2006/main">
               <a:ext uri="{FF2B5EF4-FFF2-40B4-BE49-F238E27FC236}">
-                <a16:creationId xmlns:a16="http://schemas.microsoft.com/office/drawing/2014/main" id="{2827BD04-9E80-4E5B-8BD2-39FE521BF02C}"/>
+                <a16:creationId xmlns:a16="http://schemas.microsoft.com/office/drawing/2014/main" id="{53BBB1A5-CD62-4B3B-88C2-03776BE11199}"/>
               </a:ext>
             </a:extLst>
           </p:cNvPr>
@@ -7480,7 +7480,7 @@
           <p:cNvPr id="10" name="">
             <a:extLst xmlns:a="http://schemas.openxmlformats.org/drawingml/2006/main">
               <a:ext uri="{FF2B5EF4-FFF2-40B4-BE49-F238E27FC236}">
-                <a16:creationId xmlns:a16="http://schemas.microsoft.com/office/drawing/2014/main" id="{855A257A-CDEB-43EE-AF5A-81B3491F6706}"/>
+                <a16:creationId xmlns:a16="http://schemas.microsoft.com/office/drawing/2014/main" id="{9505C4DF-040B-40D8-AF0B-85B0584A9650}"/>
               </a:ext>
             </a:extLst>
           </p:cNvPr>
@@ -7637,7 +7637,7 @@
           <p:cNvPr id="11" name="">
             <a:extLst xmlns:a="http://schemas.openxmlformats.org/drawingml/2006/main">
               <a:ext uri="{FF2B5EF4-FFF2-40B4-BE49-F238E27FC236}">
-                <a16:creationId xmlns:a16="http://schemas.microsoft.com/office/drawing/2014/main" id="{E0ABC481-2E7E-4EB6-9C95-EBEF89EF2BBA}"/>
+                <a16:creationId xmlns:a16="http://schemas.microsoft.com/office/drawing/2014/main" id="{93150D85-EDD6-46A1-AFA5-1654CB5AB707}"/>
               </a:ext>
             </a:extLst>
           </p:cNvPr>
@@ -7794,7 +7794,7 @@
           <p:cNvPr id="12" name="">
             <a:extLst xmlns:a="http://schemas.openxmlformats.org/drawingml/2006/main">
               <a:ext uri="{FF2B5EF4-FFF2-40B4-BE49-F238E27FC236}">
-                <a16:creationId xmlns:a16="http://schemas.microsoft.com/office/drawing/2014/main" id="{5D8EAED4-9A95-4EFF-9780-B8EBBF66C994}"/>
+                <a16:creationId xmlns:a16="http://schemas.microsoft.com/office/drawing/2014/main" id="{A5ABFDF4-57CD-4E91-905B-C07E0C32788C}"/>
               </a:ext>
             </a:extLst>
           </p:cNvPr>
@@ -7829,7 +7829,7 @@
           <p:cNvPr id="13" name="">
             <a:extLst xmlns:a="http://schemas.openxmlformats.org/drawingml/2006/main">
               <a:ext uri="{FF2B5EF4-FFF2-40B4-BE49-F238E27FC236}">
-                <a16:creationId xmlns:a16="http://schemas.microsoft.com/office/drawing/2014/main" id="{04F3299B-01DF-4880-83D5-C4DA4E5B7A09}"/>
+                <a16:creationId xmlns:a16="http://schemas.microsoft.com/office/drawing/2014/main" id="{57585EF3-60E3-468F-83A6-2BBCAC0DCBEF}"/>
               </a:ext>
             </a:extLst>
           </p:cNvPr>
@@ -7986,7 +7986,7 @@
           <p:cNvPr id="14" name="">
             <a:extLst xmlns:a="http://schemas.openxmlformats.org/drawingml/2006/main">
               <a:ext uri="{FF2B5EF4-FFF2-40B4-BE49-F238E27FC236}">
-                <a16:creationId xmlns:a16="http://schemas.microsoft.com/office/drawing/2014/main" id="{A28D443A-EEFA-4933-85B7-D1E034586AC7}"/>
+                <a16:creationId xmlns:a16="http://schemas.microsoft.com/office/drawing/2014/main" id="{8B3B1E60-963A-4249-BF3A-A895B273E607}"/>
               </a:ext>
             </a:extLst>
           </p:cNvPr>
@@ -8143,7 +8143,7 @@
           <p:cNvPr id="15" name="">
             <a:extLst xmlns:a="http://schemas.openxmlformats.org/drawingml/2006/main">
               <a:ext uri="{FF2B5EF4-FFF2-40B4-BE49-F238E27FC236}">
-                <a16:creationId xmlns:a16="http://schemas.microsoft.com/office/drawing/2014/main" id="{3708D613-D603-4C73-BA8D-EBC34FB57278}"/>
+                <a16:creationId xmlns:a16="http://schemas.microsoft.com/office/drawing/2014/main" id="{C90E3B2B-BDF2-430B-BEF5-9E3D581ADC5F}"/>
               </a:ext>
             </a:extLst>
           </p:cNvPr>
@@ -8300,7 +8300,7 @@
           <p:cNvPr id="16" name="">
             <a:extLst xmlns:a="http://schemas.openxmlformats.org/drawingml/2006/main">
               <a:ext uri="{FF2B5EF4-FFF2-40B4-BE49-F238E27FC236}">
-                <a16:creationId xmlns:a16="http://schemas.microsoft.com/office/drawing/2014/main" id="{252D3A0C-1CD2-4146-9CED-49E0C18BAA55}"/>
+                <a16:creationId xmlns:a16="http://schemas.microsoft.com/office/drawing/2014/main" id="{3F7691CA-8924-41CC-B3C8-EF696EE115E4}"/>
               </a:ext>
             </a:extLst>
           </p:cNvPr>
@@ -8335,7 +8335,7 @@
           <p:cNvPr id="17" name="">
             <a:extLst xmlns:a="http://schemas.openxmlformats.org/drawingml/2006/main">
               <a:ext uri="{FF2B5EF4-FFF2-40B4-BE49-F238E27FC236}">
-                <a16:creationId xmlns:a16="http://schemas.microsoft.com/office/drawing/2014/main" id="{D2A74D7E-422F-426E-A88B-05AC6C999AC1}"/>
+                <a16:creationId xmlns:a16="http://schemas.microsoft.com/office/drawing/2014/main" id="{0C21D0F6-97BF-432D-8B90-6D35E6F7AD3A}"/>
               </a:ext>
             </a:extLst>
           </p:cNvPr>
@@ -8492,7 +8492,7 @@
           <p:cNvPr id="18" name="">
             <a:extLst xmlns:a="http://schemas.openxmlformats.org/drawingml/2006/main">
               <a:ext uri="{FF2B5EF4-FFF2-40B4-BE49-F238E27FC236}">
-                <a16:creationId xmlns:a16="http://schemas.microsoft.com/office/drawing/2014/main" id="{3FEC5ED6-AAC6-4391-8932-81E4A2C226C6}"/>
+                <a16:creationId xmlns:a16="http://schemas.microsoft.com/office/drawing/2014/main" id="{CA4801FE-98E3-4388-9C07-6F5AD0F5DCB6}"/>
               </a:ext>
             </a:extLst>
           </p:cNvPr>
@@ -8649,7 +8649,7 @@
           <p:cNvPr id="19" name="">
             <a:extLst xmlns:a="http://schemas.openxmlformats.org/drawingml/2006/main">
               <a:ext uri="{FF2B5EF4-FFF2-40B4-BE49-F238E27FC236}">
-                <a16:creationId xmlns:a16="http://schemas.microsoft.com/office/drawing/2014/main" id="{83591753-07D1-48A9-9ABF-03ECB15DDCE1}"/>
+                <a16:creationId xmlns:a16="http://schemas.microsoft.com/office/drawing/2014/main" id="{23B31707-8BCE-4001-B2CA-3696B74C72B3}"/>
               </a:ext>
             </a:extLst>
           </p:cNvPr>
@@ -8680,7 +8680,7 @@
           <p:cNvPr id="20" name="">
             <a:extLst xmlns:a="http://schemas.openxmlformats.org/drawingml/2006/main">
               <a:ext uri="{FF2B5EF4-FFF2-40B4-BE49-F238E27FC236}">
-                <a16:creationId xmlns:a16="http://schemas.microsoft.com/office/drawing/2014/main" id="{5CFC2868-9BF0-4BDA-BF0A-97443BD43011}"/>
+                <a16:creationId xmlns:a16="http://schemas.microsoft.com/office/drawing/2014/main" id="{544C0C7D-933F-4F99-BA6C-A3E51089AD1F}"/>
               </a:ext>
             </a:extLst>
           </p:cNvPr>
@@ -8837,7 +8837,7 @@
           <p:cNvPr id="21" name="">
             <a:extLst xmlns:a="http://schemas.openxmlformats.org/drawingml/2006/main">
               <a:ext uri="{FF2B5EF4-FFF2-40B4-BE49-F238E27FC236}">
-                <a16:creationId xmlns:a16="http://schemas.microsoft.com/office/drawing/2014/main" id="{5257AA9E-8613-43C1-9FE3-0F076BA06AA5}"/>
+                <a16:creationId xmlns:a16="http://schemas.microsoft.com/office/drawing/2014/main" id="{226CE864-02BD-4937-BED5-8F7E96B9EEEC}"/>
               </a:ext>
             </a:extLst>
           </p:cNvPr>
@@ -8992,7 +8992,7 @@
     </p:spTree>
     <p:extLst>
       <p:ext uri="{BB962C8B-B14F-4D97-AF65-F5344CB8AC3E}">
-        <p14:creationId xmlns:p14="http://schemas.microsoft.com/office/powerpoint/2010/main" val="1926888710"/>
+        <p14:creationId xmlns:p14="http://schemas.microsoft.com/office/powerpoint/2010/main" val="1732668398"/>
       </p:ext>
     </p:extLst>
   </p:cSld>
@@ -9023,7 +9023,7 @@
           <p:cNvPr id="41" name="">
             <a:extLst xmlns:a="http://schemas.openxmlformats.org/drawingml/2006/main">
               <a:ext uri="{FF2B5EF4-FFF2-40B4-BE49-F238E27FC236}">
-                <a16:creationId xmlns:a16="http://schemas.microsoft.com/office/drawing/2014/main" id="{5D4C4F7E-7384-49F4-A5FF-F3BCF2AB1A88}"/>
+                <a16:creationId xmlns:a16="http://schemas.microsoft.com/office/drawing/2014/main" id="{87234EC4-E7ED-491F-8C17-A3CBC185C0CA}"/>
               </a:ext>
             </a:extLst>
           </p:cNvPr>
@@ -9180,7 +9180,7 @@
           <p:cNvPr id="2" name="">
             <a:extLst xmlns:a="http://schemas.openxmlformats.org/drawingml/2006/main">
               <a:ext uri="{FF2B5EF4-FFF2-40B4-BE49-F238E27FC236}">
-                <a16:creationId xmlns:a16="http://schemas.microsoft.com/office/drawing/2014/main" id="{A16B5510-E184-407D-8191-A289F2655CA7}"/>
+                <a16:creationId xmlns:a16="http://schemas.microsoft.com/office/drawing/2014/main" id="{4A7C7D9B-5A48-4A86-A5D1-300281048656}"/>
               </a:ext>
             </a:extLst>
           </p:cNvPr>
@@ -9337,7 +9337,7 @@
           <p:cNvPr id="3" name="">
             <a:extLst xmlns:a="http://schemas.openxmlformats.org/drawingml/2006/main">
               <a:ext uri="{FF2B5EF4-FFF2-40B4-BE49-F238E27FC236}">
-                <a16:creationId xmlns:a16="http://schemas.microsoft.com/office/drawing/2014/main" id="{54DFD1F0-7703-4C21-82EC-F843679AD8C3}"/>
+                <a16:creationId xmlns:a16="http://schemas.microsoft.com/office/drawing/2014/main" id="{5876DA8E-3D8F-4F2C-9347-05143BCBEC6A}"/>
               </a:ext>
             </a:extLst>
           </p:cNvPr>
@@ -9494,7 +9494,7 @@
           <p:cNvPr id="4" name="">
             <a:extLst xmlns:a="http://schemas.openxmlformats.org/drawingml/2006/main">
               <a:ext uri="{FF2B5EF4-FFF2-40B4-BE49-F238E27FC236}">
-                <a16:creationId xmlns:a16="http://schemas.microsoft.com/office/drawing/2014/main" id="{90759C09-13A4-4C12-A098-8DE8C9A359F8}"/>
+                <a16:creationId xmlns:a16="http://schemas.microsoft.com/office/drawing/2014/main" id="{3C75C9F0-DE76-4587-BF46-20D98CC94770}"/>
               </a:ext>
             </a:extLst>
           </p:cNvPr>
@@ -9529,7 +9529,7 @@
           <p:cNvPr id="5" name="">
             <a:extLst xmlns:a="http://schemas.openxmlformats.org/drawingml/2006/main">
               <a:ext uri="{FF2B5EF4-FFF2-40B4-BE49-F238E27FC236}">
-                <a16:creationId xmlns:a16="http://schemas.microsoft.com/office/drawing/2014/main" id="{F37C1D8A-3EBB-452E-8378-74F783A7012C}"/>
+                <a16:creationId xmlns:a16="http://schemas.microsoft.com/office/drawing/2014/main" id="{5DED1FD9-980B-4424-9D9A-D963A8FFA791}"/>
               </a:ext>
             </a:extLst>
           </p:cNvPr>
@@ -9564,7 +9564,7 @@
           <p:cNvPr id="6" name="">
             <a:extLst xmlns:a="http://schemas.openxmlformats.org/drawingml/2006/main">
               <a:ext uri="{FF2B5EF4-FFF2-40B4-BE49-F238E27FC236}">
-                <a16:creationId xmlns:a16="http://schemas.microsoft.com/office/drawing/2014/main" id="{D43991FA-1446-4BA2-A684-8B78BFB8A389}"/>
+                <a16:creationId xmlns:a16="http://schemas.microsoft.com/office/drawing/2014/main" id="{58152BC6-BF52-44AB-BE42-56A82AD4B141}"/>
               </a:ext>
             </a:extLst>
           </p:cNvPr>
@@ -9721,7 +9721,7 @@
           <p:cNvPr id="7" name="">
             <a:extLst xmlns:a="http://schemas.openxmlformats.org/drawingml/2006/main">
               <a:ext uri="{FF2B5EF4-FFF2-40B4-BE49-F238E27FC236}">
-                <a16:creationId xmlns:a16="http://schemas.microsoft.com/office/drawing/2014/main" id="{AB660C50-D2F2-40B1-8D5A-A1AB68FE0C4B}"/>
+                <a16:creationId xmlns:a16="http://schemas.microsoft.com/office/drawing/2014/main" id="{BB8ED88D-F97D-410A-B3C1-1BB31A3C7398}"/>
               </a:ext>
             </a:extLst>
           </p:cNvPr>
@@ -9878,7 +9878,7 @@
           <p:cNvPr id="8" name="">
             <a:extLst xmlns:a="http://schemas.openxmlformats.org/drawingml/2006/main">
               <a:ext uri="{FF2B5EF4-FFF2-40B4-BE49-F238E27FC236}">
-                <a16:creationId xmlns:a16="http://schemas.microsoft.com/office/drawing/2014/main" id="{FEE527E3-A982-4179-A76A-6BBF407B2B22}"/>
+                <a16:creationId xmlns:a16="http://schemas.microsoft.com/office/drawing/2014/main" id="{AAAB7497-4DD4-4065-BFAE-5FEB91F0FA42}"/>
               </a:ext>
             </a:extLst>
           </p:cNvPr>
@@ -10035,7 +10035,7 @@
           <p:cNvPr id="9" name="">
             <a:extLst xmlns:a="http://schemas.openxmlformats.org/drawingml/2006/main">
               <a:ext uri="{FF2B5EF4-FFF2-40B4-BE49-F238E27FC236}">
-                <a16:creationId xmlns:a16="http://schemas.microsoft.com/office/drawing/2014/main" id="{69B20270-1372-4BBB-A682-6B74B3B44C8F}"/>
+                <a16:creationId xmlns:a16="http://schemas.microsoft.com/office/drawing/2014/main" id="{58C9DD00-F4CF-4B28-BBC5-CD3C5CE7EDB0}"/>
               </a:ext>
             </a:extLst>
           </p:cNvPr>
@@ -10192,7 +10192,7 @@
           <p:cNvPr id="10" name="">
             <a:extLst xmlns:a="http://schemas.openxmlformats.org/drawingml/2006/main">
               <a:ext uri="{FF2B5EF4-FFF2-40B4-BE49-F238E27FC236}">
-                <a16:creationId xmlns:a16="http://schemas.microsoft.com/office/drawing/2014/main" id="{09125F54-9A3E-4C9F-BEFD-6456FE54C4F7}"/>
+                <a16:creationId xmlns:a16="http://schemas.microsoft.com/office/drawing/2014/main" id="{2E5E49DA-F9C2-4252-B07A-8700B5EDF44A}"/>
               </a:ext>
             </a:extLst>
           </p:cNvPr>
@@ -10227,7 +10227,7 @@
           <p:cNvPr id="11" name="">
             <a:extLst xmlns:a="http://schemas.openxmlformats.org/drawingml/2006/main">
               <a:ext uri="{FF2B5EF4-FFF2-40B4-BE49-F238E27FC236}">
-                <a16:creationId xmlns:a16="http://schemas.microsoft.com/office/drawing/2014/main" id="{E797FA54-4D50-4E03-AD51-F9650C5CF0B1}"/>
+                <a16:creationId xmlns:a16="http://schemas.microsoft.com/office/drawing/2014/main" id="{0F4EFA4C-4AE8-4718-8BFD-A26A15999E74}"/>
               </a:ext>
             </a:extLst>
           </p:cNvPr>
@@ -10262,7 +10262,7 @@
           <p:cNvPr id="12" name="">
             <a:extLst xmlns:a="http://schemas.openxmlformats.org/drawingml/2006/main">
               <a:ext uri="{FF2B5EF4-FFF2-40B4-BE49-F238E27FC236}">
-                <a16:creationId xmlns:a16="http://schemas.microsoft.com/office/drawing/2014/main" id="{F6FC65BA-AAE4-4C39-BCA5-AB0246F29F39}"/>
+                <a16:creationId xmlns:a16="http://schemas.microsoft.com/office/drawing/2014/main" id="{B6754A48-A720-4EB7-BF9C-37D9DD9F3FF4}"/>
               </a:ext>
             </a:extLst>
           </p:cNvPr>
@@ -10419,7 +10419,7 @@
           <p:cNvPr id="13" name="">
             <a:extLst xmlns:a="http://schemas.openxmlformats.org/drawingml/2006/main">
               <a:ext uri="{FF2B5EF4-FFF2-40B4-BE49-F238E27FC236}">
-                <a16:creationId xmlns:a16="http://schemas.microsoft.com/office/drawing/2014/main" id="{3502FB5B-DD52-429D-ABE8-AB1A961CDA95}"/>
+                <a16:creationId xmlns:a16="http://schemas.microsoft.com/office/drawing/2014/main" id="{1C30DE96-5BCB-4E61-BB97-45C15C930DFE}"/>
               </a:ext>
             </a:extLst>
           </p:cNvPr>
@@ -10576,7 +10576,7 @@
           <p:cNvPr id="14" name="">
             <a:extLst xmlns:a="http://schemas.openxmlformats.org/drawingml/2006/main">
               <a:ext uri="{FF2B5EF4-FFF2-40B4-BE49-F238E27FC236}">
-                <a16:creationId xmlns:a16="http://schemas.microsoft.com/office/drawing/2014/main" id="{25BBE39F-FAD1-490F-B141-AB82ACE2B4CF}"/>
+                <a16:creationId xmlns:a16="http://schemas.microsoft.com/office/drawing/2014/main" id="{3EA0D613-951B-4AE0-AD53-B2E818E56033}"/>
               </a:ext>
             </a:extLst>
           </p:cNvPr>
@@ -10733,7 +10733,7 @@
           <p:cNvPr id="15" name="">
             <a:extLst xmlns:a="http://schemas.openxmlformats.org/drawingml/2006/main">
               <a:ext uri="{FF2B5EF4-FFF2-40B4-BE49-F238E27FC236}">
-                <a16:creationId xmlns:a16="http://schemas.microsoft.com/office/drawing/2014/main" id="{C38891B5-2104-402C-AD4F-C2A0689B71E5}"/>
+                <a16:creationId xmlns:a16="http://schemas.microsoft.com/office/drawing/2014/main" id="{0B1E0CDE-146F-4469-9955-4DAF0744C871}"/>
               </a:ext>
             </a:extLst>
           </p:cNvPr>
@@ -10890,7 +10890,7 @@
           <p:cNvPr id="16" name="">
             <a:extLst xmlns:a="http://schemas.openxmlformats.org/drawingml/2006/main">
               <a:ext uri="{FF2B5EF4-FFF2-40B4-BE49-F238E27FC236}">
-                <a16:creationId xmlns:a16="http://schemas.microsoft.com/office/drawing/2014/main" id="{D7CB1F10-3D07-4D9C-A6F0-23019A678612}"/>
+                <a16:creationId xmlns:a16="http://schemas.microsoft.com/office/drawing/2014/main" id="{E1D4BD4E-7D2E-4D01-B316-07E0A97E6E0F}"/>
               </a:ext>
             </a:extLst>
           </p:cNvPr>
@@ -10925,7 +10925,7 @@
           <p:cNvPr id="17" name="">
             <a:extLst xmlns:a="http://schemas.openxmlformats.org/drawingml/2006/main">
               <a:ext uri="{FF2B5EF4-FFF2-40B4-BE49-F238E27FC236}">
-                <a16:creationId xmlns:a16="http://schemas.microsoft.com/office/drawing/2014/main" id="{BC774842-F596-4B25-AA1D-3BAC4080D01D}"/>
+                <a16:creationId xmlns:a16="http://schemas.microsoft.com/office/drawing/2014/main" id="{62356FA0-B99E-4658-9B1D-4B4A05347ED4}"/>
               </a:ext>
             </a:extLst>
           </p:cNvPr>
@@ -10960,7 +10960,7 @@
           <p:cNvPr id="18" name="">
             <a:extLst xmlns:a="http://schemas.openxmlformats.org/drawingml/2006/main">
               <a:ext uri="{FF2B5EF4-FFF2-40B4-BE49-F238E27FC236}">
-                <a16:creationId xmlns:a16="http://schemas.microsoft.com/office/drawing/2014/main" id="{0F4BCF17-841F-445E-A5B6-FD09399ED5AF}"/>
+                <a16:creationId xmlns:a16="http://schemas.microsoft.com/office/drawing/2014/main" id="{7D3EC050-9B47-4B4C-ACE1-2A4B646C3639}"/>
               </a:ext>
             </a:extLst>
           </p:cNvPr>
@@ -11117,7 +11117,7 @@
           <p:cNvPr id="19" name="">
             <a:extLst xmlns:a="http://schemas.openxmlformats.org/drawingml/2006/main">
               <a:ext uri="{FF2B5EF4-FFF2-40B4-BE49-F238E27FC236}">
-                <a16:creationId xmlns:a16="http://schemas.microsoft.com/office/drawing/2014/main" id="{6B52CD49-682A-4E57-8E6E-B339906A7CDD}"/>
+                <a16:creationId xmlns:a16="http://schemas.microsoft.com/office/drawing/2014/main" id="{9F73258A-936A-40E0-8610-1E143F247547}"/>
               </a:ext>
             </a:extLst>
           </p:cNvPr>
@@ -11274,7 +11274,7 @@
           <p:cNvPr id="20" name="">
             <a:extLst xmlns:a="http://schemas.openxmlformats.org/drawingml/2006/main">
               <a:ext uri="{FF2B5EF4-FFF2-40B4-BE49-F238E27FC236}">
-                <a16:creationId xmlns:a16="http://schemas.microsoft.com/office/drawing/2014/main" id="{C7FA817C-2795-45DC-9926-AEE01E0C4B6F}"/>
+                <a16:creationId xmlns:a16="http://schemas.microsoft.com/office/drawing/2014/main" id="{1B290D79-C9C9-44F9-8871-7279DEDC1E6B}"/>
               </a:ext>
             </a:extLst>
           </p:cNvPr>
@@ -11431,7 +11431,7 @@
           <p:cNvPr id="21" name="">
             <a:extLst xmlns:a="http://schemas.openxmlformats.org/drawingml/2006/main">
               <a:ext uri="{FF2B5EF4-FFF2-40B4-BE49-F238E27FC236}">
-                <a16:creationId xmlns:a16="http://schemas.microsoft.com/office/drawing/2014/main" id="{BF591B9E-72A6-4EDF-84F2-90F4D6435AFE}"/>
+                <a16:creationId xmlns:a16="http://schemas.microsoft.com/office/drawing/2014/main" id="{813462FA-E5F1-4523-92C4-1089F28A62DD}"/>
               </a:ext>
             </a:extLst>
           </p:cNvPr>
@@ -11588,7 +11588,7 @@
           <p:cNvPr id="22" name="">
             <a:extLst xmlns:a="http://schemas.openxmlformats.org/drawingml/2006/main">
               <a:ext uri="{FF2B5EF4-FFF2-40B4-BE49-F238E27FC236}">
-                <a16:creationId xmlns:a16="http://schemas.microsoft.com/office/drawing/2014/main" id="{C0721105-45DF-4C2B-BEAA-C5D7BCF95894}"/>
+                <a16:creationId xmlns:a16="http://schemas.microsoft.com/office/drawing/2014/main" id="{08B1D01D-54B8-426A-B742-48E4F8AD1DE6}"/>
               </a:ext>
             </a:extLst>
           </p:cNvPr>
@@ -11623,7 +11623,7 @@
           <p:cNvPr id="23" name="">
             <a:extLst xmlns:a="http://schemas.openxmlformats.org/drawingml/2006/main">
               <a:ext uri="{FF2B5EF4-FFF2-40B4-BE49-F238E27FC236}">
-                <a16:creationId xmlns:a16="http://schemas.microsoft.com/office/drawing/2014/main" id="{D0E67580-B276-4B35-9027-817655139194}"/>
+                <a16:creationId xmlns:a16="http://schemas.microsoft.com/office/drawing/2014/main" id="{B149C147-977A-470F-ABD3-F70A27AB449B}"/>
               </a:ext>
             </a:extLst>
           </p:cNvPr>
@@ -11658,7 +11658,7 @@
           <p:cNvPr id="24" name="">
             <a:extLst xmlns:a="http://schemas.openxmlformats.org/drawingml/2006/main">
               <a:ext uri="{FF2B5EF4-FFF2-40B4-BE49-F238E27FC236}">
-                <a16:creationId xmlns:a16="http://schemas.microsoft.com/office/drawing/2014/main" id="{C9550B1E-ECA6-4F73-BBD0-30E8E4CD3620}"/>
+                <a16:creationId xmlns:a16="http://schemas.microsoft.com/office/drawing/2014/main" id="{56666953-C8C1-4CCE-BA41-8912B9B6F6CE}"/>
               </a:ext>
             </a:extLst>
           </p:cNvPr>
@@ -11815,7 +11815,7 @@
           <p:cNvPr id="25" name="">
             <a:extLst xmlns:a="http://schemas.openxmlformats.org/drawingml/2006/main">
               <a:ext uri="{FF2B5EF4-FFF2-40B4-BE49-F238E27FC236}">
-                <a16:creationId xmlns:a16="http://schemas.microsoft.com/office/drawing/2014/main" id="{42AB5BDA-0306-4C3D-90E4-AFF4D5EA97B4}"/>
+                <a16:creationId xmlns:a16="http://schemas.microsoft.com/office/drawing/2014/main" id="{A8898AC1-8EA4-4756-83D9-1A56D3DC3DB5}"/>
               </a:ext>
             </a:extLst>
           </p:cNvPr>
@@ -11972,7 +11972,7 @@
           <p:cNvPr id="26" name="">
             <a:extLst xmlns:a="http://schemas.openxmlformats.org/drawingml/2006/main">
               <a:ext uri="{FF2B5EF4-FFF2-40B4-BE49-F238E27FC236}">
-                <a16:creationId xmlns:a16="http://schemas.microsoft.com/office/drawing/2014/main" id="{DE2DB916-6569-4647-8984-3ABB00CB52D6}"/>
+                <a16:creationId xmlns:a16="http://schemas.microsoft.com/office/drawing/2014/main" id="{679F3797-E72D-4BA1-B74D-740085C47EC0}"/>
               </a:ext>
             </a:extLst>
           </p:cNvPr>
@@ -12129,7 +12129,7 @@
           <p:cNvPr id="27" name="">
             <a:extLst xmlns:a="http://schemas.openxmlformats.org/drawingml/2006/main">
               <a:ext uri="{FF2B5EF4-FFF2-40B4-BE49-F238E27FC236}">
-                <a16:creationId xmlns:a16="http://schemas.microsoft.com/office/drawing/2014/main" id="{73A35A0A-02CC-4CE8-9DBB-354F1CA4E3D8}"/>
+                <a16:creationId xmlns:a16="http://schemas.microsoft.com/office/drawing/2014/main" id="{38809BB2-A740-4365-B47E-4901292E9815}"/>
               </a:ext>
             </a:extLst>
           </p:cNvPr>
@@ -12286,7 +12286,7 @@
           <p:cNvPr id="28" name="">
             <a:extLst xmlns:a="http://schemas.openxmlformats.org/drawingml/2006/main">
               <a:ext uri="{FF2B5EF4-FFF2-40B4-BE49-F238E27FC236}">
-                <a16:creationId xmlns:a16="http://schemas.microsoft.com/office/drawing/2014/main" id="{61624063-F05F-493B-97D3-DBD4F58C2E6D}"/>
+                <a16:creationId xmlns:a16="http://schemas.microsoft.com/office/drawing/2014/main" id="{2C83615C-C39F-4654-A869-4A41BB0BAC79}"/>
               </a:ext>
             </a:extLst>
           </p:cNvPr>
@@ -12321,7 +12321,7 @@
           <p:cNvPr id="29" name="">
             <a:extLst xmlns:a="http://schemas.openxmlformats.org/drawingml/2006/main">
               <a:ext uri="{FF2B5EF4-FFF2-40B4-BE49-F238E27FC236}">
-                <a16:creationId xmlns:a16="http://schemas.microsoft.com/office/drawing/2014/main" id="{F0EAF668-E882-4BC8-973B-5A72F1D1275D}"/>
+                <a16:creationId xmlns:a16="http://schemas.microsoft.com/office/drawing/2014/main" id="{6064BD52-F8F8-4E6E-B256-F4AECB9AAAC2}"/>
               </a:ext>
             </a:extLst>
           </p:cNvPr>
@@ -12356,7 +12356,7 @@
           <p:cNvPr id="30" name="">
             <a:extLst xmlns:a="http://schemas.openxmlformats.org/drawingml/2006/main">
               <a:ext uri="{FF2B5EF4-FFF2-40B4-BE49-F238E27FC236}">
-                <a16:creationId xmlns:a16="http://schemas.microsoft.com/office/drawing/2014/main" id="{CC6E2353-A058-42FF-812D-F69737440754}"/>
+                <a16:creationId xmlns:a16="http://schemas.microsoft.com/office/drawing/2014/main" id="{4935A300-5489-421E-B216-BAEB0ECFE9F7}"/>
               </a:ext>
             </a:extLst>
           </p:cNvPr>
@@ -12513,7 +12513,7 @@
           <p:cNvPr id="31" name="">
             <a:extLst xmlns:a="http://schemas.openxmlformats.org/drawingml/2006/main">
               <a:ext uri="{FF2B5EF4-FFF2-40B4-BE49-F238E27FC236}">
-                <a16:creationId xmlns:a16="http://schemas.microsoft.com/office/drawing/2014/main" id="{B08A45D5-102A-4662-9D5B-26AFF3063689}"/>
+                <a16:creationId xmlns:a16="http://schemas.microsoft.com/office/drawing/2014/main" id="{491177F0-11DF-4434-BF0D-2CDAC549C660}"/>
               </a:ext>
             </a:extLst>
           </p:cNvPr>
@@ -12670,7 +12670,7 @@
           <p:cNvPr id="32" name="">
             <a:extLst xmlns:a="http://schemas.openxmlformats.org/drawingml/2006/main">
               <a:ext uri="{FF2B5EF4-FFF2-40B4-BE49-F238E27FC236}">
-                <a16:creationId xmlns:a16="http://schemas.microsoft.com/office/drawing/2014/main" id="{6A1BB030-B047-414C-BB7B-F473CE7EF971}"/>
+                <a16:creationId xmlns:a16="http://schemas.microsoft.com/office/drawing/2014/main" id="{620B7701-3EB6-4BA6-81AA-25C07E39419E}"/>
               </a:ext>
             </a:extLst>
           </p:cNvPr>
@@ -12827,7 +12827,7 @@
           <p:cNvPr id="33" name="">
             <a:extLst xmlns:a="http://schemas.openxmlformats.org/drawingml/2006/main">
               <a:ext uri="{FF2B5EF4-FFF2-40B4-BE49-F238E27FC236}">
-                <a16:creationId xmlns:a16="http://schemas.microsoft.com/office/drawing/2014/main" id="{2BFC7871-4118-40A6-A2DC-71DA408FD15D}"/>
+                <a16:creationId xmlns:a16="http://schemas.microsoft.com/office/drawing/2014/main" id="{096E2EAB-6A36-4C66-B57E-C263E3237670}"/>
               </a:ext>
             </a:extLst>
           </p:cNvPr>
@@ -12862,7 +12862,7 @@
           <p:cNvPr id="34" name="">
             <a:extLst xmlns:a="http://schemas.openxmlformats.org/drawingml/2006/main">
               <a:ext uri="{FF2B5EF4-FFF2-40B4-BE49-F238E27FC236}">
-                <a16:creationId xmlns:a16="http://schemas.microsoft.com/office/drawing/2014/main" id="{D3F101DB-4EAC-4BC7-B0A4-AF9FD0E1DC33}"/>
+                <a16:creationId xmlns:a16="http://schemas.microsoft.com/office/drawing/2014/main" id="{780C275B-858E-46E3-A544-55D266CBA53B}"/>
               </a:ext>
             </a:extLst>
           </p:cNvPr>
@@ -12897,7 +12897,7 @@
           <p:cNvPr id="35" name="">
             <a:extLst xmlns:a="http://schemas.openxmlformats.org/drawingml/2006/main">
               <a:ext uri="{FF2B5EF4-FFF2-40B4-BE49-F238E27FC236}">
-                <a16:creationId xmlns:a16="http://schemas.microsoft.com/office/drawing/2014/main" id="{492C4244-D747-4D2A-AFF8-46F6898DA244}"/>
+                <a16:creationId xmlns:a16="http://schemas.microsoft.com/office/drawing/2014/main" id="{DA9B6C0D-0F4F-488A-A37C-CF6618E3EBD8}"/>
               </a:ext>
             </a:extLst>
           </p:cNvPr>
@@ -13054,7 +13054,7 @@
           <p:cNvPr id="36" name="">
             <a:extLst xmlns:a="http://schemas.openxmlformats.org/drawingml/2006/main">
               <a:ext uri="{FF2B5EF4-FFF2-40B4-BE49-F238E27FC236}">
-                <a16:creationId xmlns:a16="http://schemas.microsoft.com/office/drawing/2014/main" id="{195CC5EE-FDD7-4AED-B3AF-0474E3881E59}"/>
+                <a16:creationId xmlns:a16="http://schemas.microsoft.com/office/drawing/2014/main" id="{A089C501-0578-4B1E-8291-893E8069900A}"/>
               </a:ext>
             </a:extLst>
           </p:cNvPr>
@@ -13211,7 +13211,7 @@
           <p:cNvPr id="37" name="">
             <a:extLst xmlns:a="http://schemas.openxmlformats.org/drawingml/2006/main">
               <a:ext uri="{FF2B5EF4-FFF2-40B4-BE49-F238E27FC236}">
-                <a16:creationId xmlns:a16="http://schemas.microsoft.com/office/drawing/2014/main" id="{481ACAC1-0C3B-40E8-B4B3-567B555B2C5E}"/>
+                <a16:creationId xmlns:a16="http://schemas.microsoft.com/office/drawing/2014/main" id="{0C705901-D314-40CD-8757-C659F2DDB700}"/>
               </a:ext>
             </a:extLst>
           </p:cNvPr>
@@ -13368,7 +13368,7 @@
           <p:cNvPr id="38" name="">
             <a:extLst xmlns:a="http://schemas.openxmlformats.org/drawingml/2006/main">
               <a:ext uri="{FF2B5EF4-FFF2-40B4-BE49-F238E27FC236}">
-                <a16:creationId xmlns:a16="http://schemas.microsoft.com/office/drawing/2014/main" id="{E0C9589B-8E35-4B85-957B-E150E5575C9D}"/>
+                <a16:creationId xmlns:a16="http://schemas.microsoft.com/office/drawing/2014/main" id="{54769A5E-5198-4713-B48C-3EAA40F1AAC3}"/>
               </a:ext>
             </a:extLst>
           </p:cNvPr>
@@ -13399,7 +13399,7 @@
           <p:cNvPr id="39" name="">
             <a:extLst xmlns:a="http://schemas.openxmlformats.org/drawingml/2006/main">
               <a:ext uri="{FF2B5EF4-FFF2-40B4-BE49-F238E27FC236}">
-                <a16:creationId xmlns:a16="http://schemas.microsoft.com/office/drawing/2014/main" id="{A6BAFBC9-4894-4EEB-B311-D774F553BC85}"/>
+                <a16:creationId xmlns:a16="http://schemas.microsoft.com/office/drawing/2014/main" id="{0B8DD227-F881-4859-96C5-81A6DB2A7964}"/>
               </a:ext>
             </a:extLst>
           </p:cNvPr>
@@ -13556,7 +13556,7 @@
           <p:cNvPr id="40" name="">
             <a:extLst xmlns:a="http://schemas.openxmlformats.org/drawingml/2006/main">
               <a:ext uri="{FF2B5EF4-FFF2-40B4-BE49-F238E27FC236}">
-                <a16:creationId xmlns:a16="http://schemas.microsoft.com/office/drawing/2014/main" id="{83A346D7-EF2E-4E8B-B69B-CA19CF599351}"/>
+                <a16:creationId xmlns:a16="http://schemas.microsoft.com/office/drawing/2014/main" id="{718BAF09-694F-4308-B9A9-9F42037503A0}"/>
               </a:ext>
             </a:extLst>
           </p:cNvPr>
@@ -13711,7 +13711,7 @@
     </p:spTree>
     <p:extLst>
       <p:ext uri="{BB962C8B-B14F-4D97-AF65-F5344CB8AC3E}">
-        <p14:creationId xmlns:p14="http://schemas.microsoft.com/office/powerpoint/2010/main" val="259704834"/>
+        <p14:creationId xmlns:p14="http://schemas.microsoft.com/office/powerpoint/2010/main" val="1176487722"/>
       </p:ext>
     </p:extLst>
   </p:cSld>
@@ -13742,7 +13742,7 @@
           <p:cNvPr id="33" name="">
             <a:extLst xmlns:a="http://schemas.openxmlformats.org/drawingml/2006/main">
               <a:ext uri="{FF2B5EF4-FFF2-40B4-BE49-F238E27FC236}">
-                <a16:creationId xmlns:a16="http://schemas.microsoft.com/office/drawing/2014/main" id="{5B1560E2-8E3C-47AF-8140-B7B3C41CD4B0}"/>
+                <a16:creationId xmlns:a16="http://schemas.microsoft.com/office/drawing/2014/main" id="{21735D35-CDCE-445F-884E-F49758C4181A}"/>
               </a:ext>
             </a:extLst>
           </p:cNvPr>
@@ -13899,7 +13899,7 @@
           <p:cNvPr id="2" name="">
             <a:extLst xmlns:a="http://schemas.openxmlformats.org/drawingml/2006/main">
               <a:ext uri="{FF2B5EF4-FFF2-40B4-BE49-F238E27FC236}">
-                <a16:creationId xmlns:a16="http://schemas.microsoft.com/office/drawing/2014/main" id="{81244991-E7D5-41BE-9C69-195AEF2D5CD3}"/>
+                <a16:creationId xmlns:a16="http://schemas.microsoft.com/office/drawing/2014/main" id="{8568FBD6-55C9-4FD6-A25B-1D86058F8563}"/>
               </a:ext>
             </a:extLst>
           </p:cNvPr>
@@ -14056,7 +14056,7 @@
           <p:cNvPr id="3" name="">
             <a:extLst xmlns:a="http://schemas.openxmlformats.org/drawingml/2006/main">
               <a:ext uri="{FF2B5EF4-FFF2-40B4-BE49-F238E27FC236}">
-                <a16:creationId xmlns:a16="http://schemas.microsoft.com/office/drawing/2014/main" id="{CFC02913-32E5-4C52-BCDC-6CD6C9AE912C}"/>
+                <a16:creationId xmlns:a16="http://schemas.microsoft.com/office/drawing/2014/main" id="{A0E8457C-5791-4CF5-8793-F1081A5A979A}"/>
               </a:ext>
             </a:extLst>
           </p:cNvPr>
@@ -14213,7 +14213,7 @@
           <p:cNvPr id="4" name="">
             <a:extLst xmlns:a="http://schemas.openxmlformats.org/drawingml/2006/main">
               <a:ext uri="{FF2B5EF4-FFF2-40B4-BE49-F238E27FC236}">
-                <a16:creationId xmlns:a16="http://schemas.microsoft.com/office/drawing/2014/main" id="{6AA7CAC2-C6B0-4C2C-98BD-0DD15363BEFC}"/>
+                <a16:creationId xmlns:a16="http://schemas.microsoft.com/office/drawing/2014/main" id="{71127296-B69D-4058-9B56-06D3DEF18E9C}"/>
               </a:ext>
             </a:extLst>
           </p:cNvPr>
@@ -14248,7 +14248,7 @@
           <p:cNvPr id="5" name="">
             <a:extLst xmlns:a="http://schemas.openxmlformats.org/drawingml/2006/main">
               <a:ext uri="{FF2B5EF4-FFF2-40B4-BE49-F238E27FC236}">
-                <a16:creationId xmlns:a16="http://schemas.microsoft.com/office/drawing/2014/main" id="{C8F58F65-D687-4F4F-897E-ED6AB46CA11D}"/>
+                <a16:creationId xmlns:a16="http://schemas.microsoft.com/office/drawing/2014/main" id="{FF31413B-7C35-419D-A38E-DFFBE41C53B0}"/>
               </a:ext>
             </a:extLst>
           </p:cNvPr>
@@ -14405,7 +14405,7 @@
           <p:cNvPr id="6" name="">
             <a:extLst xmlns:a="http://schemas.openxmlformats.org/drawingml/2006/main">
               <a:ext uri="{FF2B5EF4-FFF2-40B4-BE49-F238E27FC236}">
-                <a16:creationId xmlns:a16="http://schemas.microsoft.com/office/drawing/2014/main" id="{A73327DA-322E-4FEC-89E1-89E0907B5501}"/>
+                <a16:creationId xmlns:a16="http://schemas.microsoft.com/office/drawing/2014/main" id="{B309B206-38B5-4640-93C1-D1E478D69250}"/>
               </a:ext>
             </a:extLst>
           </p:cNvPr>
@@ -14440,7 +14440,7 @@
           <p:cNvPr id="7" name="">
             <a:extLst xmlns:a="http://schemas.openxmlformats.org/drawingml/2006/main">
               <a:ext uri="{FF2B5EF4-FFF2-40B4-BE49-F238E27FC236}">
-                <a16:creationId xmlns:a16="http://schemas.microsoft.com/office/drawing/2014/main" id="{B25E9864-6B74-47D7-AD4B-041DCEA1B931}"/>
+                <a16:creationId xmlns:a16="http://schemas.microsoft.com/office/drawing/2014/main" id="{209F72A7-B787-4DA8-A744-297649F1EF29}"/>
               </a:ext>
             </a:extLst>
           </p:cNvPr>
@@ -14597,7 +14597,7 @@
           <p:cNvPr id="8" name="">
             <a:extLst xmlns:a="http://schemas.openxmlformats.org/drawingml/2006/main">
               <a:ext uri="{FF2B5EF4-FFF2-40B4-BE49-F238E27FC236}">
-                <a16:creationId xmlns:a16="http://schemas.microsoft.com/office/drawing/2014/main" id="{0DE136D8-F3FE-4A0B-96EA-FF5A31CF4DCD}"/>
+                <a16:creationId xmlns:a16="http://schemas.microsoft.com/office/drawing/2014/main" id="{7043689B-D83F-499E-A4D5-8A37057A7633}"/>
               </a:ext>
             </a:extLst>
           </p:cNvPr>
@@ -14754,7 +14754,7 @@
           <p:cNvPr id="9" name="">
             <a:extLst xmlns:a="http://schemas.openxmlformats.org/drawingml/2006/main">
               <a:ext uri="{FF2B5EF4-FFF2-40B4-BE49-F238E27FC236}">
-                <a16:creationId xmlns:a16="http://schemas.microsoft.com/office/drawing/2014/main" id="{E73FF06E-FD1E-40C9-8B6B-CE53FB8D2F1B}"/>
+                <a16:creationId xmlns:a16="http://schemas.microsoft.com/office/drawing/2014/main" id="{78C0FEE7-D39D-4BEB-9E17-B63EA7E392D5}"/>
               </a:ext>
             </a:extLst>
           </p:cNvPr>
@@ -14789,7 +14789,7 @@
           <p:cNvPr id="10" name="">
             <a:extLst xmlns:a="http://schemas.openxmlformats.org/drawingml/2006/main">
               <a:ext uri="{FF2B5EF4-FFF2-40B4-BE49-F238E27FC236}">
-                <a16:creationId xmlns:a16="http://schemas.microsoft.com/office/drawing/2014/main" id="{2C659E31-C9FA-4BA8-9A58-50ACF3746BB6}"/>
+                <a16:creationId xmlns:a16="http://schemas.microsoft.com/office/drawing/2014/main" id="{B7B3AB51-E02D-4369-91C2-D739A511424B}"/>
               </a:ext>
             </a:extLst>
           </p:cNvPr>
@@ -14946,7 +14946,7 @@
           <p:cNvPr id="11" name="">
             <a:extLst xmlns:a="http://schemas.openxmlformats.org/drawingml/2006/main">
               <a:ext uri="{FF2B5EF4-FFF2-40B4-BE49-F238E27FC236}">
-                <a16:creationId xmlns:a16="http://schemas.microsoft.com/office/drawing/2014/main" id="{D86472F7-F88A-42A7-A0E9-A02A10D63A74}"/>
+                <a16:creationId xmlns:a16="http://schemas.microsoft.com/office/drawing/2014/main" id="{E5F5F75D-9D63-4E3F-9999-DBD2AC9A26B9}"/>
               </a:ext>
             </a:extLst>
           </p:cNvPr>
@@ -15103,7 +15103,7 @@
           <p:cNvPr id="12" name="">
             <a:extLst xmlns:a="http://schemas.openxmlformats.org/drawingml/2006/main">
               <a:ext uri="{FF2B5EF4-FFF2-40B4-BE49-F238E27FC236}">
-                <a16:creationId xmlns:a16="http://schemas.microsoft.com/office/drawing/2014/main" id="{9515CF1F-684B-42DC-99D9-CF42AD3EF162}"/>
+                <a16:creationId xmlns:a16="http://schemas.microsoft.com/office/drawing/2014/main" id="{5DD83526-660D-4B17-A348-FDB48F2E095D}"/>
               </a:ext>
             </a:extLst>
           </p:cNvPr>
@@ -15138,7 +15138,7 @@
           <p:cNvPr id="13" name="">
             <a:extLst xmlns:a="http://schemas.openxmlformats.org/drawingml/2006/main">
               <a:ext uri="{FF2B5EF4-FFF2-40B4-BE49-F238E27FC236}">
-                <a16:creationId xmlns:a16="http://schemas.microsoft.com/office/drawing/2014/main" id="{2636670E-5AEC-42EF-A893-987ACDE452BF}"/>
+                <a16:creationId xmlns:a16="http://schemas.microsoft.com/office/drawing/2014/main" id="{749BF2A2-9214-44B0-B9A9-EBB3A70B063E}"/>
               </a:ext>
             </a:extLst>
           </p:cNvPr>
@@ -15295,7 +15295,7 @@
           <p:cNvPr id="14" name="">
             <a:extLst xmlns:a="http://schemas.openxmlformats.org/drawingml/2006/main">
               <a:ext uri="{FF2B5EF4-FFF2-40B4-BE49-F238E27FC236}">
-                <a16:creationId xmlns:a16="http://schemas.microsoft.com/office/drawing/2014/main" id="{BCC154A7-C265-4EBA-A270-FC3D291AE799}"/>
+                <a16:creationId xmlns:a16="http://schemas.microsoft.com/office/drawing/2014/main" id="{A5797896-6525-4183-95C1-CE2A2B3709BF}"/>
               </a:ext>
             </a:extLst>
           </p:cNvPr>
@@ -15452,7 +15452,7 @@
           <p:cNvPr id="15" name="">
             <a:extLst xmlns:a="http://schemas.openxmlformats.org/drawingml/2006/main">
               <a:ext uri="{FF2B5EF4-FFF2-40B4-BE49-F238E27FC236}">
-                <a16:creationId xmlns:a16="http://schemas.microsoft.com/office/drawing/2014/main" id="{5736F05B-5EDA-4F43-BA07-131B5FABA449}"/>
+                <a16:creationId xmlns:a16="http://schemas.microsoft.com/office/drawing/2014/main" id="{FDB7E879-A446-4260-8E3B-3E47D9C47AFC}"/>
               </a:ext>
             </a:extLst>
           </p:cNvPr>
@@ -15487,7 +15487,7 @@
           <p:cNvPr id="16" name="">
             <a:extLst xmlns:a="http://schemas.openxmlformats.org/drawingml/2006/main">
               <a:ext uri="{FF2B5EF4-FFF2-40B4-BE49-F238E27FC236}">
-                <a16:creationId xmlns:a16="http://schemas.microsoft.com/office/drawing/2014/main" id="{D42BD106-11DE-40A4-A1EC-831B8D1A83E2}"/>
+                <a16:creationId xmlns:a16="http://schemas.microsoft.com/office/drawing/2014/main" id="{8DF1751E-280B-45B3-891F-F82AE4EA7299}"/>
               </a:ext>
             </a:extLst>
           </p:cNvPr>
@@ -15644,7 +15644,7 @@
           <p:cNvPr id="17" name="">
             <a:extLst xmlns:a="http://schemas.openxmlformats.org/drawingml/2006/main">
               <a:ext uri="{FF2B5EF4-FFF2-40B4-BE49-F238E27FC236}">
-                <a16:creationId xmlns:a16="http://schemas.microsoft.com/office/drawing/2014/main" id="{BA397B68-A6FA-464F-8E00-E114DB091208}"/>
+                <a16:creationId xmlns:a16="http://schemas.microsoft.com/office/drawing/2014/main" id="{74C52FA0-A4F5-4D7D-985E-2FC5146891E4}"/>
               </a:ext>
             </a:extLst>
           </p:cNvPr>
@@ -15801,7 +15801,7 @@
           <p:cNvPr id="18" name="">
             <a:extLst xmlns:a="http://schemas.openxmlformats.org/drawingml/2006/main">
               <a:ext uri="{FF2B5EF4-FFF2-40B4-BE49-F238E27FC236}">
-                <a16:creationId xmlns:a16="http://schemas.microsoft.com/office/drawing/2014/main" id="{C8E050BD-5081-41F2-AE89-65E8D9A9432C}"/>
+                <a16:creationId xmlns:a16="http://schemas.microsoft.com/office/drawing/2014/main" id="{1D30BE06-CDAC-44DA-9C7D-1DB5EB3B21AA}"/>
               </a:ext>
             </a:extLst>
           </p:cNvPr>
@@ -15958,7 +15958,7 @@
           <p:cNvPr id="19" name="">
             <a:extLst xmlns:a="http://schemas.openxmlformats.org/drawingml/2006/main">
               <a:ext uri="{FF2B5EF4-FFF2-40B4-BE49-F238E27FC236}">
-                <a16:creationId xmlns:a16="http://schemas.microsoft.com/office/drawing/2014/main" id="{A541D05A-B8D4-4555-9DC7-E218F5743830}"/>
+                <a16:creationId xmlns:a16="http://schemas.microsoft.com/office/drawing/2014/main" id="{A7B42EC6-D3FF-4B79-B911-667E6BBCCFBE}"/>
               </a:ext>
             </a:extLst>
           </p:cNvPr>
@@ -16115,7 +16115,7 @@
           <p:cNvPr id="20" name="">
             <a:extLst xmlns:a="http://schemas.openxmlformats.org/drawingml/2006/main">
               <a:ext uri="{FF2B5EF4-FFF2-40B4-BE49-F238E27FC236}">
-                <a16:creationId xmlns:a16="http://schemas.microsoft.com/office/drawing/2014/main" id="{27BC65A3-627F-44C2-8DDB-432522C625A2}"/>
+                <a16:creationId xmlns:a16="http://schemas.microsoft.com/office/drawing/2014/main" id="{61A839CA-7682-4CD2-85C5-41FF904C64FF}"/>
               </a:ext>
             </a:extLst>
           </p:cNvPr>
@@ -16150,7 +16150,7 @@
           <p:cNvPr id="21" name="">
             <a:extLst xmlns:a="http://schemas.openxmlformats.org/drawingml/2006/main">
               <a:ext uri="{FF2B5EF4-FFF2-40B4-BE49-F238E27FC236}">
-                <a16:creationId xmlns:a16="http://schemas.microsoft.com/office/drawing/2014/main" id="{0CBF5799-1C4F-43EA-ACFA-4B848C4B3B33}"/>
+                <a16:creationId xmlns:a16="http://schemas.microsoft.com/office/drawing/2014/main" id="{B892BF1E-9D46-4812-B485-8907B4FEFA6D}"/>
               </a:ext>
             </a:extLst>
           </p:cNvPr>
@@ -16307,7 +16307,7 @@
           <p:cNvPr id="22" name="">
             <a:extLst xmlns:a="http://schemas.openxmlformats.org/drawingml/2006/main">
               <a:ext uri="{FF2B5EF4-FFF2-40B4-BE49-F238E27FC236}">
-                <a16:creationId xmlns:a16="http://schemas.microsoft.com/office/drawing/2014/main" id="{8FB01A7B-4334-4ACA-96CE-A35FD072976F}"/>
+                <a16:creationId xmlns:a16="http://schemas.microsoft.com/office/drawing/2014/main" id="{FC9983B0-DF60-4CFA-907F-4366A34A8F4D}"/>
               </a:ext>
             </a:extLst>
           </p:cNvPr>
@@ -16342,7 +16342,7 @@
           <p:cNvPr id="23" name="">
             <a:extLst xmlns:a="http://schemas.openxmlformats.org/drawingml/2006/main">
               <a:ext uri="{FF2B5EF4-FFF2-40B4-BE49-F238E27FC236}">
-                <a16:creationId xmlns:a16="http://schemas.microsoft.com/office/drawing/2014/main" id="{8D632419-F8AF-4353-AC1C-BEF115154E60}"/>
+                <a16:creationId xmlns:a16="http://schemas.microsoft.com/office/drawing/2014/main" id="{11F41A51-00D2-498F-BB25-76FDF2507C4E}"/>
               </a:ext>
             </a:extLst>
           </p:cNvPr>
@@ -16499,7 +16499,7 @@
           <p:cNvPr id="24" name="">
             <a:extLst xmlns:a="http://schemas.openxmlformats.org/drawingml/2006/main">
               <a:ext uri="{FF2B5EF4-FFF2-40B4-BE49-F238E27FC236}">
-                <a16:creationId xmlns:a16="http://schemas.microsoft.com/office/drawing/2014/main" id="{0FD6B7B2-64AE-41C3-A769-7AF87A264860}"/>
+                <a16:creationId xmlns:a16="http://schemas.microsoft.com/office/drawing/2014/main" id="{07545AF1-7622-4A95-AFC4-DF99F00FB50F}"/>
               </a:ext>
             </a:extLst>
           </p:cNvPr>
@@ -16534,7 +16534,7 @@
           <p:cNvPr id="25" name="">
             <a:extLst xmlns:a="http://schemas.openxmlformats.org/drawingml/2006/main">
               <a:ext uri="{FF2B5EF4-FFF2-40B4-BE49-F238E27FC236}">
-                <a16:creationId xmlns:a16="http://schemas.microsoft.com/office/drawing/2014/main" id="{1CCB2002-EDB7-4986-A1A0-A59B24851C84}"/>
+                <a16:creationId xmlns:a16="http://schemas.microsoft.com/office/drawing/2014/main" id="{9C1E0DEF-58D6-4267-A339-11D6ADC40FA8}"/>
               </a:ext>
             </a:extLst>
           </p:cNvPr>
@@ -16691,7 +16691,7 @@
           <p:cNvPr id="26" name="">
             <a:extLst xmlns:a="http://schemas.openxmlformats.org/drawingml/2006/main">
               <a:ext uri="{FF2B5EF4-FFF2-40B4-BE49-F238E27FC236}">
-                <a16:creationId xmlns:a16="http://schemas.microsoft.com/office/drawing/2014/main" id="{40EB5D53-1939-470C-96E5-77D779304A7C}"/>
+                <a16:creationId xmlns:a16="http://schemas.microsoft.com/office/drawing/2014/main" id="{B8F6CA85-A9CC-465E-A17E-692980F87A2D}"/>
               </a:ext>
             </a:extLst>
           </p:cNvPr>
@@ -16726,7 +16726,7 @@
           <p:cNvPr id="27" name="">
             <a:extLst xmlns:a="http://schemas.openxmlformats.org/drawingml/2006/main">
               <a:ext uri="{FF2B5EF4-FFF2-40B4-BE49-F238E27FC236}">
-                <a16:creationId xmlns:a16="http://schemas.microsoft.com/office/drawing/2014/main" id="{4039AF21-EA06-4C76-80F4-C78E64EEF8CB}"/>
+                <a16:creationId xmlns:a16="http://schemas.microsoft.com/office/drawing/2014/main" id="{7FAD90B7-E5D3-49E0-8475-6E4EAC14ECA1}"/>
               </a:ext>
             </a:extLst>
           </p:cNvPr>
@@ -16883,7 +16883,7 @@
           <p:cNvPr id="28" name="">
             <a:extLst xmlns:a="http://schemas.openxmlformats.org/drawingml/2006/main">
               <a:ext uri="{FF2B5EF4-FFF2-40B4-BE49-F238E27FC236}">
-                <a16:creationId xmlns:a16="http://schemas.microsoft.com/office/drawing/2014/main" id="{D3D1BECB-4129-4CC9-8DF4-9F47A5F3DB48}"/>
+                <a16:creationId xmlns:a16="http://schemas.microsoft.com/office/drawing/2014/main" id="{701628AA-E328-4604-8F9E-5BC66328088A}"/>
               </a:ext>
             </a:extLst>
           </p:cNvPr>
@@ -16918,7 +16918,7 @@
           <p:cNvPr id="29" name="">
             <a:extLst xmlns:a="http://schemas.openxmlformats.org/drawingml/2006/main">
               <a:ext uri="{FF2B5EF4-FFF2-40B4-BE49-F238E27FC236}">
-                <a16:creationId xmlns:a16="http://schemas.microsoft.com/office/drawing/2014/main" id="{AD625329-838B-4A79-820F-CF64229CD3F1}"/>
+                <a16:creationId xmlns:a16="http://schemas.microsoft.com/office/drawing/2014/main" id="{F4B430CB-4B33-45A4-BFF9-982331701CCB}"/>
               </a:ext>
             </a:extLst>
           </p:cNvPr>
@@ -17075,7 +17075,7 @@
           <p:cNvPr id="30" name="">
             <a:extLst xmlns:a="http://schemas.openxmlformats.org/drawingml/2006/main">
               <a:ext uri="{FF2B5EF4-FFF2-40B4-BE49-F238E27FC236}">
-                <a16:creationId xmlns:a16="http://schemas.microsoft.com/office/drawing/2014/main" id="{82BA7C66-4CDD-4077-8245-64481E9A77D1}"/>
+                <a16:creationId xmlns:a16="http://schemas.microsoft.com/office/drawing/2014/main" id="{5AEAFF47-E754-421C-B661-3BAAA7C7684C}"/>
               </a:ext>
             </a:extLst>
           </p:cNvPr>
@@ -17106,7 +17106,7 @@
           <p:cNvPr id="31" name="">
             <a:extLst xmlns:a="http://schemas.openxmlformats.org/drawingml/2006/main">
               <a:ext uri="{FF2B5EF4-FFF2-40B4-BE49-F238E27FC236}">
-                <a16:creationId xmlns:a16="http://schemas.microsoft.com/office/drawing/2014/main" id="{3AB05C12-D04D-4A71-BFB8-EBF1EBDBD987}"/>
+                <a16:creationId xmlns:a16="http://schemas.microsoft.com/office/drawing/2014/main" id="{7636B51F-1080-4A33-9539-71FAA3BB41C1}"/>
               </a:ext>
             </a:extLst>
           </p:cNvPr>
@@ -17263,7 +17263,7 @@
           <p:cNvPr id="32" name="">
             <a:extLst xmlns:a="http://schemas.openxmlformats.org/drawingml/2006/main">
               <a:ext uri="{FF2B5EF4-FFF2-40B4-BE49-F238E27FC236}">
-                <a16:creationId xmlns:a16="http://schemas.microsoft.com/office/drawing/2014/main" id="{16F0159E-3204-461B-AA3A-9EDAC8516D35}"/>
+                <a16:creationId xmlns:a16="http://schemas.microsoft.com/office/drawing/2014/main" id="{3999AA50-9F94-4F99-B2C2-67843A84038F}"/>
               </a:ext>
             </a:extLst>
           </p:cNvPr>
@@ -17418,7 +17418,7 @@
     </p:spTree>
     <p:extLst>
       <p:ext uri="{BB962C8B-B14F-4D97-AF65-F5344CB8AC3E}">
-        <p14:creationId xmlns:p14="http://schemas.microsoft.com/office/powerpoint/2010/main" val="591541181"/>
+        <p14:creationId xmlns:p14="http://schemas.microsoft.com/office/powerpoint/2010/main" val="1926473638"/>
       </p:ext>
     </p:extLst>
   </p:cSld>
@@ -17449,7 +17449,7 @@
           <p:cNvPr id="31" name="">
             <a:extLst xmlns:a="http://schemas.openxmlformats.org/drawingml/2006/main">
               <a:ext uri="{FF2B5EF4-FFF2-40B4-BE49-F238E27FC236}">
-                <a16:creationId xmlns:a16="http://schemas.microsoft.com/office/drawing/2014/main" id="{51C991E8-745E-45BC-AAE9-3BE8D08AECA4}"/>
+                <a16:creationId xmlns:a16="http://schemas.microsoft.com/office/drawing/2014/main" id="{C72CC3C8-D66C-49DA-B1A0-BD2803A25CC4}"/>
               </a:ext>
             </a:extLst>
           </p:cNvPr>
@@ -17606,7 +17606,7 @@
           <p:cNvPr id="2" name="">
             <a:extLst xmlns:a="http://schemas.openxmlformats.org/drawingml/2006/main">
               <a:ext uri="{FF2B5EF4-FFF2-40B4-BE49-F238E27FC236}">
-                <a16:creationId xmlns:a16="http://schemas.microsoft.com/office/drawing/2014/main" id="{3DC6ECED-504C-46D1-94DB-B7B16F03D04A}"/>
+                <a16:creationId xmlns:a16="http://schemas.microsoft.com/office/drawing/2014/main" id="{F67C8AD5-03A9-42CE-9C73-406E85895794}"/>
               </a:ext>
             </a:extLst>
           </p:cNvPr>
@@ -17763,7 +17763,7 @@
           <p:cNvPr id="3" name="">
             <a:extLst xmlns:a="http://schemas.openxmlformats.org/drawingml/2006/main">
               <a:ext uri="{FF2B5EF4-FFF2-40B4-BE49-F238E27FC236}">
-                <a16:creationId xmlns:a16="http://schemas.microsoft.com/office/drawing/2014/main" id="{28B4EBF3-418B-4733-A74A-E06F04697A4B}"/>
+                <a16:creationId xmlns:a16="http://schemas.microsoft.com/office/drawing/2014/main" id="{EA8F2896-CE97-4E60-AB6F-5CE36BB8C7E6}"/>
               </a:ext>
             </a:extLst>
           </p:cNvPr>
@@ -17920,7 +17920,7 @@
           <p:cNvPr id="4" name="">
             <a:extLst xmlns:a="http://schemas.openxmlformats.org/drawingml/2006/main">
               <a:ext uri="{FF2B5EF4-FFF2-40B4-BE49-F238E27FC236}">
-                <a16:creationId xmlns:a16="http://schemas.microsoft.com/office/drawing/2014/main" id="{902414D2-4E40-4C19-92D2-EC45509E56CB}"/>
+                <a16:creationId xmlns:a16="http://schemas.microsoft.com/office/drawing/2014/main" id="{ACF67097-43BE-4755-AA4F-30DB554DC676}"/>
               </a:ext>
             </a:extLst>
           </p:cNvPr>
@@ -17955,7 +17955,7 @@
           <p:cNvPr id="5" name="">
             <a:extLst xmlns:a="http://schemas.openxmlformats.org/drawingml/2006/main">
               <a:ext uri="{FF2B5EF4-FFF2-40B4-BE49-F238E27FC236}">
-                <a16:creationId xmlns:a16="http://schemas.microsoft.com/office/drawing/2014/main" id="{C827ED68-B7D4-4D6F-9FC5-8F9B9883413A}"/>
+                <a16:creationId xmlns:a16="http://schemas.microsoft.com/office/drawing/2014/main" id="{E894ABF8-997C-49A2-ABF2-AAF8B954C1E7}"/>
               </a:ext>
             </a:extLst>
           </p:cNvPr>
@@ -17990,7 +17990,7 @@
           <p:cNvPr id="6" name="">
             <a:extLst xmlns:a="http://schemas.openxmlformats.org/drawingml/2006/main">
               <a:ext uri="{FF2B5EF4-FFF2-40B4-BE49-F238E27FC236}">
-                <a16:creationId xmlns:a16="http://schemas.microsoft.com/office/drawing/2014/main" id="{4561887C-B4D0-4BBA-9E28-629CC40E2015}"/>
+                <a16:creationId xmlns:a16="http://schemas.microsoft.com/office/drawing/2014/main" id="{7C313935-104B-416B-90EC-1EA0426BC452}"/>
               </a:ext>
             </a:extLst>
           </p:cNvPr>
@@ -18147,7 +18147,7 @@
           <p:cNvPr id="7" name="">
             <a:extLst xmlns:a="http://schemas.openxmlformats.org/drawingml/2006/main">
               <a:ext uri="{FF2B5EF4-FFF2-40B4-BE49-F238E27FC236}">
-                <a16:creationId xmlns:a16="http://schemas.microsoft.com/office/drawing/2014/main" id="{5636A2F3-2D0A-4A53-AC26-B1F15D0DBD60}"/>
+                <a16:creationId xmlns:a16="http://schemas.microsoft.com/office/drawing/2014/main" id="{434A38C6-38B9-48A6-AEB7-3F18B8EF7C86}"/>
               </a:ext>
             </a:extLst>
           </p:cNvPr>
@@ -18304,7 +18304,7 @@
           <p:cNvPr id="8" name="">
             <a:extLst xmlns:a="http://schemas.openxmlformats.org/drawingml/2006/main">
               <a:ext uri="{FF2B5EF4-FFF2-40B4-BE49-F238E27FC236}">
-                <a16:creationId xmlns:a16="http://schemas.microsoft.com/office/drawing/2014/main" id="{612928FC-9EB2-4614-8E71-48866A014ACA}"/>
+                <a16:creationId xmlns:a16="http://schemas.microsoft.com/office/drawing/2014/main" id="{CA51B48E-B4D3-4491-8F7D-911EF0C87A32}"/>
               </a:ext>
             </a:extLst>
           </p:cNvPr>
@@ -18461,7 +18461,7 @@
           <p:cNvPr id="9" name="">
             <a:extLst xmlns:a="http://schemas.openxmlformats.org/drawingml/2006/main">
               <a:ext uri="{FF2B5EF4-FFF2-40B4-BE49-F238E27FC236}">
-                <a16:creationId xmlns:a16="http://schemas.microsoft.com/office/drawing/2014/main" id="{CBEFAA64-3C27-41AA-85F0-520A133E5F4A}"/>
+                <a16:creationId xmlns:a16="http://schemas.microsoft.com/office/drawing/2014/main" id="{B1606CF7-414E-456A-9F5A-B5FC80FAD393}"/>
               </a:ext>
             </a:extLst>
           </p:cNvPr>
@@ -18496,7 +18496,7 @@
           <p:cNvPr id="10" name="">
             <a:extLst xmlns:a="http://schemas.openxmlformats.org/drawingml/2006/main">
               <a:ext uri="{FF2B5EF4-FFF2-40B4-BE49-F238E27FC236}">
-                <a16:creationId xmlns:a16="http://schemas.microsoft.com/office/drawing/2014/main" id="{B3F60C6A-977F-42AB-90DD-149E3CBC211A}"/>
+                <a16:creationId xmlns:a16="http://schemas.microsoft.com/office/drawing/2014/main" id="{6BBE29AA-76C9-45A3-A083-B29AEF61F043}"/>
               </a:ext>
             </a:extLst>
           </p:cNvPr>
@@ -18531,7 +18531,7 @@
           <p:cNvPr id="11" name="">
             <a:extLst xmlns:a="http://schemas.openxmlformats.org/drawingml/2006/main">
               <a:ext uri="{FF2B5EF4-FFF2-40B4-BE49-F238E27FC236}">
-                <a16:creationId xmlns:a16="http://schemas.microsoft.com/office/drawing/2014/main" id="{44536FE7-697B-44E9-8C9C-EC072549BCBA}"/>
+                <a16:creationId xmlns:a16="http://schemas.microsoft.com/office/drawing/2014/main" id="{6159CC23-F250-4ED3-A5C8-A3C8616B66B4}"/>
               </a:ext>
             </a:extLst>
           </p:cNvPr>
@@ -18688,7 +18688,7 @@
           <p:cNvPr id="12" name="">
             <a:extLst xmlns:a="http://schemas.openxmlformats.org/drawingml/2006/main">
               <a:ext uri="{FF2B5EF4-FFF2-40B4-BE49-F238E27FC236}">
-                <a16:creationId xmlns:a16="http://schemas.microsoft.com/office/drawing/2014/main" id="{C88B5737-B56C-4327-8B4B-D3DC53BC9B06}"/>
+                <a16:creationId xmlns:a16="http://schemas.microsoft.com/office/drawing/2014/main" id="{D45F2820-1A77-4FB1-B065-02E757E9DAAB}"/>
               </a:ext>
             </a:extLst>
           </p:cNvPr>
@@ -18845,7 +18845,7 @@
           <p:cNvPr id="13" name="">
             <a:extLst xmlns:a="http://schemas.openxmlformats.org/drawingml/2006/main">
               <a:ext uri="{FF2B5EF4-FFF2-40B4-BE49-F238E27FC236}">
-                <a16:creationId xmlns:a16="http://schemas.microsoft.com/office/drawing/2014/main" id="{B6A29A32-32AB-418C-A59F-FE9656DF4C79}"/>
+                <a16:creationId xmlns:a16="http://schemas.microsoft.com/office/drawing/2014/main" id="{76FBCE98-9E9E-4CA2-ADC6-6273BC012D2E}"/>
               </a:ext>
             </a:extLst>
           </p:cNvPr>
@@ -19002,7 +19002,7 @@
           <p:cNvPr id="14" name="">
             <a:extLst xmlns:a="http://schemas.openxmlformats.org/drawingml/2006/main">
               <a:ext uri="{FF2B5EF4-FFF2-40B4-BE49-F238E27FC236}">
-                <a16:creationId xmlns:a16="http://schemas.microsoft.com/office/drawing/2014/main" id="{49B46546-2FFC-4118-B33A-08D7BD12267F}"/>
+                <a16:creationId xmlns:a16="http://schemas.microsoft.com/office/drawing/2014/main" id="{5DC075F1-BD03-457E-A028-0502D4F90CDB}"/>
               </a:ext>
             </a:extLst>
           </p:cNvPr>
@@ -19037,7 +19037,7 @@
           <p:cNvPr id="15" name="">
             <a:extLst xmlns:a="http://schemas.openxmlformats.org/drawingml/2006/main">
               <a:ext uri="{FF2B5EF4-FFF2-40B4-BE49-F238E27FC236}">
-                <a16:creationId xmlns:a16="http://schemas.microsoft.com/office/drawing/2014/main" id="{EFF3A6D3-B06D-408D-8237-6EE65EE473D0}"/>
+                <a16:creationId xmlns:a16="http://schemas.microsoft.com/office/drawing/2014/main" id="{C2B1CF36-6DCD-4CF3-B32E-A7212B128252}"/>
               </a:ext>
             </a:extLst>
           </p:cNvPr>
@@ -19072,7 +19072,7 @@
           <p:cNvPr id="16" name="">
             <a:extLst xmlns:a="http://schemas.openxmlformats.org/drawingml/2006/main">
               <a:ext uri="{FF2B5EF4-FFF2-40B4-BE49-F238E27FC236}">
-                <a16:creationId xmlns:a16="http://schemas.microsoft.com/office/drawing/2014/main" id="{260A3D82-D791-4562-94FE-66D8E373DEE3}"/>
+                <a16:creationId xmlns:a16="http://schemas.microsoft.com/office/drawing/2014/main" id="{99732A38-4B01-4FD7-96E2-FC23338FA4A6}"/>
               </a:ext>
             </a:extLst>
           </p:cNvPr>
@@ -19229,7 +19229,7 @@
           <p:cNvPr id="17" name="">
             <a:extLst xmlns:a="http://schemas.openxmlformats.org/drawingml/2006/main">
               <a:ext uri="{FF2B5EF4-FFF2-40B4-BE49-F238E27FC236}">
-                <a16:creationId xmlns:a16="http://schemas.microsoft.com/office/drawing/2014/main" id="{5D3FEEC4-3876-4824-83D9-1EDF5EFDAEC1}"/>
+                <a16:creationId xmlns:a16="http://schemas.microsoft.com/office/drawing/2014/main" id="{DD387455-E198-4C14-8694-E6D70FF1B92C}"/>
               </a:ext>
             </a:extLst>
           </p:cNvPr>
@@ -19386,7 +19386,7 @@
           <p:cNvPr id="18" name="">
             <a:extLst xmlns:a="http://schemas.openxmlformats.org/drawingml/2006/main">
               <a:ext uri="{FF2B5EF4-FFF2-40B4-BE49-F238E27FC236}">
-                <a16:creationId xmlns:a16="http://schemas.microsoft.com/office/drawing/2014/main" id="{BFD456AF-7AE0-4732-ADA5-14075F0FEDFB}"/>
+                <a16:creationId xmlns:a16="http://schemas.microsoft.com/office/drawing/2014/main" id="{79222453-B96D-4EC2-AD84-B3D298D0F8B5}"/>
               </a:ext>
             </a:extLst>
           </p:cNvPr>
@@ -19543,7 +19543,7 @@
           <p:cNvPr id="19" name="">
             <a:extLst xmlns:a="http://schemas.openxmlformats.org/drawingml/2006/main">
               <a:ext uri="{FF2B5EF4-FFF2-40B4-BE49-F238E27FC236}">
-                <a16:creationId xmlns:a16="http://schemas.microsoft.com/office/drawing/2014/main" id="{8C70A0E4-B1FF-4D4A-AD5E-6F60E14F2D44}"/>
+                <a16:creationId xmlns:a16="http://schemas.microsoft.com/office/drawing/2014/main" id="{BEBB8A99-5895-439B-9BE6-44DE040C8228}"/>
               </a:ext>
             </a:extLst>
           </p:cNvPr>
@@ -19578,7 +19578,7 @@
           <p:cNvPr id="20" name="">
             <a:extLst xmlns:a="http://schemas.openxmlformats.org/drawingml/2006/main">
               <a:ext uri="{FF2B5EF4-FFF2-40B4-BE49-F238E27FC236}">
-                <a16:creationId xmlns:a16="http://schemas.microsoft.com/office/drawing/2014/main" id="{D3127CA5-FC2A-4E2D-9A3C-444177DD6B52}"/>
+                <a16:creationId xmlns:a16="http://schemas.microsoft.com/office/drawing/2014/main" id="{D1E60FDC-EE4C-4206-99B4-40F6E6F5EB47}"/>
               </a:ext>
             </a:extLst>
           </p:cNvPr>
@@ -19735,7 +19735,7 @@
           <p:cNvPr id="21" name="">
             <a:extLst xmlns:a="http://schemas.openxmlformats.org/drawingml/2006/main">
               <a:ext uri="{FF2B5EF4-FFF2-40B4-BE49-F238E27FC236}">
-                <a16:creationId xmlns:a16="http://schemas.microsoft.com/office/drawing/2014/main" id="{8F32EA91-115B-49B1-A945-09E4D32BC0DF}"/>
+                <a16:creationId xmlns:a16="http://schemas.microsoft.com/office/drawing/2014/main" id="{967ABE3F-8919-48E3-9872-35A599EBE1E7}"/>
               </a:ext>
             </a:extLst>
           </p:cNvPr>
@@ -19892,7 +19892,7 @@
           <p:cNvPr id="22" name="">
             <a:extLst xmlns:a="http://schemas.openxmlformats.org/drawingml/2006/main">
               <a:ext uri="{FF2B5EF4-FFF2-40B4-BE49-F238E27FC236}">
-                <a16:creationId xmlns:a16="http://schemas.microsoft.com/office/drawing/2014/main" id="{65B1673B-B3A3-4D72-B0FA-EB26623C26F3}"/>
+                <a16:creationId xmlns:a16="http://schemas.microsoft.com/office/drawing/2014/main" id="{823CAF0C-7E08-4604-9588-44FBC88898FE}"/>
               </a:ext>
             </a:extLst>
           </p:cNvPr>
@@ -20049,7 +20049,7 @@
           <p:cNvPr id="23" name="">
             <a:extLst xmlns:a="http://schemas.openxmlformats.org/drawingml/2006/main">
               <a:ext uri="{FF2B5EF4-FFF2-40B4-BE49-F238E27FC236}">
-                <a16:creationId xmlns:a16="http://schemas.microsoft.com/office/drawing/2014/main" id="{E0FFC889-AEB8-48EA-B410-F3A6229B1CA0}"/>
+                <a16:creationId xmlns:a16="http://schemas.microsoft.com/office/drawing/2014/main" id="{C07A1355-0E4A-40B5-AB76-C756809240D8}"/>
               </a:ext>
             </a:extLst>
           </p:cNvPr>
@@ -20206,7 +20206,7 @@
           <p:cNvPr id="24" name="">
             <a:extLst xmlns:a="http://schemas.openxmlformats.org/drawingml/2006/main">
               <a:ext uri="{FF2B5EF4-FFF2-40B4-BE49-F238E27FC236}">
-                <a16:creationId xmlns:a16="http://schemas.microsoft.com/office/drawing/2014/main" id="{21E4F0CC-89A5-442D-B76A-B15D14A3871E}"/>
+                <a16:creationId xmlns:a16="http://schemas.microsoft.com/office/drawing/2014/main" id="{687C00CA-829D-485B-B428-6B4EAF3514CC}"/>
               </a:ext>
             </a:extLst>
           </p:cNvPr>
@@ -20363,7 +20363,7 @@
           <p:cNvPr id="25" name="">
             <a:extLst xmlns:a="http://schemas.openxmlformats.org/drawingml/2006/main">
               <a:ext uri="{FF2B5EF4-FFF2-40B4-BE49-F238E27FC236}">
-                <a16:creationId xmlns:a16="http://schemas.microsoft.com/office/drawing/2014/main" id="{E78D95E2-5674-4131-BD10-1B1B7E317EAC}"/>
+                <a16:creationId xmlns:a16="http://schemas.microsoft.com/office/drawing/2014/main" id="{028E6894-B04E-49FC-9BEB-8BF8E4A97068}"/>
               </a:ext>
             </a:extLst>
           </p:cNvPr>
@@ -20520,7 +20520,7 @@
           <p:cNvPr id="26" name="">
             <a:extLst xmlns:a="http://schemas.openxmlformats.org/drawingml/2006/main">
               <a:ext uri="{FF2B5EF4-FFF2-40B4-BE49-F238E27FC236}">
-                <a16:creationId xmlns:a16="http://schemas.microsoft.com/office/drawing/2014/main" id="{ED92C474-3428-4A8A-9EE9-FABA3BD88956}"/>
+                <a16:creationId xmlns:a16="http://schemas.microsoft.com/office/drawing/2014/main" id="{98A3B1F5-B159-4C29-974A-CDB8A432B2A1}"/>
               </a:ext>
             </a:extLst>
           </p:cNvPr>
@@ -20677,7 +20677,7 @@
           <p:cNvPr id="27" name="">
             <a:extLst xmlns:a="http://schemas.openxmlformats.org/drawingml/2006/main">
               <a:ext uri="{FF2B5EF4-FFF2-40B4-BE49-F238E27FC236}">
-                <a16:creationId xmlns:a16="http://schemas.microsoft.com/office/drawing/2014/main" id="{0D344F18-7715-4DF2-82CD-358E814E310E}"/>
+                <a16:creationId xmlns:a16="http://schemas.microsoft.com/office/drawing/2014/main" id="{940C7F15-50CF-4DF7-99ED-387F6256C2E5}"/>
               </a:ext>
             </a:extLst>
           </p:cNvPr>
@@ -20834,7 +20834,7 @@
           <p:cNvPr id="28" name="">
             <a:extLst xmlns:a="http://schemas.openxmlformats.org/drawingml/2006/main">
               <a:ext uri="{FF2B5EF4-FFF2-40B4-BE49-F238E27FC236}">
-                <a16:creationId xmlns:a16="http://schemas.microsoft.com/office/drawing/2014/main" id="{541D8B79-4D4B-405F-B61F-3BE794C37BB1}"/>
+                <a16:creationId xmlns:a16="http://schemas.microsoft.com/office/drawing/2014/main" id="{F92B610F-75CE-4ED2-BFEB-761735A1ED5A}"/>
               </a:ext>
             </a:extLst>
           </p:cNvPr>
@@ -20865,7 +20865,7 @@
           <p:cNvPr id="29" name="">
             <a:extLst xmlns:a="http://schemas.openxmlformats.org/drawingml/2006/main">
               <a:ext uri="{FF2B5EF4-FFF2-40B4-BE49-F238E27FC236}">
-                <a16:creationId xmlns:a16="http://schemas.microsoft.com/office/drawing/2014/main" id="{E6770CB0-ACCF-4335-8BC6-BEB0FDF982AD}"/>
+                <a16:creationId xmlns:a16="http://schemas.microsoft.com/office/drawing/2014/main" id="{BC2C145B-2EE3-4639-990A-BB13D7B4D75B}"/>
               </a:ext>
             </a:extLst>
           </p:cNvPr>
@@ -21022,7 +21022,7 @@
           <p:cNvPr id="30" name="">
             <a:extLst xmlns:a="http://schemas.openxmlformats.org/drawingml/2006/main">
               <a:ext uri="{FF2B5EF4-FFF2-40B4-BE49-F238E27FC236}">
-                <a16:creationId xmlns:a16="http://schemas.microsoft.com/office/drawing/2014/main" id="{AEA88465-61AB-4FE6-8C04-F2B72442D1D9}"/>
+                <a16:creationId xmlns:a16="http://schemas.microsoft.com/office/drawing/2014/main" id="{8A76EF7A-A164-4301-8723-9B66692328BE}"/>
               </a:ext>
             </a:extLst>
           </p:cNvPr>
@@ -21177,7 +21177,7 @@
     </p:spTree>
     <p:extLst>
       <p:ext uri="{BB962C8B-B14F-4D97-AF65-F5344CB8AC3E}">
-        <p14:creationId xmlns:p14="http://schemas.microsoft.com/office/powerpoint/2010/main" val="465317998"/>
+        <p14:creationId xmlns:p14="http://schemas.microsoft.com/office/powerpoint/2010/main" val="518547796"/>
       </p:ext>
     </p:extLst>
   </p:cSld>
@@ -21208,7 +21208,7 @@
           <p:cNvPr id="32" name="">
             <a:extLst xmlns:a="http://schemas.openxmlformats.org/drawingml/2006/main">
               <a:ext uri="{FF2B5EF4-FFF2-40B4-BE49-F238E27FC236}">
-                <a16:creationId xmlns:a16="http://schemas.microsoft.com/office/drawing/2014/main" id="{1DBF90F0-5F9B-4455-BDF4-EB60B9D5BA6F}"/>
+                <a16:creationId xmlns:a16="http://schemas.microsoft.com/office/drawing/2014/main" id="{6D6B326E-86A7-40A3-AB35-44B6F74849E2}"/>
               </a:ext>
             </a:extLst>
           </p:cNvPr>
@@ -21365,7 +21365,7 @@
           <p:cNvPr id="2" name="">
             <a:extLst xmlns:a="http://schemas.openxmlformats.org/drawingml/2006/main">
               <a:ext uri="{FF2B5EF4-FFF2-40B4-BE49-F238E27FC236}">
-                <a16:creationId xmlns:a16="http://schemas.microsoft.com/office/drawing/2014/main" id="{98765F31-2890-4560-B4FC-FF341AF3D535}"/>
+                <a16:creationId xmlns:a16="http://schemas.microsoft.com/office/drawing/2014/main" id="{0050EB53-50B2-4AFE-A67E-845807E4D6D1}"/>
               </a:ext>
             </a:extLst>
           </p:cNvPr>
@@ -21522,7 +21522,7 @@
           <p:cNvPr id="3" name="">
             <a:extLst xmlns:a="http://schemas.openxmlformats.org/drawingml/2006/main">
               <a:ext uri="{FF2B5EF4-FFF2-40B4-BE49-F238E27FC236}">
-                <a16:creationId xmlns:a16="http://schemas.microsoft.com/office/drawing/2014/main" id="{AE4F3DC8-B88B-4BA7-95A2-1105E54BAFF2}"/>
+                <a16:creationId xmlns:a16="http://schemas.microsoft.com/office/drawing/2014/main" id="{C9CA6726-DD4A-4266-B89C-26136065466F}"/>
               </a:ext>
             </a:extLst>
           </p:cNvPr>
@@ -21679,7 +21679,7 @@
           <p:cNvPr id="4" name="">
             <a:extLst xmlns:a="http://schemas.openxmlformats.org/drawingml/2006/main">
               <a:ext uri="{FF2B5EF4-FFF2-40B4-BE49-F238E27FC236}">
-                <a16:creationId xmlns:a16="http://schemas.microsoft.com/office/drawing/2014/main" id="{BF04DFB9-8E4E-41AD-8F37-D40ED0851FBB}"/>
+                <a16:creationId xmlns:a16="http://schemas.microsoft.com/office/drawing/2014/main" id="{FD94EFD1-0BBA-4E7A-9D8F-F087DC2ADE01}"/>
               </a:ext>
             </a:extLst>
           </p:cNvPr>
@@ -21714,7 +21714,7 @@
           <p:cNvPr id="5" name="">
             <a:extLst xmlns:a="http://schemas.openxmlformats.org/drawingml/2006/main">
               <a:ext uri="{FF2B5EF4-FFF2-40B4-BE49-F238E27FC236}">
-                <a16:creationId xmlns:a16="http://schemas.microsoft.com/office/drawing/2014/main" id="{88D69F6D-C0E1-48FF-A000-6911FAED972A}"/>
+                <a16:creationId xmlns:a16="http://schemas.microsoft.com/office/drawing/2014/main" id="{4891E7E9-BE97-4994-86C6-D7B1DCCBA2F6}"/>
               </a:ext>
             </a:extLst>
           </p:cNvPr>
@@ -21871,7 +21871,7 @@
           <p:cNvPr id="6" name="">
             <a:extLst xmlns:a="http://schemas.openxmlformats.org/drawingml/2006/main">
               <a:ext uri="{FF2B5EF4-FFF2-40B4-BE49-F238E27FC236}">
-                <a16:creationId xmlns:a16="http://schemas.microsoft.com/office/drawing/2014/main" id="{DF67C44A-F498-426A-A33E-C0D6CA596302}"/>
+                <a16:creationId xmlns:a16="http://schemas.microsoft.com/office/drawing/2014/main" id="{659704D2-9811-4DF5-A5B6-A90E7A3A73D7}"/>
               </a:ext>
             </a:extLst>
           </p:cNvPr>
@@ -22028,7 +22028,7 @@
           <p:cNvPr id="7" name="">
             <a:extLst xmlns:a="http://schemas.openxmlformats.org/drawingml/2006/main">
               <a:ext uri="{FF2B5EF4-FFF2-40B4-BE49-F238E27FC236}">
-                <a16:creationId xmlns:a16="http://schemas.microsoft.com/office/drawing/2014/main" id="{75599288-83D2-4DF2-8C85-0004179B01C6}"/>
+                <a16:creationId xmlns:a16="http://schemas.microsoft.com/office/drawing/2014/main" id="{B7838C30-06EB-4C27-BDEE-FED0B37C68D1}"/>
               </a:ext>
             </a:extLst>
           </p:cNvPr>
@@ -22063,7 +22063,7 @@
           <p:cNvPr id="8" name="">
             <a:extLst xmlns:a="http://schemas.openxmlformats.org/drawingml/2006/main">
               <a:ext uri="{FF2B5EF4-FFF2-40B4-BE49-F238E27FC236}">
-                <a16:creationId xmlns:a16="http://schemas.microsoft.com/office/drawing/2014/main" id="{525CD367-060E-4862-B9A0-ECEEF497556C}"/>
+                <a16:creationId xmlns:a16="http://schemas.microsoft.com/office/drawing/2014/main" id="{9D62E96B-C480-412A-950D-E9FC9AAFB823}"/>
               </a:ext>
             </a:extLst>
           </p:cNvPr>
@@ -22220,7 +22220,7 @@
           <p:cNvPr id="9" name="">
             <a:extLst xmlns:a="http://schemas.openxmlformats.org/drawingml/2006/main">
               <a:ext uri="{FF2B5EF4-FFF2-40B4-BE49-F238E27FC236}">
-                <a16:creationId xmlns:a16="http://schemas.microsoft.com/office/drawing/2014/main" id="{41C3BBF8-4526-45A6-B09C-0C9C1544D0C9}"/>
+                <a16:creationId xmlns:a16="http://schemas.microsoft.com/office/drawing/2014/main" id="{176A95C2-A43E-4285-9AA2-315BD2F8E79A}"/>
               </a:ext>
             </a:extLst>
           </p:cNvPr>
@@ -22255,7 +22255,7 @@
           <p:cNvPr id="10" name="">
             <a:extLst xmlns:a="http://schemas.openxmlformats.org/drawingml/2006/main">
               <a:ext uri="{FF2B5EF4-FFF2-40B4-BE49-F238E27FC236}">
-                <a16:creationId xmlns:a16="http://schemas.microsoft.com/office/drawing/2014/main" id="{E5441D9E-030B-4E81-8573-B165F24D3F85}"/>
+                <a16:creationId xmlns:a16="http://schemas.microsoft.com/office/drawing/2014/main" id="{7A82AB1A-8A12-4DD7-9AA6-B5EB08085055}"/>
               </a:ext>
             </a:extLst>
           </p:cNvPr>
@@ -22412,7 +22412,7 @@
           <p:cNvPr id="11" name="">
             <a:extLst xmlns:a="http://schemas.openxmlformats.org/drawingml/2006/main">
               <a:ext uri="{FF2B5EF4-FFF2-40B4-BE49-F238E27FC236}">
-                <a16:creationId xmlns:a16="http://schemas.microsoft.com/office/drawing/2014/main" id="{8A177C5C-5E75-4837-BE86-14A2E34AB5B9}"/>
+                <a16:creationId xmlns:a16="http://schemas.microsoft.com/office/drawing/2014/main" id="{7D166F05-AC79-4E8D-B2CF-784764195B8B}"/>
               </a:ext>
             </a:extLst>
           </p:cNvPr>
@@ -22569,7 +22569,7 @@
           <p:cNvPr id="12" name="">
             <a:extLst xmlns:a="http://schemas.openxmlformats.org/drawingml/2006/main">
               <a:ext uri="{FF2B5EF4-FFF2-40B4-BE49-F238E27FC236}">
-                <a16:creationId xmlns:a16="http://schemas.microsoft.com/office/drawing/2014/main" id="{2A68A001-8D65-4ABA-9F24-31CAE3DE97F4}"/>
+                <a16:creationId xmlns:a16="http://schemas.microsoft.com/office/drawing/2014/main" id="{5F245668-235E-4F09-B5C9-20C9B266D874}"/>
               </a:ext>
             </a:extLst>
           </p:cNvPr>
@@ -22604,7 +22604,7 @@
           <p:cNvPr id="13" name="">
             <a:extLst xmlns:a="http://schemas.openxmlformats.org/drawingml/2006/main">
               <a:ext uri="{FF2B5EF4-FFF2-40B4-BE49-F238E27FC236}">
-                <a16:creationId xmlns:a16="http://schemas.microsoft.com/office/drawing/2014/main" id="{46A14DA1-FD73-4FA5-AD87-25DF10CD5780}"/>
+                <a16:creationId xmlns:a16="http://schemas.microsoft.com/office/drawing/2014/main" id="{C2B6A958-2554-4D92-993C-53FA8BEF8048}"/>
               </a:ext>
             </a:extLst>
           </p:cNvPr>
@@ -22761,7 +22761,7 @@
           <p:cNvPr id="14" name="">
             <a:extLst xmlns:a="http://schemas.openxmlformats.org/drawingml/2006/main">
               <a:ext uri="{FF2B5EF4-FFF2-40B4-BE49-F238E27FC236}">
-                <a16:creationId xmlns:a16="http://schemas.microsoft.com/office/drawing/2014/main" id="{ACC9A5EA-03B2-4054-B44C-28A496A4836C}"/>
+                <a16:creationId xmlns:a16="http://schemas.microsoft.com/office/drawing/2014/main" id="{BC9791C3-E39C-47C7-8A8A-C4C3F08F1A05}"/>
               </a:ext>
             </a:extLst>
           </p:cNvPr>
@@ -22796,7 +22796,7 @@
           <p:cNvPr id="15" name="">
             <a:extLst xmlns:a="http://schemas.openxmlformats.org/drawingml/2006/main">
               <a:ext uri="{FF2B5EF4-FFF2-40B4-BE49-F238E27FC236}">
-                <a16:creationId xmlns:a16="http://schemas.microsoft.com/office/drawing/2014/main" id="{8506CF3A-692A-416B-8BAA-0C0F23D710E4}"/>
+                <a16:creationId xmlns:a16="http://schemas.microsoft.com/office/drawing/2014/main" id="{26B05A4D-2D57-407D-8B51-C20D8019F027}"/>
               </a:ext>
             </a:extLst>
           </p:cNvPr>
@@ -22953,7 +22953,7 @@
           <p:cNvPr id="16" name="">
             <a:extLst xmlns:a="http://schemas.openxmlformats.org/drawingml/2006/main">
               <a:ext uri="{FF2B5EF4-FFF2-40B4-BE49-F238E27FC236}">
-                <a16:creationId xmlns:a16="http://schemas.microsoft.com/office/drawing/2014/main" id="{49FCC835-06BC-495E-B9DB-1F05B8EAA9EB}"/>
+                <a16:creationId xmlns:a16="http://schemas.microsoft.com/office/drawing/2014/main" id="{B5490CD9-06BF-47E5-ACE4-64FAD44B2786}"/>
               </a:ext>
             </a:extLst>
           </p:cNvPr>
@@ -23110,7 +23110,7 @@
           <p:cNvPr id="17" name="">
             <a:extLst xmlns:a="http://schemas.openxmlformats.org/drawingml/2006/main">
               <a:ext uri="{FF2B5EF4-FFF2-40B4-BE49-F238E27FC236}">
-                <a16:creationId xmlns:a16="http://schemas.microsoft.com/office/drawing/2014/main" id="{725876C5-2CA2-441C-9533-D4BDB1138C1B}"/>
+                <a16:creationId xmlns:a16="http://schemas.microsoft.com/office/drawing/2014/main" id="{0FD7CC2E-ACC3-4ADB-947B-5BCB33D10202}"/>
               </a:ext>
             </a:extLst>
           </p:cNvPr>
@@ -23145,7 +23145,7 @@
           <p:cNvPr id="18" name="">
             <a:extLst xmlns:a="http://schemas.openxmlformats.org/drawingml/2006/main">
               <a:ext uri="{FF2B5EF4-FFF2-40B4-BE49-F238E27FC236}">
-                <a16:creationId xmlns:a16="http://schemas.microsoft.com/office/drawing/2014/main" id="{F0954E45-15E3-4D48-AEC9-8E1101D7931F}"/>
+                <a16:creationId xmlns:a16="http://schemas.microsoft.com/office/drawing/2014/main" id="{4155AF4D-C291-40B8-8701-698D8395596A}"/>
               </a:ext>
             </a:extLst>
           </p:cNvPr>
@@ -23302,7 +23302,7 @@
           <p:cNvPr id="19" name="">
             <a:extLst xmlns:a="http://schemas.openxmlformats.org/drawingml/2006/main">
               <a:ext uri="{FF2B5EF4-FFF2-40B4-BE49-F238E27FC236}">
-                <a16:creationId xmlns:a16="http://schemas.microsoft.com/office/drawing/2014/main" id="{9919C45B-B3DF-4557-A02F-CC88A1A323EC}"/>
+                <a16:creationId xmlns:a16="http://schemas.microsoft.com/office/drawing/2014/main" id="{346A9C04-0D25-4E8E-873F-8C5CE180B1D9}"/>
               </a:ext>
             </a:extLst>
           </p:cNvPr>
@@ -23337,7 +23337,7 @@
           <p:cNvPr id="20" name="">
             <a:extLst xmlns:a="http://schemas.openxmlformats.org/drawingml/2006/main">
               <a:ext uri="{FF2B5EF4-FFF2-40B4-BE49-F238E27FC236}">
-                <a16:creationId xmlns:a16="http://schemas.microsoft.com/office/drawing/2014/main" id="{554EC101-A2AB-4D30-8242-14371C0F7DA4}"/>
+                <a16:creationId xmlns:a16="http://schemas.microsoft.com/office/drawing/2014/main" id="{A5D34880-691D-44BB-953A-8920AC434FFC}"/>
               </a:ext>
             </a:extLst>
           </p:cNvPr>
@@ -23494,7 +23494,7 @@
           <p:cNvPr id="21" name="">
             <a:extLst xmlns:a="http://schemas.openxmlformats.org/drawingml/2006/main">
               <a:ext uri="{FF2B5EF4-FFF2-40B4-BE49-F238E27FC236}">
-                <a16:creationId xmlns:a16="http://schemas.microsoft.com/office/drawing/2014/main" id="{031C34B5-FDD1-4838-9E23-BEA07D4E93AF}"/>
+                <a16:creationId xmlns:a16="http://schemas.microsoft.com/office/drawing/2014/main" id="{CB9CAD84-07B4-405B-B982-1AF2A2B7BF82}"/>
               </a:ext>
             </a:extLst>
           </p:cNvPr>
@@ -23651,7 +23651,7 @@
           <p:cNvPr id="22" name="">
             <a:extLst xmlns:a="http://schemas.openxmlformats.org/drawingml/2006/main">
               <a:ext uri="{FF2B5EF4-FFF2-40B4-BE49-F238E27FC236}">
-                <a16:creationId xmlns:a16="http://schemas.microsoft.com/office/drawing/2014/main" id="{8F5A573F-7F9E-4A6E-9851-13733EF6141E}"/>
+                <a16:creationId xmlns:a16="http://schemas.microsoft.com/office/drawing/2014/main" id="{5CB4C0C0-6062-4C5B-8BF9-E7C64DBA4112}"/>
               </a:ext>
             </a:extLst>
           </p:cNvPr>
@@ -23686,7 +23686,7 @@
           <p:cNvPr id="23" name="">
             <a:extLst xmlns:a="http://schemas.openxmlformats.org/drawingml/2006/main">
               <a:ext uri="{FF2B5EF4-FFF2-40B4-BE49-F238E27FC236}">
-                <a16:creationId xmlns:a16="http://schemas.microsoft.com/office/drawing/2014/main" id="{84FBBBC5-6D93-45D5-A9FE-F82BEFFC9060}"/>
+                <a16:creationId xmlns:a16="http://schemas.microsoft.com/office/drawing/2014/main" id="{AE2F01B0-F02A-4318-9938-A873B33E17F3}"/>
               </a:ext>
             </a:extLst>
           </p:cNvPr>
@@ -23843,7 +23843,7 @@
           <p:cNvPr id="24" name="">
             <a:extLst xmlns:a="http://schemas.openxmlformats.org/drawingml/2006/main">
               <a:ext uri="{FF2B5EF4-FFF2-40B4-BE49-F238E27FC236}">
-                <a16:creationId xmlns:a16="http://schemas.microsoft.com/office/drawing/2014/main" id="{3B655BE9-23D4-48C6-9776-D93337147710}"/>
+                <a16:creationId xmlns:a16="http://schemas.microsoft.com/office/drawing/2014/main" id="{72B2B409-7FEE-4450-99EC-F098C9AACA74}"/>
               </a:ext>
             </a:extLst>
           </p:cNvPr>
@@ -23878,7 +23878,7 @@
           <p:cNvPr id="25" name="">
             <a:extLst xmlns:a="http://schemas.openxmlformats.org/drawingml/2006/main">
               <a:ext uri="{FF2B5EF4-FFF2-40B4-BE49-F238E27FC236}">
-                <a16:creationId xmlns:a16="http://schemas.microsoft.com/office/drawing/2014/main" id="{A1649AF8-43F5-4DFE-BF28-92DA5C7C0C01}"/>
+                <a16:creationId xmlns:a16="http://schemas.microsoft.com/office/drawing/2014/main" id="{2EF15DC8-F9B6-455E-866A-D43250AE5FEF}"/>
               </a:ext>
             </a:extLst>
           </p:cNvPr>
@@ -24035,7 +24035,7 @@
           <p:cNvPr id="26" name="">
             <a:extLst xmlns:a="http://schemas.openxmlformats.org/drawingml/2006/main">
               <a:ext uri="{FF2B5EF4-FFF2-40B4-BE49-F238E27FC236}">
-                <a16:creationId xmlns:a16="http://schemas.microsoft.com/office/drawing/2014/main" id="{E8A71F4E-B0DE-43E2-940C-F532C8CA08A4}"/>
+                <a16:creationId xmlns:a16="http://schemas.microsoft.com/office/drawing/2014/main" id="{E2EB0AFE-7FD8-4869-BBCB-0ACDF8133CE7}"/>
               </a:ext>
             </a:extLst>
           </p:cNvPr>
@@ -24192,7 +24192,7 @@
           <p:cNvPr id="27" name="">
             <a:extLst xmlns:a="http://schemas.openxmlformats.org/drawingml/2006/main">
               <a:ext uri="{FF2B5EF4-FFF2-40B4-BE49-F238E27FC236}">
-                <a16:creationId xmlns:a16="http://schemas.microsoft.com/office/drawing/2014/main" id="{4EA46AB9-CF67-4ECD-9816-DA67754E286D}"/>
+                <a16:creationId xmlns:a16="http://schemas.microsoft.com/office/drawing/2014/main" id="{6F25AF20-C73C-47A6-85FB-E2B1F55C4588}"/>
               </a:ext>
             </a:extLst>
           </p:cNvPr>
@@ -24227,7 +24227,7 @@
           <p:cNvPr id="28" name="">
             <a:extLst xmlns:a="http://schemas.openxmlformats.org/drawingml/2006/main">
               <a:ext uri="{FF2B5EF4-FFF2-40B4-BE49-F238E27FC236}">
-                <a16:creationId xmlns:a16="http://schemas.microsoft.com/office/drawing/2014/main" id="{7BBA364B-7833-4AD8-85D8-351DBC51B7C8}"/>
+                <a16:creationId xmlns:a16="http://schemas.microsoft.com/office/drawing/2014/main" id="{948BFE70-65FB-488F-8DC6-181E04643DB8}"/>
               </a:ext>
             </a:extLst>
           </p:cNvPr>
@@ -24384,7 +24384,7 @@
           <p:cNvPr id="29" name="">
             <a:extLst xmlns:a="http://schemas.openxmlformats.org/drawingml/2006/main">
               <a:ext uri="{FF2B5EF4-FFF2-40B4-BE49-F238E27FC236}">
-                <a16:creationId xmlns:a16="http://schemas.microsoft.com/office/drawing/2014/main" id="{32ACE2DE-EA51-4683-8DB2-F92028920F84}"/>
+                <a16:creationId xmlns:a16="http://schemas.microsoft.com/office/drawing/2014/main" id="{76B71438-EC59-450E-A519-C083262914F7}"/>
               </a:ext>
             </a:extLst>
           </p:cNvPr>
@@ -24415,7 +24415,7 @@
           <p:cNvPr id="30" name="">
             <a:extLst xmlns:a="http://schemas.openxmlformats.org/drawingml/2006/main">
               <a:ext uri="{FF2B5EF4-FFF2-40B4-BE49-F238E27FC236}">
-                <a16:creationId xmlns:a16="http://schemas.microsoft.com/office/drawing/2014/main" id="{C1C88749-EE60-45F0-BEC7-2362E66CBBAF}"/>
+                <a16:creationId xmlns:a16="http://schemas.microsoft.com/office/drawing/2014/main" id="{E991D058-B700-420C-9CCF-66F0ED84F8DA}"/>
               </a:ext>
             </a:extLst>
           </p:cNvPr>
@@ -24572,7 +24572,7 @@
           <p:cNvPr id="31" name="">
             <a:extLst xmlns:a="http://schemas.openxmlformats.org/drawingml/2006/main">
               <a:ext uri="{FF2B5EF4-FFF2-40B4-BE49-F238E27FC236}">
-                <a16:creationId xmlns:a16="http://schemas.microsoft.com/office/drawing/2014/main" id="{09E30F88-5A6C-4C8D-9305-CD2449261F3B}"/>
+                <a16:creationId xmlns:a16="http://schemas.microsoft.com/office/drawing/2014/main" id="{485BB4A4-BC65-454D-B731-AD3B82F05FDC}"/>
               </a:ext>
             </a:extLst>
           </p:cNvPr>
@@ -24727,7 +24727,7 @@
     </p:spTree>
     <p:extLst>
       <p:ext uri="{BB962C8B-B14F-4D97-AF65-F5344CB8AC3E}">
-        <p14:creationId xmlns:p14="http://schemas.microsoft.com/office/powerpoint/2010/main" val="1503385282"/>
+        <p14:creationId xmlns:p14="http://schemas.microsoft.com/office/powerpoint/2010/main" val="283142137"/>
       </p:ext>
     </p:extLst>
   </p:cSld>
@@ -24758,7 +24758,7 @@
           <p:cNvPr id="25" name="">
             <a:extLst xmlns:a="http://schemas.openxmlformats.org/drawingml/2006/main">
               <a:ext uri="{FF2B5EF4-FFF2-40B4-BE49-F238E27FC236}">
-                <a16:creationId xmlns:a16="http://schemas.microsoft.com/office/drawing/2014/main" id="{CA29E44D-1EF7-4DF3-A989-4538F5F5FC4C}"/>
+                <a16:creationId xmlns:a16="http://schemas.microsoft.com/office/drawing/2014/main" id="{7717E067-D8E0-4437-BE70-EB4315695DFA}"/>
               </a:ext>
             </a:extLst>
           </p:cNvPr>
@@ -24915,7 +24915,7 @@
           <p:cNvPr id="2" name="">
             <a:extLst xmlns:a="http://schemas.openxmlformats.org/drawingml/2006/main">
               <a:ext uri="{FF2B5EF4-FFF2-40B4-BE49-F238E27FC236}">
-                <a16:creationId xmlns:a16="http://schemas.microsoft.com/office/drawing/2014/main" id="{6D812700-123B-4A3D-96CB-F35E5E323AC4}"/>
+                <a16:creationId xmlns:a16="http://schemas.microsoft.com/office/drawing/2014/main" id="{3E700549-AF53-465B-A77B-88242FFCE545}"/>
               </a:ext>
             </a:extLst>
           </p:cNvPr>
@@ -25072,7 +25072,7 @@
           <p:cNvPr id="3" name="">
             <a:extLst xmlns:a="http://schemas.openxmlformats.org/drawingml/2006/main">
               <a:ext uri="{FF2B5EF4-FFF2-40B4-BE49-F238E27FC236}">
-                <a16:creationId xmlns:a16="http://schemas.microsoft.com/office/drawing/2014/main" id="{43231870-12CB-4F96-948E-A9D8F03FE5FC}"/>
+                <a16:creationId xmlns:a16="http://schemas.microsoft.com/office/drawing/2014/main" id="{6FB15141-1822-44D6-94DC-5F82FBA858D1}"/>
               </a:ext>
             </a:extLst>
           </p:cNvPr>
@@ -25229,7 +25229,7 @@
           <p:cNvPr id="4" name="">
             <a:extLst xmlns:a="http://schemas.openxmlformats.org/drawingml/2006/main">
               <a:ext uri="{FF2B5EF4-FFF2-40B4-BE49-F238E27FC236}">
-                <a16:creationId xmlns:a16="http://schemas.microsoft.com/office/drawing/2014/main" id="{554C9FA2-3074-4747-BDAE-A13B1BD2B3F7}"/>
+                <a16:creationId xmlns:a16="http://schemas.microsoft.com/office/drawing/2014/main" id="{FF66CB2E-0542-413F-8075-437DB259F755}"/>
               </a:ext>
             </a:extLst>
           </p:cNvPr>
@@ -25264,7 +25264,7 @@
           <p:cNvPr id="5" name="">
             <a:extLst xmlns:a="http://schemas.openxmlformats.org/drawingml/2006/main">
               <a:ext uri="{FF2B5EF4-FFF2-40B4-BE49-F238E27FC236}">
-                <a16:creationId xmlns:a16="http://schemas.microsoft.com/office/drawing/2014/main" id="{27FEFCAF-688B-47A2-8449-9C16D3E41B5F}"/>
+                <a16:creationId xmlns:a16="http://schemas.microsoft.com/office/drawing/2014/main" id="{87C16B86-A6EC-4670-9946-75D574B147A4}"/>
               </a:ext>
             </a:extLst>
           </p:cNvPr>
@@ -25421,7 +25421,7 @@
           <p:cNvPr id="6" name="">
             <a:extLst xmlns:a="http://schemas.openxmlformats.org/drawingml/2006/main">
               <a:ext uri="{FF2B5EF4-FFF2-40B4-BE49-F238E27FC236}">
-                <a16:creationId xmlns:a16="http://schemas.microsoft.com/office/drawing/2014/main" id="{37246635-3235-4092-8F51-D90213350377}"/>
+                <a16:creationId xmlns:a16="http://schemas.microsoft.com/office/drawing/2014/main" id="{D3211956-D509-4030-A84F-B736983FA402}"/>
               </a:ext>
             </a:extLst>
           </p:cNvPr>
@@ -25578,7 +25578,7 @@
           <p:cNvPr id="7" name="">
             <a:extLst xmlns:a="http://schemas.openxmlformats.org/drawingml/2006/main">
               <a:ext uri="{FF2B5EF4-FFF2-40B4-BE49-F238E27FC236}">
-                <a16:creationId xmlns:a16="http://schemas.microsoft.com/office/drawing/2014/main" id="{D9037128-F09F-44A1-A270-7EB891FD146E}"/>
+                <a16:creationId xmlns:a16="http://schemas.microsoft.com/office/drawing/2014/main" id="{18AEE5E6-9A6A-40FA-B890-F0713D2B9905}"/>
               </a:ext>
             </a:extLst>
           </p:cNvPr>
@@ -25735,7 +25735,7 @@
           <p:cNvPr id="8" name="">
             <a:extLst xmlns:a="http://schemas.openxmlformats.org/drawingml/2006/main">
               <a:ext uri="{FF2B5EF4-FFF2-40B4-BE49-F238E27FC236}">
-                <a16:creationId xmlns:a16="http://schemas.microsoft.com/office/drawing/2014/main" id="{8084D1C3-B267-49E0-A44B-91BC87A129DC}"/>
+                <a16:creationId xmlns:a16="http://schemas.microsoft.com/office/drawing/2014/main" id="{B32941B9-3931-482D-A104-59BB962AE4E8}"/>
               </a:ext>
             </a:extLst>
           </p:cNvPr>
@@ -25892,7 +25892,7 @@
           <p:cNvPr id="9" name="">
             <a:extLst xmlns:a="http://schemas.openxmlformats.org/drawingml/2006/main">
               <a:ext uri="{FF2B5EF4-FFF2-40B4-BE49-F238E27FC236}">
-                <a16:creationId xmlns:a16="http://schemas.microsoft.com/office/drawing/2014/main" id="{B6AA8512-621A-4A43-A768-AA8FA25F02B2}"/>
+                <a16:creationId xmlns:a16="http://schemas.microsoft.com/office/drawing/2014/main" id="{5CC309BF-1224-4D89-949A-4120B2EE3838}"/>
               </a:ext>
             </a:extLst>
           </p:cNvPr>
@@ -25927,7 +25927,7 @@
           <p:cNvPr id="10" name="">
             <a:extLst xmlns:a="http://schemas.openxmlformats.org/drawingml/2006/main">
               <a:ext uri="{FF2B5EF4-FFF2-40B4-BE49-F238E27FC236}">
-                <a16:creationId xmlns:a16="http://schemas.microsoft.com/office/drawing/2014/main" id="{16528F8D-1155-4D5D-A924-A78D6DA4191D}"/>
+                <a16:creationId xmlns:a16="http://schemas.microsoft.com/office/drawing/2014/main" id="{46CA505A-C9B8-4AC2-9839-660B04CF11E7}"/>
               </a:ext>
             </a:extLst>
           </p:cNvPr>
@@ -26084,7 +26084,7 @@
           <p:cNvPr id="11" name="">
             <a:extLst xmlns:a="http://schemas.openxmlformats.org/drawingml/2006/main">
               <a:ext uri="{FF2B5EF4-FFF2-40B4-BE49-F238E27FC236}">
-                <a16:creationId xmlns:a16="http://schemas.microsoft.com/office/drawing/2014/main" id="{90B84B61-A852-4D9D-86C4-8552F6A8A02F}"/>
+                <a16:creationId xmlns:a16="http://schemas.microsoft.com/office/drawing/2014/main" id="{5A69B679-E1DE-4140-9485-6602DCE77BAB}"/>
               </a:ext>
             </a:extLst>
           </p:cNvPr>
@@ -26119,7 +26119,7 @@
           <p:cNvPr id="12" name="">
             <a:extLst xmlns:a="http://schemas.openxmlformats.org/drawingml/2006/main">
               <a:ext uri="{FF2B5EF4-FFF2-40B4-BE49-F238E27FC236}">
-                <a16:creationId xmlns:a16="http://schemas.microsoft.com/office/drawing/2014/main" id="{EC5C4D8C-E1FC-49FC-A284-1AFB75BEC50A}"/>
+                <a16:creationId xmlns:a16="http://schemas.microsoft.com/office/drawing/2014/main" id="{65BF27FA-3FCC-4308-85A3-429FB29CE143}"/>
               </a:ext>
             </a:extLst>
           </p:cNvPr>
@@ -26148,7 +26148,7 @@
             <a:defPPr algn="l">
               <a:defRPr sz="1275" b="0">
                 <a:solidFill>
-                  <a:srgbClr val="FFBF69"/>
+                  <a:srgbClr val="57D49B"/>
                 </a:solidFill>
                 <a:latin typeface="Aptos"/>
                 <a:ea typeface="Aptos"/>
@@ -26158,7 +26158,7 @@
             <a:lvl1pPr algn="l">
               <a:defRPr sz="1275" b="0">
                 <a:solidFill>
-                  <a:srgbClr val="FFBF69"/>
+                  <a:srgbClr val="57D49B"/>
                 </a:solidFill>
                 <a:latin typeface="Aptos"/>
                 <a:ea typeface="Aptos"/>
@@ -26168,7 +26168,7 @@
             <a:lvl2pPr algn="l">
               <a:defRPr sz="1275" b="0">
                 <a:solidFill>
-                  <a:srgbClr val="FFBF69"/>
+                  <a:srgbClr val="57D49B"/>
                 </a:solidFill>
                 <a:latin typeface="Aptos"/>
                 <a:ea typeface="Aptos"/>
@@ -26178,7 +26178,7 @@
             <a:lvl3pPr algn="l">
               <a:defRPr sz="1275" b="0">
                 <a:solidFill>
-                  <a:srgbClr val="FFBF69"/>
+                  <a:srgbClr val="57D49B"/>
                 </a:solidFill>
                 <a:latin typeface="Aptos"/>
                 <a:ea typeface="Aptos"/>
@@ -26188,7 +26188,7 @@
             <a:lvl4pPr algn="l">
               <a:defRPr sz="1275" b="0">
                 <a:solidFill>
-                  <a:srgbClr val="FFBF69"/>
+                  <a:srgbClr val="57D49B"/>
                 </a:solidFill>
                 <a:latin typeface="Aptos"/>
                 <a:ea typeface="Aptos"/>
@@ -26198,7 +26198,7 @@
             <a:lvl5pPr algn="l">
               <a:defRPr sz="1275" b="0">
                 <a:solidFill>
-                  <a:srgbClr val="FFBF69"/>
+                  <a:srgbClr val="57D49B"/>
                 </a:solidFill>
                 <a:latin typeface="Aptos"/>
                 <a:ea typeface="Aptos"/>
@@ -26208,7 +26208,7 @@
             <a:lvl6pPr algn="l">
               <a:defRPr sz="1275" b="0">
                 <a:solidFill>
-                  <a:srgbClr val="FFBF69"/>
+                  <a:srgbClr val="57D49B"/>
                 </a:solidFill>
                 <a:latin typeface="Aptos"/>
                 <a:ea typeface="Aptos"/>
@@ -26218,7 +26218,7 @@
             <a:lvl7pPr algn="l">
               <a:defRPr sz="1275" b="0">
                 <a:solidFill>
-                  <a:srgbClr val="FFBF69"/>
+                  <a:srgbClr val="57D49B"/>
                 </a:solidFill>
                 <a:latin typeface="Aptos"/>
                 <a:ea typeface="Aptos"/>
@@ -26228,7 +26228,7 @@
             <a:lvl8pPr algn="l">
               <a:defRPr sz="1275" b="0">
                 <a:solidFill>
-                  <a:srgbClr val="FFBF69"/>
+                  <a:srgbClr val="57D49B"/>
                 </a:solidFill>
                 <a:latin typeface="Aptos"/>
                 <a:ea typeface="Aptos"/>
@@ -26238,7 +26238,7 @@
             <a:lvl9pPr algn="l">
               <a:defRPr sz="1275" b="0">
                 <a:solidFill>
-                  <a:srgbClr val="FFBF69"/>
+                  <a:srgbClr val="57D49B"/>
                 </a:solidFill>
                 <a:latin typeface="Aptos"/>
                 <a:ea typeface="Aptos"/>
@@ -26250,7 +26250,7 @@
             <a:pPr algn="l">
               <a:defRPr sz="1275" b="0">
                 <a:solidFill>
-                  <a:srgbClr val="FFBF69"/>
+                  <a:srgbClr val="57D49B"/>
                 </a:solidFill>
                 <a:latin typeface="Aptos"/>
                 <a:ea typeface="Aptos"/>
@@ -26260,7 +26260,7 @@
             <a:r>
               <a:rPr sz="1275" b="0">
                 <a:solidFill>
-                  <a:srgbClr val="FFBF69"/>
+                  <a:srgbClr val="57D49B"/>
                 </a:solidFill>
                 <a:latin typeface="Aptos"/>
                 <a:ea typeface="Aptos"/>
@@ -26276,7 +26276,7 @@
           <p:cNvPr id="13" name="">
             <a:extLst xmlns:a="http://schemas.openxmlformats.org/drawingml/2006/main">
               <a:ext uri="{FF2B5EF4-FFF2-40B4-BE49-F238E27FC236}">
-                <a16:creationId xmlns:a16="http://schemas.microsoft.com/office/drawing/2014/main" id="{EDEAE94D-04E6-4694-AC34-3AE5F2621A27}"/>
+                <a16:creationId xmlns:a16="http://schemas.microsoft.com/office/drawing/2014/main" id="{1CF5CD3E-D1C6-466B-9DEC-27FB5EE04917}"/>
               </a:ext>
             </a:extLst>
           </p:cNvPr>
@@ -26311,7 +26311,7 @@
           <p:cNvPr id="14" name="">
             <a:extLst xmlns:a="http://schemas.openxmlformats.org/drawingml/2006/main">
               <a:ext uri="{FF2B5EF4-FFF2-40B4-BE49-F238E27FC236}">
-                <a16:creationId xmlns:a16="http://schemas.microsoft.com/office/drawing/2014/main" id="{3604CE4F-70E8-461D-A85F-95709C8CE1AC}"/>
+                <a16:creationId xmlns:a16="http://schemas.microsoft.com/office/drawing/2014/main" id="{43F8CEAE-2CC7-4095-AAEB-5D6373C92018}"/>
               </a:ext>
             </a:extLst>
           </p:cNvPr>
@@ -26468,7 +26468,7 @@
           <p:cNvPr id="15" name="">
             <a:extLst xmlns:a="http://schemas.openxmlformats.org/drawingml/2006/main">
               <a:ext uri="{FF2B5EF4-FFF2-40B4-BE49-F238E27FC236}">
-                <a16:creationId xmlns:a16="http://schemas.microsoft.com/office/drawing/2014/main" id="{131A1142-68A7-4E1D-BA8F-A466A6E3C3EA}"/>
+                <a16:creationId xmlns:a16="http://schemas.microsoft.com/office/drawing/2014/main" id="{6A114BD8-0C38-4332-BDCC-8FA56A3187E5}"/>
               </a:ext>
             </a:extLst>
           </p:cNvPr>
@@ -26503,7 +26503,7 @@
           <p:cNvPr id="16" name="">
             <a:extLst xmlns:a="http://schemas.openxmlformats.org/drawingml/2006/main">
               <a:ext uri="{FF2B5EF4-FFF2-40B4-BE49-F238E27FC236}">
-                <a16:creationId xmlns:a16="http://schemas.microsoft.com/office/drawing/2014/main" id="{432FC8CD-AF2C-42A9-AB01-8BBC5F173688}"/>
+                <a16:creationId xmlns:a16="http://schemas.microsoft.com/office/drawing/2014/main" id="{04AC0A94-F40D-4AA4-9265-F8A1209F5AF9}"/>
               </a:ext>
             </a:extLst>
           </p:cNvPr>
@@ -26660,7 +26660,7 @@
           <p:cNvPr id="17" name="">
             <a:extLst xmlns:a="http://schemas.openxmlformats.org/drawingml/2006/main">
               <a:ext uri="{FF2B5EF4-FFF2-40B4-BE49-F238E27FC236}">
-                <a16:creationId xmlns:a16="http://schemas.microsoft.com/office/drawing/2014/main" id="{0EFF4B7C-0A5A-46D7-AE84-A10CBA97B261}"/>
+                <a16:creationId xmlns:a16="http://schemas.microsoft.com/office/drawing/2014/main" id="{5297FE9C-1D01-406D-9840-1817DE022F30}"/>
               </a:ext>
             </a:extLst>
           </p:cNvPr>
@@ -26695,7 +26695,7 @@
           <p:cNvPr id="18" name="">
             <a:extLst xmlns:a="http://schemas.openxmlformats.org/drawingml/2006/main">
               <a:ext uri="{FF2B5EF4-FFF2-40B4-BE49-F238E27FC236}">
-                <a16:creationId xmlns:a16="http://schemas.microsoft.com/office/drawing/2014/main" id="{6C6613D9-45DA-4462-AE6F-A1FA8FD79842}"/>
+                <a16:creationId xmlns:a16="http://schemas.microsoft.com/office/drawing/2014/main" id="{EBB814AA-33AE-4DFB-88BF-4E9A46A0CB59}"/>
               </a:ext>
             </a:extLst>
           </p:cNvPr>
@@ -26852,7 +26852,7 @@
           <p:cNvPr id="19" name="">
             <a:extLst xmlns:a="http://schemas.openxmlformats.org/drawingml/2006/main">
               <a:ext uri="{FF2B5EF4-FFF2-40B4-BE49-F238E27FC236}">
-                <a16:creationId xmlns:a16="http://schemas.microsoft.com/office/drawing/2014/main" id="{3F73907C-D2F6-4EFB-8330-4F38866C6F8F}"/>
+                <a16:creationId xmlns:a16="http://schemas.microsoft.com/office/drawing/2014/main" id="{59B33394-D4DE-4301-B639-57A048A64F35}"/>
               </a:ext>
             </a:extLst>
           </p:cNvPr>
@@ -27009,7 +27009,7 @@
           <p:cNvPr id="20" name="">
             <a:extLst xmlns:a="http://schemas.openxmlformats.org/drawingml/2006/main">
               <a:ext uri="{FF2B5EF4-FFF2-40B4-BE49-F238E27FC236}">
-                <a16:creationId xmlns:a16="http://schemas.microsoft.com/office/drawing/2014/main" id="{118BC639-1689-48EA-B399-0D82E1F34511}"/>
+                <a16:creationId xmlns:a16="http://schemas.microsoft.com/office/drawing/2014/main" id="{BA36F8B6-8EFC-49D2-85FD-96ADF66F6F01}"/>
               </a:ext>
             </a:extLst>
           </p:cNvPr>
@@ -27029,11 +27029,11 @@
             </a:avLst>
           </a:prstGeom>
           <a:solidFill xmlns:a="http://schemas.openxmlformats.org/drawingml/2006/main">
-            <a:srgbClr val="FFBF69"/>
+            <a:srgbClr val="57D49B"/>
           </a:solidFill>
           <a:ln xmlns:a="http://schemas.openxmlformats.org/drawingml/2006/main" w="9525">
             <a:solidFill>
-              <a:srgbClr val="FFBF69"/>
+              <a:srgbClr val="57D49B"/>
             </a:solidFill>
             <a:prstDash val="solid"/>
           </a:ln>
@@ -27044,7 +27044,7 @@
           <p:cNvPr id="21" name="">
             <a:extLst xmlns:a="http://schemas.openxmlformats.org/drawingml/2006/main">
               <a:ext uri="{FF2B5EF4-FFF2-40B4-BE49-F238E27FC236}">
-                <a16:creationId xmlns:a16="http://schemas.microsoft.com/office/drawing/2014/main" id="{9CA9E2EF-057B-4846-9655-2145C414762F}"/>
+                <a16:creationId xmlns:a16="http://schemas.microsoft.com/office/drawing/2014/main" id="{33CE0FBD-BB57-4D10-9C2A-E529EA697F07}"/>
               </a:ext>
             </a:extLst>
           </p:cNvPr>
@@ -27191,7 +27191,7 @@
                 <a:ea typeface="Aptos"/>
                 <a:cs typeface="Aptos"/>
               </a:rPr>
-              <a:t>PUBLICATION PENDING</a:t>
+              <a:t>PUBLIC &amp; VERIFIED</a:t>
             </a:r>
           </a:p>
         </p:txBody>
@@ -27201,7 +27201,7 @@
           <p:cNvPr id="22" name="">
             <a:extLst xmlns:a="http://schemas.openxmlformats.org/drawingml/2006/main">
               <a:ext uri="{FF2B5EF4-FFF2-40B4-BE49-F238E27FC236}">
-                <a16:creationId xmlns:a16="http://schemas.microsoft.com/office/drawing/2014/main" id="{47198A12-0509-46E2-B89A-27FFD0426F0F}"/>
+                <a16:creationId xmlns:a16="http://schemas.microsoft.com/office/drawing/2014/main" id="{F4A6B3A6-0220-4F2C-8C3A-243B1C767164}"/>
               </a:ext>
             </a:extLst>
           </p:cNvPr>
@@ -27232,7 +27232,7 @@
           <p:cNvPr id="23" name="">
             <a:extLst xmlns:a="http://schemas.openxmlformats.org/drawingml/2006/main">
               <a:ext uri="{FF2B5EF4-FFF2-40B4-BE49-F238E27FC236}">
-                <a16:creationId xmlns:a16="http://schemas.microsoft.com/office/drawing/2014/main" id="{CF38B89B-3731-4083-BE80-1B99DC1F297F}"/>
+                <a16:creationId xmlns:a16="http://schemas.microsoft.com/office/drawing/2014/main" id="{F755234D-C2F6-434E-846F-A13378360C55}"/>
               </a:ext>
             </a:extLst>
           </p:cNvPr>
@@ -27389,7 +27389,7 @@
           <p:cNvPr id="24" name="">
             <a:extLst xmlns:a="http://schemas.openxmlformats.org/drawingml/2006/main">
               <a:ext uri="{FF2B5EF4-FFF2-40B4-BE49-F238E27FC236}">
-                <a16:creationId xmlns:a16="http://schemas.microsoft.com/office/drawing/2014/main" id="{8DE3F59A-AF24-4AE9-829C-C75917B21A55}"/>
+                <a16:creationId xmlns:a16="http://schemas.microsoft.com/office/drawing/2014/main" id="{107A0E09-7C67-4776-9C06-E73FE532D5FA}"/>
               </a:ext>
             </a:extLst>
           </p:cNvPr>
@@ -27544,7 +27544,7 @@
     </p:spTree>
     <p:extLst>
       <p:ext uri="{BB962C8B-B14F-4D97-AF65-F5344CB8AC3E}">
-        <p14:creationId xmlns:p14="http://schemas.microsoft.com/office/powerpoint/2010/main" val="612910029"/>
+        <p14:creationId xmlns:p14="http://schemas.microsoft.com/office/powerpoint/2010/main" val="1189937809"/>
       </p:ext>
     </p:extLst>
   </p:cSld>

</xml_diff>

<commit_message>
Finalize verified Zetaris and Meterless submission evidence
</commit_message>
<xml_diff>
--- a/artifacts/VELQIRIS_Open_Agent_2026_Pitch_Deck.pptx
+++ b/artifacts/VELQIRIS_Open_Agent_2026_Pitch_Deck.pptx
@@ -2,19 +2,19 @@
 <file path=ppt/presentation.xml><?xml version="1.0" encoding="utf-8"?>
 <p:presentation xmlns:p="http://schemas.openxmlformats.org/presentationml/2006/main">
   <p:sldMasterIdLst>
-    <p:sldMasterId xmlns:r="http://schemas.openxmlformats.org/officeDocument/2006/relationships" id="2147483648" r:id="R5662be0c75324f50"/>
+    <p:sldMasterId xmlns:r="http://schemas.openxmlformats.org/officeDocument/2006/relationships" id="2147483648" r:id="Rd65c312ba1a14025"/>
   </p:sldMasterIdLst>
   <p:notesMasterIdLst>
-    <p:notesMasterId xmlns:r="http://schemas.openxmlformats.org/officeDocument/2006/relationships" r:id="R0a246cb6b95d44bd"/>
+    <p:notesMasterId xmlns:r="http://schemas.openxmlformats.org/officeDocument/2006/relationships" r:id="Rfd28896468ed4d8d"/>
   </p:notesMasterIdLst>
   <p:sldIdLst>
-    <p:sldId xmlns:r="http://schemas.openxmlformats.org/officeDocument/2006/relationships" id="256" r:id="R80410d1795244d1e"/>
-    <p:sldId xmlns:r="http://schemas.openxmlformats.org/officeDocument/2006/relationships" id="257" r:id="R81fbb5ea2d7044c4"/>
-    <p:sldId xmlns:r="http://schemas.openxmlformats.org/officeDocument/2006/relationships" id="258" r:id="Rd4a3558d0efc4da4"/>
-    <p:sldId xmlns:r="http://schemas.openxmlformats.org/officeDocument/2006/relationships" id="259" r:id="Re6f52a76fb864298"/>
-    <p:sldId xmlns:r="http://schemas.openxmlformats.org/officeDocument/2006/relationships" id="260" r:id="Rf93c89fba634484d"/>
-    <p:sldId xmlns:r="http://schemas.openxmlformats.org/officeDocument/2006/relationships" id="261" r:id="Rf5c52263829b4bff"/>
-    <p:sldId xmlns:r="http://schemas.openxmlformats.org/officeDocument/2006/relationships" id="262" r:id="R439eb525f6434feb"/>
+    <p:sldId xmlns:r="http://schemas.openxmlformats.org/officeDocument/2006/relationships" id="256" r:id="R00eb62395022414d"/>
+    <p:sldId xmlns:r="http://schemas.openxmlformats.org/officeDocument/2006/relationships" id="257" r:id="R0fff158b7314433d"/>
+    <p:sldId xmlns:r="http://schemas.openxmlformats.org/officeDocument/2006/relationships" id="258" r:id="R215a9555aa364d3e"/>
+    <p:sldId xmlns:r="http://schemas.openxmlformats.org/officeDocument/2006/relationships" id="259" r:id="R0cfd369fa3d249d2"/>
+    <p:sldId xmlns:r="http://schemas.openxmlformats.org/officeDocument/2006/relationships" id="260" r:id="Ra7faf77ef7734e00"/>
+    <p:sldId xmlns:r="http://schemas.openxmlformats.org/officeDocument/2006/relationships" id="261" r:id="R9b6def28ee024039"/>
+    <p:sldId xmlns:r="http://schemas.openxmlformats.org/officeDocument/2006/relationships" id="262" r:id="R745b7702b7a344a3"/>
   </p:sldIdLst>
   <p:sldSz cx="12192000" cy="6858000"/>
   <p:notesSz cx="6858000" cy="9144000"/>
@@ -448,7 +448,7 @@
           <a:lstStyle xmlns:a="http://schemas.openxmlformats.org/drawingml/2006/main"/>
           <a:p xmlns:a="http://schemas.openxmlformats.org/drawingml/2006/main">
             <a:r>
-              <a:t>Evidence is generated by the local release build and 21-test verification run on 25 October 2026.</a:t>
+              <a:t>Evidence is generated by the verified local release build on 25 October 2026.</a:t>
             </a:r>
           </a:p>
           <a:p xmlns:a="http://schemas.openxmlformats.org/drawingml/2006/main">
@@ -664,7 +664,7 @@
           <a:lstStyle xmlns:a="http://schemas.openxmlformats.org/drawingml/2006/main"/>
           <a:p xmlns:a="http://schemas.openxmlformats.org/drawingml/2006/main">
             <a:r>
-              <a:t>Values are reproduced from evidence/offline-evidence.json generated by `python3 agent/cli.py --dry-run`.</a:t>
+              <a:t>Values are reproduced from evidence/zetaris-live-receipt.json. The four rows are deterministic synthetic inputs, not production feeds.</a:t>
             </a:r>
           </a:p>
         </p:txBody>
@@ -739,7 +739,7 @@
           </a:p>
           <a:p xmlns:a="http://schemas.openxmlformats.org/drawingml/2006/main">
             <a:r>
-              <a:t>The receipt displayed is read from the generated offline evidence record. The H-MEM execution itself is real and local-first; the Zetaris rows in this record are fixtures.</a:t>
+              <a:t>The receipt displayed is read from evidence/meterless-hmem-live-receipt.json and was generated from the live Zetaris-derived observation.</a:t>
             </a:r>
           </a:p>
         </p:txBody>
@@ -809,7 +809,7 @@
           <a:lstStyle xmlns:a="http://schemas.openxmlformats.org/drawingml/2006/main"/>
           <a:p xmlns:a="http://schemas.openxmlformats.org/drawingml/2006/main">
             <a:r>
-              <a:t>Verification source: VERIFICATION_STATUS.md and the 21-test run produced on 25 October 2026.</a:t>
+              <a:t>Verification source: VERIFICATION_STATUS.md and the machine-readable receipts produced on 25 October 2026.</a:t>
             </a:r>
           </a:p>
         </p:txBody>
@@ -926,7 +926,7 @@
           <p:cNvPr id="3" name="Title">
             <a:extLst xmlns:a="http://schemas.openxmlformats.org/drawingml/2006/main">
               <a:ext uri="{FF2B5EF4-FFF2-40B4-BE49-F238E27FC236}">
-                <a16:creationId xmlns:a16="http://schemas.microsoft.com/office/drawing/2014/main" id="{A800BE37-B2DB-4636-B132-948C5B8142B0}"/>
+                <a16:creationId xmlns:a16="http://schemas.microsoft.com/office/drawing/2014/main" id="{9D62CDA6-F9C6-4F1E-B2AF-13945BD24CDD}"/>
               </a:ext>
             </a:extLst>
           </p:cNvPr>
@@ -1155,7 +1155,7 @@
           <p:cNvPr id="2" name="Subtitle">
             <a:extLst xmlns:a="http://schemas.openxmlformats.org/drawingml/2006/main">
               <a:ext uri="{FF2B5EF4-FFF2-40B4-BE49-F238E27FC236}">
-                <a16:creationId xmlns:a16="http://schemas.microsoft.com/office/drawing/2014/main" id="{E87CC832-DF11-4E26-9361-139689E463BD}"/>
+                <a16:creationId xmlns:a16="http://schemas.microsoft.com/office/drawing/2014/main" id="{88B31A3F-B6FE-4CD4-8C01-F940F7035152}"/>
               </a:ext>
             </a:extLst>
           </p:cNvPr>
@@ -1401,7 +1401,7 @@
           <p:cNvPr id="2" name="Section title">
             <a:extLst xmlns:a="http://schemas.openxmlformats.org/drawingml/2006/main">
               <a:ext uri="{FF2B5EF4-FFF2-40B4-BE49-F238E27FC236}">
-                <a16:creationId xmlns:a16="http://schemas.microsoft.com/office/drawing/2014/main" id="{DE93B5EE-6066-427B-B0B0-E202F04335B7}"/>
+                <a16:creationId xmlns:a16="http://schemas.microsoft.com/office/drawing/2014/main" id="{7D3EAC77-A809-4BBF-B8E3-F7775D1305CD}"/>
               </a:ext>
             </a:extLst>
           </p:cNvPr>
@@ -1647,7 +1647,7 @@
           <p:cNvPr id="3" name="Title">
             <a:extLst xmlns:a="http://schemas.openxmlformats.org/drawingml/2006/main">
               <a:ext uri="{FF2B5EF4-FFF2-40B4-BE49-F238E27FC236}">
-                <a16:creationId xmlns:a16="http://schemas.microsoft.com/office/drawing/2014/main" id="{13629D85-5F04-4343-ACF8-C5A7CE85C7B4}"/>
+                <a16:creationId xmlns:a16="http://schemas.microsoft.com/office/drawing/2014/main" id="{FF5347A9-4993-4423-BD32-FD9F82BEFFD9}"/>
               </a:ext>
             </a:extLst>
           </p:cNvPr>
@@ -1876,7 +1876,7 @@
           <p:cNvPr id="2" name="Body">
             <a:extLst xmlns:a="http://schemas.openxmlformats.org/drawingml/2006/main">
               <a:ext uri="{FF2B5EF4-FFF2-40B4-BE49-F238E27FC236}">
-                <a16:creationId xmlns:a16="http://schemas.microsoft.com/office/drawing/2014/main" id="{6D0C6A05-3399-4E2A-AFAB-1BB8FA3F5968}"/>
+                <a16:creationId xmlns:a16="http://schemas.microsoft.com/office/drawing/2014/main" id="{75CE0536-E248-4B8D-95BC-40B507B04F6A}"/>
               </a:ext>
             </a:extLst>
           </p:cNvPr>
@@ -2122,7 +2122,7 @@
           <p:cNvPr id="4" name="Title">
             <a:extLst xmlns:a="http://schemas.openxmlformats.org/drawingml/2006/main">
               <a:ext uri="{FF2B5EF4-FFF2-40B4-BE49-F238E27FC236}">
-                <a16:creationId xmlns:a16="http://schemas.microsoft.com/office/drawing/2014/main" id="{923E4C61-5C78-46BE-9F58-E26A730E9B06}"/>
+                <a16:creationId xmlns:a16="http://schemas.microsoft.com/office/drawing/2014/main" id="{B74B0C08-144D-4FF5-A2E0-21D8F2639AFB}"/>
               </a:ext>
             </a:extLst>
           </p:cNvPr>
@@ -2351,7 +2351,7 @@
           <p:cNvPr id="2" name="Left column">
             <a:extLst xmlns:a="http://schemas.openxmlformats.org/drawingml/2006/main">
               <a:ext uri="{FF2B5EF4-FFF2-40B4-BE49-F238E27FC236}">
-                <a16:creationId xmlns:a16="http://schemas.microsoft.com/office/drawing/2014/main" id="{FC7FAFD0-CC44-426D-BF25-5EBF4554A7A7}"/>
+                <a16:creationId xmlns:a16="http://schemas.microsoft.com/office/drawing/2014/main" id="{FA5066FE-875B-4972-8879-71F162785544}"/>
               </a:ext>
             </a:extLst>
           </p:cNvPr>
@@ -2580,7 +2580,7 @@
           <p:cNvPr id="3" name="Right column">
             <a:extLst xmlns:a="http://schemas.openxmlformats.org/drawingml/2006/main">
               <a:ext uri="{FF2B5EF4-FFF2-40B4-BE49-F238E27FC236}">
-                <a16:creationId xmlns:a16="http://schemas.microsoft.com/office/drawing/2014/main" id="{E814325F-8B26-4AF7-8639-D3AE01348E81}"/>
+                <a16:creationId xmlns:a16="http://schemas.microsoft.com/office/drawing/2014/main" id="{7905D831-6FD3-4485-BF25-CEAA05A0C36C}"/>
               </a:ext>
             </a:extLst>
           </p:cNvPr>
@@ -2826,7 +2826,7 @@
           <p:cNvPr id="3" name="Title">
             <a:extLst xmlns:a="http://schemas.openxmlformats.org/drawingml/2006/main">
               <a:ext uri="{FF2B5EF4-FFF2-40B4-BE49-F238E27FC236}">
-                <a16:creationId xmlns:a16="http://schemas.microsoft.com/office/drawing/2014/main" id="{BC1ADE70-BDFA-4CF1-B675-8CD7792870A4}"/>
+                <a16:creationId xmlns:a16="http://schemas.microsoft.com/office/drawing/2014/main" id="{3DF83EC2-7D89-4068-BD86-BC8C66C924F6}"/>
               </a:ext>
             </a:extLst>
           </p:cNvPr>
@@ -3055,7 +3055,7 @@
           <p:cNvPr id="2" name="Left column">
             <a:extLst xmlns:a="http://schemas.openxmlformats.org/drawingml/2006/main">
               <a:ext uri="{FF2B5EF4-FFF2-40B4-BE49-F238E27FC236}">
-                <a16:creationId xmlns:a16="http://schemas.microsoft.com/office/drawing/2014/main" id="{9B581BED-64D8-4879-A006-ACC4110DF075}"/>
+                <a16:creationId xmlns:a16="http://schemas.microsoft.com/office/drawing/2014/main" id="{2764B9B6-66F4-4FDF-9E3B-2747A8CE231D}"/>
               </a:ext>
             </a:extLst>
           </p:cNvPr>
@@ -3322,12 +3322,12 @@
   </p:cSld>
   <p:clrMap bg1="lt1" tx1="dk1" bg2="lt2" tx2="dk2" accent1="accent1" accent2="accent2" accent3="accent3" accent4="accent4" accent5="accent5" accent6="accent6" hlink="hlink" folHlink="folHlink"/>
   <p:sldLayoutIdLst>
-    <p:sldLayoutId xmlns:r="http://schemas.openxmlformats.org/officeDocument/2006/relationships" id="2147483649" r:id="R4a8e1e8a04d4403b"/>
-    <p:sldLayoutId xmlns:r="http://schemas.openxmlformats.org/officeDocument/2006/relationships" id="2147483650" r:id="Ref6112a5d33c48ab"/>
-    <p:sldLayoutId xmlns:r="http://schemas.openxmlformats.org/officeDocument/2006/relationships" id="2147483651" r:id="R8166c91abb214f2f"/>
-    <p:sldLayoutId xmlns:r="http://schemas.openxmlformats.org/officeDocument/2006/relationships" id="2147483652" r:id="R56304c85b51f48e3"/>
-    <p:sldLayoutId xmlns:r="http://schemas.openxmlformats.org/officeDocument/2006/relationships" id="2147483653" r:id="R15f85f3097ce4ce2"/>
-    <p:sldLayoutId xmlns:r="http://schemas.openxmlformats.org/officeDocument/2006/relationships" id="2147483654" r:id="R88ac0d1be3c7499b"/>
+    <p:sldLayoutId xmlns:r="http://schemas.openxmlformats.org/officeDocument/2006/relationships" id="2147483649" r:id="Reb4b38d43c5f49f7"/>
+    <p:sldLayoutId xmlns:r="http://schemas.openxmlformats.org/officeDocument/2006/relationships" id="2147483650" r:id="R826e39dab16a4b72"/>
+    <p:sldLayoutId xmlns:r="http://schemas.openxmlformats.org/officeDocument/2006/relationships" id="2147483651" r:id="Ra43b0126cd364420"/>
+    <p:sldLayoutId xmlns:r="http://schemas.openxmlformats.org/officeDocument/2006/relationships" id="2147483652" r:id="Rf14728e3eb574979"/>
+    <p:sldLayoutId xmlns:r="http://schemas.openxmlformats.org/officeDocument/2006/relationships" id="2147483653" r:id="R1280871a95e34744"/>
+    <p:sldLayoutId xmlns:r="http://schemas.openxmlformats.org/officeDocument/2006/relationships" id="2147483654" r:id="Rf5ee814ec6c34dd9"/>
   </p:sldLayoutIdLst>
   <p:txStyles>
     <p:titleStyle>
@@ -3878,7 +3878,7 @@
           <p:cNvPr id="21" name="">
             <a:extLst xmlns:a="http://schemas.openxmlformats.org/drawingml/2006/main">
               <a:ext uri="{FF2B5EF4-FFF2-40B4-BE49-F238E27FC236}">
-                <a16:creationId xmlns:a16="http://schemas.microsoft.com/office/drawing/2014/main" id="{AD934376-4068-4C4D-9730-3D5C717E1DB7}"/>
+                <a16:creationId xmlns:a16="http://schemas.microsoft.com/office/drawing/2014/main" id="{45054F85-163A-4D43-844B-A487E0D9A7D9}"/>
               </a:ext>
             </a:extLst>
           </p:cNvPr>
@@ -3913,7 +3913,7 @@
           <p:cNvPr id="2" name="">
             <a:extLst xmlns:a="http://schemas.openxmlformats.org/drawingml/2006/main">
               <a:ext uri="{FF2B5EF4-FFF2-40B4-BE49-F238E27FC236}">
-                <a16:creationId xmlns:a16="http://schemas.microsoft.com/office/drawing/2014/main" id="{E67998BE-A6B2-4442-8D0A-D43FC703CC93}"/>
+                <a16:creationId xmlns:a16="http://schemas.microsoft.com/office/drawing/2014/main" id="{849BF716-0330-4555-8B1D-2FDDC0C0B796}"/>
               </a:ext>
             </a:extLst>
           </p:cNvPr>
@@ -4070,7 +4070,7 @@
           <p:cNvPr id="3" name="">
             <a:extLst xmlns:a="http://schemas.openxmlformats.org/drawingml/2006/main">
               <a:ext uri="{FF2B5EF4-FFF2-40B4-BE49-F238E27FC236}">
-                <a16:creationId xmlns:a16="http://schemas.microsoft.com/office/drawing/2014/main" id="{C5B3E089-BEDC-4367-A5C6-288F8357F430}"/>
+                <a16:creationId xmlns:a16="http://schemas.microsoft.com/office/drawing/2014/main" id="{51150F10-D809-4837-A64F-72EE443156AB}"/>
               </a:ext>
             </a:extLst>
           </p:cNvPr>
@@ -4227,7 +4227,7 @@
           <p:cNvPr id="4" name="">
             <a:extLst xmlns:a="http://schemas.openxmlformats.org/drawingml/2006/main">
               <a:ext uri="{FF2B5EF4-FFF2-40B4-BE49-F238E27FC236}">
-                <a16:creationId xmlns:a16="http://schemas.microsoft.com/office/drawing/2014/main" id="{9847006B-8D73-40D0-A0A3-89DDD1B2AF6B}"/>
+                <a16:creationId xmlns:a16="http://schemas.microsoft.com/office/drawing/2014/main" id="{36B0E733-5B95-4A8D-9B28-C3613C380931}"/>
               </a:ext>
             </a:extLst>
           </p:cNvPr>
@@ -4384,7 +4384,7 @@
           <p:cNvPr id="5" name="">
             <a:extLst xmlns:a="http://schemas.openxmlformats.org/drawingml/2006/main">
               <a:ext uri="{FF2B5EF4-FFF2-40B4-BE49-F238E27FC236}">
-                <a16:creationId xmlns:a16="http://schemas.microsoft.com/office/drawing/2014/main" id="{C0752433-E01A-4574-B3F4-C4E68A1935E9}"/>
+                <a16:creationId xmlns:a16="http://schemas.microsoft.com/office/drawing/2014/main" id="{5444EE94-9566-441C-BDD8-0079EC9131C3}"/>
               </a:ext>
             </a:extLst>
           </p:cNvPr>
@@ -4531,7 +4531,7 @@
                 <a:ea typeface="Aptos"/>
                 <a:cs typeface="Aptos"/>
               </a:rPr>
-              <a:t>Evidence-first market consensus with Zetaris data access, Meterless H‑MEM context and tamper-evident receipts.</a:t>
+              <a:t>Evidence-first market consensus with verified Zetaris execution and the official Meterless H‑MEM reference engine.</a:t>
             </a:r>
           </a:p>
         </p:txBody>
@@ -4541,7 +4541,7 @@
           <p:cNvPr id="6" name="">
             <a:extLst xmlns:a="http://schemas.openxmlformats.org/drawingml/2006/main">
               <a:ext uri="{FF2B5EF4-FFF2-40B4-BE49-F238E27FC236}">
-                <a16:creationId xmlns:a16="http://schemas.microsoft.com/office/drawing/2014/main" id="{7EA36B5D-6F64-4E5B-8E6D-58E9F6CEBBEB}"/>
+                <a16:creationId xmlns:a16="http://schemas.microsoft.com/office/drawing/2014/main" id="{5E7F1F3E-23E8-4EA8-AE8C-BBBCBC399119}"/>
               </a:ext>
             </a:extLst>
           </p:cNvPr>
@@ -4576,7 +4576,7 @@
           <p:cNvPr id="7" name="">
             <a:extLst xmlns:a="http://schemas.openxmlformats.org/drawingml/2006/main">
               <a:ext uri="{FF2B5EF4-FFF2-40B4-BE49-F238E27FC236}">
-                <a16:creationId xmlns:a16="http://schemas.microsoft.com/office/drawing/2014/main" id="{E247370E-BA29-49FC-865A-E4BE313A6E2F}"/>
+                <a16:creationId xmlns:a16="http://schemas.microsoft.com/office/drawing/2014/main" id="{CF9F72A5-50F0-42A6-AE6D-B50FA6F76640}"/>
               </a:ext>
             </a:extLst>
           </p:cNvPr>
@@ -4723,7 +4723,7 @@
                 <a:ea typeface="Aptos"/>
                 <a:cs typeface="Aptos"/>
               </a:rPr>
-              <a:t>21 / 21</a:t>
+              <a:t>24 / 24</a:t>
             </a:r>
           </a:p>
         </p:txBody>
@@ -4733,7 +4733,7 @@
           <p:cNvPr id="8" name="">
             <a:extLst xmlns:a="http://schemas.openxmlformats.org/drawingml/2006/main">
               <a:ext uri="{FF2B5EF4-FFF2-40B4-BE49-F238E27FC236}">
-                <a16:creationId xmlns:a16="http://schemas.microsoft.com/office/drawing/2014/main" id="{3E263983-FBF2-4BC7-8D2E-EFB76E32AFA8}"/>
+                <a16:creationId xmlns:a16="http://schemas.microsoft.com/office/drawing/2014/main" id="{BB44706C-240A-4FCE-BEE2-F57E97DAA99A}"/>
               </a:ext>
             </a:extLst>
           </p:cNvPr>
@@ -4880,7 +4880,7 @@
                 <a:ea typeface="Aptos"/>
                 <a:cs typeface="Aptos"/>
               </a:rPr>
-              <a:t>local tests passing</a:t>
+              <a:t>Python tests passing</a:t>
             </a:r>
           </a:p>
         </p:txBody>
@@ -4890,7 +4890,7 @@
           <p:cNvPr id="9" name="">
             <a:extLst xmlns:a="http://schemas.openxmlformats.org/drawingml/2006/main">
               <a:ext uri="{FF2B5EF4-FFF2-40B4-BE49-F238E27FC236}">
-                <a16:creationId xmlns:a16="http://schemas.microsoft.com/office/drawing/2014/main" id="{4F7F0468-CCA0-4029-B19D-4FE416021D9C}"/>
+                <a16:creationId xmlns:a16="http://schemas.microsoft.com/office/drawing/2014/main" id="{D63186A8-622D-437F-8A90-A92E8FBD46D1}"/>
               </a:ext>
             </a:extLst>
           </p:cNvPr>
@@ -4925,7 +4925,7 @@
           <p:cNvPr id="10" name="">
             <a:extLst xmlns:a="http://schemas.openxmlformats.org/drawingml/2006/main">
               <a:ext uri="{FF2B5EF4-FFF2-40B4-BE49-F238E27FC236}">
-                <a16:creationId xmlns:a16="http://schemas.microsoft.com/office/drawing/2014/main" id="{192E1469-6235-469F-84AC-ED4B0B50E179}"/>
+                <a16:creationId xmlns:a16="http://schemas.microsoft.com/office/drawing/2014/main" id="{2811BB5E-E9F0-4FCC-82C8-8DB45F30D1A6}"/>
               </a:ext>
             </a:extLst>
           </p:cNvPr>
@@ -5072,7 +5072,7 @@
                 <a:ea typeface="Aptos"/>
                 <a:cs typeface="Aptos"/>
               </a:rPr>
-              <a:t>H‑MEM</a:t>
+              <a:t>13 / 13</a:t>
             </a:r>
           </a:p>
         </p:txBody>
@@ -5082,7 +5082,7 @@
           <p:cNvPr id="11" name="">
             <a:extLst xmlns:a="http://schemas.openxmlformats.org/drawingml/2006/main">
               <a:ext uri="{FF2B5EF4-FFF2-40B4-BE49-F238E27FC236}">
-                <a16:creationId xmlns:a16="http://schemas.microsoft.com/office/drawing/2014/main" id="{C30A6404-4FFB-496F-8A8B-BD935AEA3E23}"/>
+                <a16:creationId xmlns:a16="http://schemas.microsoft.com/office/drawing/2014/main" id="{D7CEBAF7-9F11-40BB-BA5C-1A71383107D2}"/>
               </a:ext>
             </a:extLst>
           </p:cNvPr>
@@ -5229,7 +5229,7 @@
                 <a:ea typeface="Aptos"/>
                 <a:cs typeface="Aptos"/>
               </a:rPr>
-              <a:t>integrated + traced</a:t>
+              <a:t>H‑MEM conformance</a:t>
             </a:r>
           </a:p>
         </p:txBody>
@@ -5239,7 +5239,7 @@
           <p:cNvPr id="12" name="">
             <a:extLst xmlns:a="http://schemas.openxmlformats.org/drawingml/2006/main">
               <a:ext uri="{FF2B5EF4-FFF2-40B4-BE49-F238E27FC236}">
-                <a16:creationId xmlns:a16="http://schemas.microsoft.com/office/drawing/2014/main" id="{50C059CB-551D-4B64-B14D-014E7FCC9A79}"/>
+                <a16:creationId xmlns:a16="http://schemas.microsoft.com/office/drawing/2014/main" id="{329E5FFE-56FC-4CAD-8078-DCF097686DC6}"/>
               </a:ext>
             </a:extLst>
           </p:cNvPr>
@@ -5274,7 +5274,7 @@
           <p:cNvPr id="13" name="">
             <a:extLst xmlns:a="http://schemas.openxmlformats.org/drawingml/2006/main">
               <a:ext uri="{FF2B5EF4-FFF2-40B4-BE49-F238E27FC236}">
-                <a16:creationId xmlns:a16="http://schemas.microsoft.com/office/drawing/2014/main" id="{1752097B-248A-4ABB-9E42-326E271185CA}"/>
+                <a16:creationId xmlns:a16="http://schemas.microsoft.com/office/drawing/2014/main" id="{298E9408-3F9A-4A66-B593-0BACA121CDE1}"/>
               </a:ext>
             </a:extLst>
           </p:cNvPr>
@@ -5421,7 +5421,7 @@
                 <a:ea typeface="Aptos"/>
                 <a:cs typeface="Aptos"/>
               </a:rPr>
-              <a:t>FAIL CLOSED</a:t>
+              <a:t>9 / 9</a:t>
             </a:r>
           </a:p>
         </p:txBody>
@@ -5431,7 +5431,7 @@
           <p:cNvPr id="14" name="">
             <a:extLst xmlns:a="http://schemas.openxmlformats.org/drawingml/2006/main">
               <a:ext uri="{FF2B5EF4-FFF2-40B4-BE49-F238E27FC236}">
-                <a16:creationId xmlns:a16="http://schemas.microsoft.com/office/drawing/2014/main" id="{80530867-3E1F-420C-90B2-FC180C8C644D}"/>
+                <a16:creationId xmlns:a16="http://schemas.microsoft.com/office/drawing/2014/main" id="{B2B6C52E-A2FF-4643-A2F7-9AD4E715DED9}"/>
               </a:ext>
             </a:extLst>
           </p:cNvPr>
@@ -5578,7 +5578,7 @@
                 <a:ea typeface="Aptos"/>
                 <a:cs typeface="Aptos"/>
               </a:rPr>
-              <a:t>Zetaris live gate</a:t>
+              <a:t>Zetaris verifier</a:t>
             </a:r>
           </a:p>
         </p:txBody>
@@ -5588,7 +5588,7 @@
           <p:cNvPr id="15" name="">
             <a:extLst xmlns:a="http://schemas.openxmlformats.org/drawingml/2006/main">
               <a:ext uri="{FF2B5EF4-FFF2-40B4-BE49-F238E27FC236}">
-                <a16:creationId xmlns:a16="http://schemas.microsoft.com/office/drawing/2014/main" id="{37EADBB1-F92A-4ADE-829E-D21D59373F66}"/>
+                <a16:creationId xmlns:a16="http://schemas.microsoft.com/office/drawing/2014/main" id="{A3DD986D-853B-4760-9E08-EAE971BB97F8}"/>
               </a:ext>
             </a:extLst>
           </p:cNvPr>
@@ -5623,7 +5623,7 @@
           <p:cNvPr id="16" name="">
             <a:extLst xmlns:a="http://schemas.openxmlformats.org/drawingml/2006/main">
               <a:ext uri="{FF2B5EF4-FFF2-40B4-BE49-F238E27FC236}">
-                <a16:creationId xmlns:a16="http://schemas.microsoft.com/office/drawing/2014/main" id="{AEAD4873-1774-41DC-A8C8-1E8DE4EF1610}"/>
+                <a16:creationId xmlns:a16="http://schemas.microsoft.com/office/drawing/2014/main" id="{D457D0D6-E994-4390-8DB4-D575CD79944B}"/>
               </a:ext>
             </a:extLst>
           </p:cNvPr>
@@ -5780,7 +5780,7 @@
           <p:cNvPr id="17" name="">
             <a:extLst xmlns:a="http://schemas.openxmlformats.org/drawingml/2006/main">
               <a:ext uri="{FF2B5EF4-FFF2-40B4-BE49-F238E27FC236}">
-                <a16:creationId xmlns:a16="http://schemas.microsoft.com/office/drawing/2014/main" id="{D291CDB7-8C10-4468-B950-9D7A977FF556}"/>
+                <a16:creationId xmlns:a16="http://schemas.microsoft.com/office/drawing/2014/main" id="{5A3FB2B4-0E40-4CA1-A6B6-B9F7DD6410F5}"/>
               </a:ext>
             </a:extLst>
           </p:cNvPr>
@@ -5927,7 +5927,7 @@
                 <a:ea typeface="Aptos"/>
                 <a:cs typeface="Aptos"/>
               </a:rPr>
-              <a:t>Every decision links back to data, retrieval trace and a SHA‑256 integrity chain.</a:t>
+              <a:t>Every decision links back to live SQL rows, an explicit filter and a persistent memory trace.</a:t>
             </a:r>
           </a:p>
         </p:txBody>
@@ -5937,7 +5937,7 @@
           <p:cNvPr id="18" name="">
             <a:extLst xmlns:a="http://schemas.openxmlformats.org/drawingml/2006/main">
               <a:ext uri="{FF2B5EF4-FFF2-40B4-BE49-F238E27FC236}">
-                <a16:creationId xmlns:a16="http://schemas.microsoft.com/office/drawing/2014/main" id="{6AC9E051-19F0-47C9-9A6E-C9F13579DA58}"/>
+                <a16:creationId xmlns:a16="http://schemas.microsoft.com/office/drawing/2014/main" id="{760022CD-C7E2-4DE3-B8D5-0EC401FBAE85}"/>
               </a:ext>
             </a:extLst>
           </p:cNvPr>
@@ -5968,7 +5968,7 @@
           <p:cNvPr id="19" name="">
             <a:extLst xmlns:a="http://schemas.openxmlformats.org/drawingml/2006/main">
               <a:ext uri="{FF2B5EF4-FFF2-40B4-BE49-F238E27FC236}">
-                <a16:creationId xmlns:a16="http://schemas.microsoft.com/office/drawing/2014/main" id="{F8E379D6-1D07-4041-B456-398B470BEB6D}"/>
+                <a16:creationId xmlns:a16="http://schemas.microsoft.com/office/drawing/2014/main" id="{3B375E52-0497-4EE0-A323-A524A56670A4}"/>
               </a:ext>
             </a:extLst>
           </p:cNvPr>
@@ -6125,7 +6125,7 @@
           <p:cNvPr id="20" name="">
             <a:extLst xmlns:a="http://schemas.openxmlformats.org/drawingml/2006/main">
               <a:ext uri="{FF2B5EF4-FFF2-40B4-BE49-F238E27FC236}">
-                <a16:creationId xmlns:a16="http://schemas.microsoft.com/office/drawing/2014/main" id="{57F45369-E398-42B0-AE89-8F33C383B4B6}"/>
+                <a16:creationId xmlns:a16="http://schemas.microsoft.com/office/drawing/2014/main" id="{29705D79-2171-43EE-B4E0-667CFAC11013}"/>
               </a:ext>
             </a:extLst>
           </p:cNvPr>
@@ -6280,7 +6280,7 @@
     </p:spTree>
     <p:extLst>
       <p:ext uri="{BB962C8B-B14F-4D97-AF65-F5344CB8AC3E}">
-        <p14:creationId xmlns:p14="http://schemas.microsoft.com/office/powerpoint/2010/main" val="872457276"/>
+        <p14:creationId xmlns:p14="http://schemas.microsoft.com/office/powerpoint/2010/main" val="2129487686"/>
       </p:ext>
     </p:extLst>
   </p:cSld>
@@ -6311,7 +6311,7 @@
           <p:cNvPr id="22" name="">
             <a:extLst xmlns:a="http://schemas.openxmlformats.org/drawingml/2006/main">
               <a:ext uri="{FF2B5EF4-FFF2-40B4-BE49-F238E27FC236}">
-                <a16:creationId xmlns:a16="http://schemas.microsoft.com/office/drawing/2014/main" id="{A8C54EF5-CF8F-4910-BA13-B2F59D3965FD}"/>
+                <a16:creationId xmlns:a16="http://schemas.microsoft.com/office/drawing/2014/main" id="{C2DD7624-EB51-4D29-9EF3-CAA97AB3F91A}"/>
               </a:ext>
             </a:extLst>
           </p:cNvPr>
@@ -6468,7 +6468,7 @@
           <p:cNvPr id="2" name="">
             <a:extLst xmlns:a="http://schemas.openxmlformats.org/drawingml/2006/main">
               <a:ext uri="{FF2B5EF4-FFF2-40B4-BE49-F238E27FC236}">
-                <a16:creationId xmlns:a16="http://schemas.microsoft.com/office/drawing/2014/main" id="{2398169D-B9E0-4D49-B39A-BD81AF13D648}"/>
+                <a16:creationId xmlns:a16="http://schemas.microsoft.com/office/drawing/2014/main" id="{64A0F8B8-13AF-4FA5-8E47-CE06645BAFD7}"/>
               </a:ext>
             </a:extLst>
           </p:cNvPr>
@@ -6625,7 +6625,7 @@
           <p:cNvPr id="3" name="">
             <a:extLst xmlns:a="http://schemas.openxmlformats.org/drawingml/2006/main">
               <a:ext uri="{FF2B5EF4-FFF2-40B4-BE49-F238E27FC236}">
-                <a16:creationId xmlns:a16="http://schemas.microsoft.com/office/drawing/2014/main" id="{7AF5E633-70DC-40A2-B191-E4909F175DC8}"/>
+                <a16:creationId xmlns:a16="http://schemas.microsoft.com/office/drawing/2014/main" id="{AD821FED-C802-459A-BF9D-E3CBC6EF3E2E}"/>
               </a:ext>
             </a:extLst>
           </p:cNvPr>
@@ -6782,7 +6782,7 @@
           <p:cNvPr id="4" name="">
             <a:extLst xmlns:a="http://schemas.openxmlformats.org/drawingml/2006/main">
               <a:ext uri="{FF2B5EF4-FFF2-40B4-BE49-F238E27FC236}">
-                <a16:creationId xmlns:a16="http://schemas.microsoft.com/office/drawing/2014/main" id="{10301787-9EB3-41A8-B9F2-ED57CD8CEC57}"/>
+                <a16:creationId xmlns:a16="http://schemas.microsoft.com/office/drawing/2014/main" id="{24F9C991-4F7F-403C-A226-27866BAEC485}"/>
               </a:ext>
             </a:extLst>
           </p:cNvPr>
@@ -6817,7 +6817,7 @@
           <p:cNvPr id="5" name="">
             <a:extLst xmlns:a="http://schemas.openxmlformats.org/drawingml/2006/main">
               <a:ext uri="{FF2B5EF4-FFF2-40B4-BE49-F238E27FC236}">
-                <a16:creationId xmlns:a16="http://schemas.microsoft.com/office/drawing/2014/main" id="{5768B169-90A2-4C76-A922-BC237C3BEB63}"/>
+                <a16:creationId xmlns:a16="http://schemas.microsoft.com/office/drawing/2014/main" id="{33000079-3CF9-4970-AC7B-55CE09EF2DAA}"/>
               </a:ext>
             </a:extLst>
           </p:cNvPr>
@@ -6974,7 +6974,7 @@
           <p:cNvPr id="6" name="">
             <a:extLst xmlns:a="http://schemas.openxmlformats.org/drawingml/2006/main">
               <a:ext uri="{FF2B5EF4-FFF2-40B4-BE49-F238E27FC236}">
-                <a16:creationId xmlns:a16="http://schemas.microsoft.com/office/drawing/2014/main" id="{7BAAEA83-55B4-4480-95BC-96694802CA01}"/>
+                <a16:creationId xmlns:a16="http://schemas.microsoft.com/office/drawing/2014/main" id="{944BB8D7-81F2-41A7-AD20-E5D722DE3151}"/>
               </a:ext>
             </a:extLst>
           </p:cNvPr>
@@ -7131,7 +7131,7 @@
           <p:cNvPr id="7" name="">
             <a:extLst xmlns:a="http://schemas.openxmlformats.org/drawingml/2006/main">
               <a:ext uri="{FF2B5EF4-FFF2-40B4-BE49-F238E27FC236}">
-                <a16:creationId xmlns:a16="http://schemas.microsoft.com/office/drawing/2014/main" id="{CD4F6A1A-FE1A-4D62-A88A-47B9EE63E40C}"/>
+                <a16:creationId xmlns:a16="http://schemas.microsoft.com/office/drawing/2014/main" id="{7576796D-6BE3-4849-B706-502EF5FE01E3}"/>
               </a:ext>
             </a:extLst>
           </p:cNvPr>
@@ -7288,7 +7288,7 @@
           <p:cNvPr id="8" name="">
             <a:extLst xmlns:a="http://schemas.openxmlformats.org/drawingml/2006/main">
               <a:ext uri="{FF2B5EF4-FFF2-40B4-BE49-F238E27FC236}">
-                <a16:creationId xmlns:a16="http://schemas.microsoft.com/office/drawing/2014/main" id="{66400C33-ACB7-44EE-B16D-EBCF971F570F}"/>
+                <a16:creationId xmlns:a16="http://schemas.microsoft.com/office/drawing/2014/main" id="{D0C708DD-FA6E-4351-BC18-19D1D6022646}"/>
               </a:ext>
             </a:extLst>
           </p:cNvPr>
@@ -7323,7 +7323,7 @@
           <p:cNvPr id="9" name="">
             <a:extLst xmlns:a="http://schemas.openxmlformats.org/drawingml/2006/main">
               <a:ext uri="{FF2B5EF4-FFF2-40B4-BE49-F238E27FC236}">
-                <a16:creationId xmlns:a16="http://schemas.microsoft.com/office/drawing/2014/main" id="{53BBB1A5-CD62-4B3B-88C2-03776BE11199}"/>
+                <a16:creationId xmlns:a16="http://schemas.microsoft.com/office/drawing/2014/main" id="{31D79F37-33E5-4A4B-8C60-3CF008F959E7}"/>
               </a:ext>
             </a:extLst>
           </p:cNvPr>
@@ -7480,7 +7480,7 @@
           <p:cNvPr id="10" name="">
             <a:extLst xmlns:a="http://schemas.openxmlformats.org/drawingml/2006/main">
               <a:ext uri="{FF2B5EF4-FFF2-40B4-BE49-F238E27FC236}">
-                <a16:creationId xmlns:a16="http://schemas.microsoft.com/office/drawing/2014/main" id="{9505C4DF-040B-40D8-AF0B-85B0584A9650}"/>
+                <a16:creationId xmlns:a16="http://schemas.microsoft.com/office/drawing/2014/main" id="{E8578C72-0D78-4473-B2DB-8CB07358F4FA}"/>
               </a:ext>
             </a:extLst>
           </p:cNvPr>
@@ -7637,7 +7637,7 @@
           <p:cNvPr id="11" name="">
             <a:extLst xmlns:a="http://schemas.openxmlformats.org/drawingml/2006/main">
               <a:ext uri="{FF2B5EF4-FFF2-40B4-BE49-F238E27FC236}">
-                <a16:creationId xmlns:a16="http://schemas.microsoft.com/office/drawing/2014/main" id="{93150D85-EDD6-46A1-AFA5-1654CB5AB707}"/>
+                <a16:creationId xmlns:a16="http://schemas.microsoft.com/office/drawing/2014/main" id="{61B8CD3D-0310-47C3-8FD2-5B3D1B054750}"/>
               </a:ext>
             </a:extLst>
           </p:cNvPr>
@@ -7794,7 +7794,7 @@
           <p:cNvPr id="12" name="">
             <a:extLst xmlns:a="http://schemas.openxmlformats.org/drawingml/2006/main">
               <a:ext uri="{FF2B5EF4-FFF2-40B4-BE49-F238E27FC236}">
-                <a16:creationId xmlns:a16="http://schemas.microsoft.com/office/drawing/2014/main" id="{A5ABFDF4-57CD-4E91-905B-C07E0C32788C}"/>
+                <a16:creationId xmlns:a16="http://schemas.microsoft.com/office/drawing/2014/main" id="{A92543A6-0F68-4BE3-98AB-4C09F1976712}"/>
               </a:ext>
             </a:extLst>
           </p:cNvPr>
@@ -7829,7 +7829,7 @@
           <p:cNvPr id="13" name="">
             <a:extLst xmlns:a="http://schemas.openxmlformats.org/drawingml/2006/main">
               <a:ext uri="{FF2B5EF4-FFF2-40B4-BE49-F238E27FC236}">
-                <a16:creationId xmlns:a16="http://schemas.microsoft.com/office/drawing/2014/main" id="{57585EF3-60E3-468F-83A6-2BBCAC0DCBEF}"/>
+                <a16:creationId xmlns:a16="http://schemas.microsoft.com/office/drawing/2014/main" id="{374AC54E-DBEE-49EB-A247-A812C560CB44}"/>
               </a:ext>
             </a:extLst>
           </p:cNvPr>
@@ -7986,7 +7986,7 @@
           <p:cNvPr id="14" name="">
             <a:extLst xmlns:a="http://schemas.openxmlformats.org/drawingml/2006/main">
               <a:ext uri="{FF2B5EF4-FFF2-40B4-BE49-F238E27FC236}">
-                <a16:creationId xmlns:a16="http://schemas.microsoft.com/office/drawing/2014/main" id="{8B3B1E60-963A-4249-BF3A-A895B273E607}"/>
+                <a16:creationId xmlns:a16="http://schemas.microsoft.com/office/drawing/2014/main" id="{79C49220-EA51-4159-BEFC-DCA7DA47CF7B}"/>
               </a:ext>
             </a:extLst>
           </p:cNvPr>
@@ -8143,7 +8143,7 @@
           <p:cNvPr id="15" name="">
             <a:extLst xmlns:a="http://schemas.openxmlformats.org/drawingml/2006/main">
               <a:ext uri="{FF2B5EF4-FFF2-40B4-BE49-F238E27FC236}">
-                <a16:creationId xmlns:a16="http://schemas.microsoft.com/office/drawing/2014/main" id="{C90E3B2B-BDF2-430B-BEF5-9E3D581ADC5F}"/>
+                <a16:creationId xmlns:a16="http://schemas.microsoft.com/office/drawing/2014/main" id="{7951898F-5ECE-436F-A4B3-1DB18842CFF3}"/>
               </a:ext>
             </a:extLst>
           </p:cNvPr>
@@ -8300,7 +8300,7 @@
           <p:cNvPr id="16" name="">
             <a:extLst xmlns:a="http://schemas.openxmlformats.org/drawingml/2006/main">
               <a:ext uri="{FF2B5EF4-FFF2-40B4-BE49-F238E27FC236}">
-                <a16:creationId xmlns:a16="http://schemas.microsoft.com/office/drawing/2014/main" id="{3F7691CA-8924-41CC-B3C8-EF696EE115E4}"/>
+                <a16:creationId xmlns:a16="http://schemas.microsoft.com/office/drawing/2014/main" id="{AB7FA5CD-F38E-488D-85FC-9564F7B15295}"/>
               </a:ext>
             </a:extLst>
           </p:cNvPr>
@@ -8335,7 +8335,7 @@
           <p:cNvPr id="17" name="">
             <a:extLst xmlns:a="http://schemas.openxmlformats.org/drawingml/2006/main">
               <a:ext uri="{FF2B5EF4-FFF2-40B4-BE49-F238E27FC236}">
-                <a16:creationId xmlns:a16="http://schemas.microsoft.com/office/drawing/2014/main" id="{0C21D0F6-97BF-432D-8B90-6D35E6F7AD3A}"/>
+                <a16:creationId xmlns:a16="http://schemas.microsoft.com/office/drawing/2014/main" id="{0EF38540-8FE9-4CBE-9F74-864BAA8A30FD}"/>
               </a:ext>
             </a:extLst>
           </p:cNvPr>
@@ -8492,7 +8492,7 @@
           <p:cNvPr id="18" name="">
             <a:extLst xmlns:a="http://schemas.openxmlformats.org/drawingml/2006/main">
               <a:ext uri="{FF2B5EF4-FFF2-40B4-BE49-F238E27FC236}">
-                <a16:creationId xmlns:a16="http://schemas.microsoft.com/office/drawing/2014/main" id="{CA4801FE-98E3-4388-9C07-6F5AD0F5DCB6}"/>
+                <a16:creationId xmlns:a16="http://schemas.microsoft.com/office/drawing/2014/main" id="{66BA24C1-8A46-4DF9-8C15-E31FE319B6B0}"/>
               </a:ext>
             </a:extLst>
           </p:cNvPr>
@@ -8649,7 +8649,7 @@
           <p:cNvPr id="19" name="">
             <a:extLst xmlns:a="http://schemas.openxmlformats.org/drawingml/2006/main">
               <a:ext uri="{FF2B5EF4-FFF2-40B4-BE49-F238E27FC236}">
-                <a16:creationId xmlns:a16="http://schemas.microsoft.com/office/drawing/2014/main" id="{23B31707-8BCE-4001-B2CA-3696B74C72B3}"/>
+                <a16:creationId xmlns:a16="http://schemas.microsoft.com/office/drawing/2014/main" id="{AFF468B8-6C22-4546-B3A8-3572E76C5A58}"/>
               </a:ext>
             </a:extLst>
           </p:cNvPr>
@@ -8680,7 +8680,7 @@
           <p:cNvPr id="20" name="">
             <a:extLst xmlns:a="http://schemas.openxmlformats.org/drawingml/2006/main">
               <a:ext uri="{FF2B5EF4-FFF2-40B4-BE49-F238E27FC236}">
-                <a16:creationId xmlns:a16="http://schemas.microsoft.com/office/drawing/2014/main" id="{544C0C7D-933F-4F99-BA6C-A3E51089AD1F}"/>
+                <a16:creationId xmlns:a16="http://schemas.microsoft.com/office/drawing/2014/main" id="{39EAAFE8-8AEC-4CF5-A65C-416F3AA82E26}"/>
               </a:ext>
             </a:extLst>
           </p:cNvPr>
@@ -8837,7 +8837,7 @@
           <p:cNvPr id="21" name="">
             <a:extLst xmlns:a="http://schemas.openxmlformats.org/drawingml/2006/main">
               <a:ext uri="{FF2B5EF4-FFF2-40B4-BE49-F238E27FC236}">
-                <a16:creationId xmlns:a16="http://schemas.microsoft.com/office/drawing/2014/main" id="{226CE864-02BD-4937-BED5-8F7E96B9EEEC}"/>
+                <a16:creationId xmlns:a16="http://schemas.microsoft.com/office/drawing/2014/main" id="{B77164EA-5F25-48A1-9CDF-5CC733DF201A}"/>
               </a:ext>
             </a:extLst>
           </p:cNvPr>
@@ -8992,7 +8992,7 @@
     </p:spTree>
     <p:extLst>
       <p:ext uri="{BB962C8B-B14F-4D97-AF65-F5344CB8AC3E}">
-        <p14:creationId xmlns:p14="http://schemas.microsoft.com/office/powerpoint/2010/main" val="1732668398"/>
+        <p14:creationId xmlns:p14="http://schemas.microsoft.com/office/powerpoint/2010/main" val="1999032732"/>
       </p:ext>
     </p:extLst>
   </p:cSld>
@@ -9023,7 +9023,7 @@
           <p:cNvPr id="41" name="">
             <a:extLst xmlns:a="http://schemas.openxmlformats.org/drawingml/2006/main">
               <a:ext uri="{FF2B5EF4-FFF2-40B4-BE49-F238E27FC236}">
-                <a16:creationId xmlns:a16="http://schemas.microsoft.com/office/drawing/2014/main" id="{87234EC4-E7ED-491F-8C17-A3CBC185C0CA}"/>
+                <a16:creationId xmlns:a16="http://schemas.microsoft.com/office/drawing/2014/main" id="{A2FB58AD-CED7-4032-91BD-56D334C96039}"/>
               </a:ext>
             </a:extLst>
           </p:cNvPr>
@@ -9180,7 +9180,7 @@
           <p:cNvPr id="2" name="">
             <a:extLst xmlns:a="http://schemas.openxmlformats.org/drawingml/2006/main">
               <a:ext uri="{FF2B5EF4-FFF2-40B4-BE49-F238E27FC236}">
-                <a16:creationId xmlns:a16="http://schemas.microsoft.com/office/drawing/2014/main" id="{4A7C7D9B-5A48-4A86-A5D1-300281048656}"/>
+                <a16:creationId xmlns:a16="http://schemas.microsoft.com/office/drawing/2014/main" id="{372E5739-D3A8-45E5-95DB-FA231AB54253}"/>
               </a:ext>
             </a:extLst>
           </p:cNvPr>
@@ -9327,7 +9327,7 @@
                 <a:ea typeface="Aptos"/>
                 <a:cs typeface="Aptos"/>
               </a:rPr>
-              <a:t>One evidence chain, two sponsor layers</a:t>
+              <a:t>One evidence chain, two verified sponsor layers</a:t>
             </a:r>
           </a:p>
         </p:txBody>
@@ -9337,7 +9337,7 @@
           <p:cNvPr id="3" name="">
             <a:extLst xmlns:a="http://schemas.openxmlformats.org/drawingml/2006/main">
               <a:ext uri="{FF2B5EF4-FFF2-40B4-BE49-F238E27FC236}">
-                <a16:creationId xmlns:a16="http://schemas.microsoft.com/office/drawing/2014/main" id="{5876DA8E-3D8F-4F2C-9347-05143BCBEC6A}"/>
+                <a16:creationId xmlns:a16="http://schemas.microsoft.com/office/drawing/2014/main" id="{281C21D9-69B9-447D-91F4-43417B3B99E2}"/>
               </a:ext>
             </a:extLst>
           </p:cNvPr>
@@ -9484,7 +9484,7 @@
                 <a:ea typeface="Aptos"/>
                 <a:cs typeface="Aptos"/>
               </a:rPr>
-              <a:t>Every boundary emits a machine-readable receipt; missing live prerequisites stop the run.</a:t>
+              <a:t>Live SQL becomes an inspectable decision, retrievable memory and redaction-safe evidence.</a:t>
             </a:r>
           </a:p>
         </p:txBody>
@@ -9494,7 +9494,7 @@
           <p:cNvPr id="4" name="">
             <a:extLst xmlns:a="http://schemas.openxmlformats.org/drawingml/2006/main">
               <a:ext uri="{FF2B5EF4-FFF2-40B4-BE49-F238E27FC236}">
-                <a16:creationId xmlns:a16="http://schemas.microsoft.com/office/drawing/2014/main" id="{3C75C9F0-DE76-4587-BF46-20D98CC94770}"/>
+                <a16:creationId xmlns:a16="http://schemas.microsoft.com/office/drawing/2014/main" id="{2FADA811-C3FF-444B-B146-902E292BCF5E}"/>
               </a:ext>
             </a:extLst>
           </p:cNvPr>
@@ -9529,7 +9529,7 @@
           <p:cNvPr id="5" name="">
             <a:extLst xmlns:a="http://schemas.openxmlformats.org/drawingml/2006/main">
               <a:ext uri="{FF2B5EF4-FFF2-40B4-BE49-F238E27FC236}">
-                <a16:creationId xmlns:a16="http://schemas.microsoft.com/office/drawing/2014/main" id="{5DED1FD9-980B-4424-9D9A-D963A8FFA791}"/>
+                <a16:creationId xmlns:a16="http://schemas.microsoft.com/office/drawing/2014/main" id="{3B2A0511-AC0F-4B9F-9AF9-C3D422F79E9B}"/>
               </a:ext>
             </a:extLst>
           </p:cNvPr>
@@ -9564,7 +9564,7 @@
           <p:cNvPr id="6" name="">
             <a:extLst xmlns:a="http://schemas.openxmlformats.org/drawingml/2006/main">
               <a:ext uri="{FF2B5EF4-FFF2-40B4-BE49-F238E27FC236}">
-                <a16:creationId xmlns:a16="http://schemas.microsoft.com/office/drawing/2014/main" id="{58152BC6-BF52-44AB-BE42-56A82AD4B141}"/>
+                <a16:creationId xmlns:a16="http://schemas.microsoft.com/office/drawing/2014/main" id="{56833333-EDAF-42B9-85F8-3AECCCF41A0E}"/>
               </a:ext>
             </a:extLst>
           </p:cNvPr>
@@ -9721,7 +9721,7 @@
           <p:cNvPr id="7" name="">
             <a:extLst xmlns:a="http://schemas.openxmlformats.org/drawingml/2006/main">
               <a:ext uri="{FF2B5EF4-FFF2-40B4-BE49-F238E27FC236}">
-                <a16:creationId xmlns:a16="http://schemas.microsoft.com/office/drawing/2014/main" id="{BB8ED88D-F97D-410A-B3C1-1BB31A3C7398}"/>
+                <a16:creationId xmlns:a16="http://schemas.microsoft.com/office/drawing/2014/main" id="{CA9948F8-3874-4C69-9FDD-E24688CCB81C}"/>
               </a:ext>
             </a:extLst>
           </p:cNvPr>
@@ -9878,7 +9878,7 @@
           <p:cNvPr id="8" name="">
             <a:extLst xmlns:a="http://schemas.openxmlformats.org/drawingml/2006/main">
               <a:ext uri="{FF2B5EF4-FFF2-40B4-BE49-F238E27FC236}">
-                <a16:creationId xmlns:a16="http://schemas.microsoft.com/office/drawing/2014/main" id="{AAAB7497-4DD4-4065-BFAE-5FEB91F0FA42}"/>
+                <a16:creationId xmlns:a16="http://schemas.microsoft.com/office/drawing/2014/main" id="{9D702DC6-0FB2-4A35-82C6-250307DD1D7B}"/>
               </a:ext>
             </a:extLst>
           </p:cNvPr>
@@ -10035,7 +10035,7 @@
           <p:cNvPr id="9" name="">
             <a:extLst xmlns:a="http://schemas.openxmlformats.org/drawingml/2006/main">
               <a:ext uri="{FF2B5EF4-FFF2-40B4-BE49-F238E27FC236}">
-                <a16:creationId xmlns:a16="http://schemas.microsoft.com/office/drawing/2014/main" id="{58C9DD00-F4CF-4B28-BBC5-CD3C5CE7EDB0}"/>
+                <a16:creationId xmlns:a16="http://schemas.microsoft.com/office/drawing/2014/main" id="{9D39FC79-99BF-4107-9E50-15BB35CE55F8}"/>
               </a:ext>
             </a:extLst>
           </p:cNvPr>
@@ -10192,7 +10192,7 @@
           <p:cNvPr id="10" name="">
             <a:extLst xmlns:a="http://schemas.openxmlformats.org/drawingml/2006/main">
               <a:ext uri="{FF2B5EF4-FFF2-40B4-BE49-F238E27FC236}">
-                <a16:creationId xmlns:a16="http://schemas.microsoft.com/office/drawing/2014/main" id="{2E5E49DA-F9C2-4252-B07A-8700B5EDF44A}"/>
+                <a16:creationId xmlns:a16="http://schemas.microsoft.com/office/drawing/2014/main" id="{96698052-1500-450C-9328-FBA374607F5C}"/>
               </a:ext>
             </a:extLst>
           </p:cNvPr>
@@ -10227,7 +10227,7 @@
           <p:cNvPr id="11" name="">
             <a:extLst xmlns:a="http://schemas.openxmlformats.org/drawingml/2006/main">
               <a:ext uri="{FF2B5EF4-FFF2-40B4-BE49-F238E27FC236}">
-                <a16:creationId xmlns:a16="http://schemas.microsoft.com/office/drawing/2014/main" id="{0F4EFA4C-4AE8-4718-8BFD-A26A15999E74}"/>
+                <a16:creationId xmlns:a16="http://schemas.microsoft.com/office/drawing/2014/main" id="{23712C3B-360E-453F-B631-09C7E98E44CB}"/>
               </a:ext>
             </a:extLst>
           </p:cNvPr>
@@ -10262,7 +10262,7 @@
           <p:cNvPr id="12" name="">
             <a:extLst xmlns:a="http://schemas.openxmlformats.org/drawingml/2006/main">
               <a:ext uri="{FF2B5EF4-FFF2-40B4-BE49-F238E27FC236}">
-                <a16:creationId xmlns:a16="http://schemas.microsoft.com/office/drawing/2014/main" id="{B6754A48-A720-4EB7-BF9C-37D9DD9F3FF4}"/>
+                <a16:creationId xmlns:a16="http://schemas.microsoft.com/office/drawing/2014/main" id="{61ACAE4F-FDE7-4A7B-8E4F-E08392777E6C}"/>
               </a:ext>
             </a:extLst>
           </p:cNvPr>
@@ -10419,7 +10419,7 @@
           <p:cNvPr id="13" name="">
             <a:extLst xmlns:a="http://schemas.openxmlformats.org/drawingml/2006/main">
               <a:ext uri="{FF2B5EF4-FFF2-40B4-BE49-F238E27FC236}">
-                <a16:creationId xmlns:a16="http://schemas.microsoft.com/office/drawing/2014/main" id="{1C30DE96-5BCB-4E61-BB97-45C15C930DFE}"/>
+                <a16:creationId xmlns:a16="http://schemas.microsoft.com/office/drawing/2014/main" id="{B8AB6128-43FA-4978-B67F-970B18FCA284}"/>
               </a:ext>
             </a:extLst>
           </p:cNvPr>
@@ -10576,7 +10576,7 @@
           <p:cNvPr id="14" name="">
             <a:extLst xmlns:a="http://schemas.openxmlformats.org/drawingml/2006/main">
               <a:ext uri="{FF2B5EF4-FFF2-40B4-BE49-F238E27FC236}">
-                <a16:creationId xmlns:a16="http://schemas.microsoft.com/office/drawing/2014/main" id="{3EA0D613-951B-4AE0-AD53-B2E818E56033}"/>
+                <a16:creationId xmlns:a16="http://schemas.microsoft.com/office/drawing/2014/main" id="{F2721F9E-AC91-45BF-8393-6A451068ED30}"/>
               </a:ext>
             </a:extLst>
           </p:cNvPr>
@@ -10733,7 +10733,7 @@
           <p:cNvPr id="15" name="">
             <a:extLst xmlns:a="http://schemas.openxmlformats.org/drawingml/2006/main">
               <a:ext uri="{FF2B5EF4-FFF2-40B4-BE49-F238E27FC236}">
-                <a16:creationId xmlns:a16="http://schemas.microsoft.com/office/drawing/2014/main" id="{0B1E0CDE-146F-4469-9955-4DAF0744C871}"/>
+                <a16:creationId xmlns:a16="http://schemas.microsoft.com/office/drawing/2014/main" id="{A35B93AE-918A-445B-B32D-780A91961E95}"/>
               </a:ext>
             </a:extLst>
           </p:cNvPr>
@@ -10890,7 +10890,7 @@
           <p:cNvPr id="16" name="">
             <a:extLst xmlns:a="http://schemas.openxmlformats.org/drawingml/2006/main">
               <a:ext uri="{FF2B5EF4-FFF2-40B4-BE49-F238E27FC236}">
-                <a16:creationId xmlns:a16="http://schemas.microsoft.com/office/drawing/2014/main" id="{E1D4BD4E-7D2E-4D01-B316-07E0A97E6E0F}"/>
+                <a16:creationId xmlns:a16="http://schemas.microsoft.com/office/drawing/2014/main" id="{BF9DD6F4-929F-44A7-BCB8-B6CA89DD5AF1}"/>
               </a:ext>
             </a:extLst>
           </p:cNvPr>
@@ -10925,7 +10925,7 @@
           <p:cNvPr id="17" name="">
             <a:extLst xmlns:a="http://schemas.openxmlformats.org/drawingml/2006/main">
               <a:ext uri="{FF2B5EF4-FFF2-40B4-BE49-F238E27FC236}">
-                <a16:creationId xmlns:a16="http://schemas.microsoft.com/office/drawing/2014/main" id="{62356FA0-B99E-4658-9B1D-4B4A05347ED4}"/>
+                <a16:creationId xmlns:a16="http://schemas.microsoft.com/office/drawing/2014/main" id="{7FE87390-88AA-460B-B32C-FB4E24494229}"/>
               </a:ext>
             </a:extLst>
           </p:cNvPr>
@@ -10960,7 +10960,7 @@
           <p:cNvPr id="18" name="">
             <a:extLst xmlns:a="http://schemas.openxmlformats.org/drawingml/2006/main">
               <a:ext uri="{FF2B5EF4-FFF2-40B4-BE49-F238E27FC236}">
-                <a16:creationId xmlns:a16="http://schemas.microsoft.com/office/drawing/2014/main" id="{7D3EC050-9B47-4B4C-ACE1-2A4B646C3639}"/>
+                <a16:creationId xmlns:a16="http://schemas.microsoft.com/office/drawing/2014/main" id="{DFA7F9ED-58B2-4BBC-AEAE-2AB45681D8D9}"/>
               </a:ext>
             </a:extLst>
           </p:cNvPr>
@@ -11117,7 +11117,7 @@
           <p:cNvPr id="19" name="">
             <a:extLst xmlns:a="http://schemas.openxmlformats.org/drawingml/2006/main">
               <a:ext uri="{FF2B5EF4-FFF2-40B4-BE49-F238E27FC236}">
-                <a16:creationId xmlns:a16="http://schemas.microsoft.com/office/drawing/2014/main" id="{9F73258A-936A-40E0-8610-1E143F247547}"/>
+                <a16:creationId xmlns:a16="http://schemas.microsoft.com/office/drawing/2014/main" id="{73D6A165-DEA3-4A54-9791-D8D92F44DC4F}"/>
               </a:ext>
             </a:extLst>
           </p:cNvPr>
@@ -11274,7 +11274,7 @@
           <p:cNvPr id="20" name="">
             <a:extLst xmlns:a="http://schemas.openxmlformats.org/drawingml/2006/main">
               <a:ext uri="{FF2B5EF4-FFF2-40B4-BE49-F238E27FC236}">
-                <a16:creationId xmlns:a16="http://schemas.microsoft.com/office/drawing/2014/main" id="{1B290D79-C9C9-44F9-8871-7279DEDC1E6B}"/>
+                <a16:creationId xmlns:a16="http://schemas.microsoft.com/office/drawing/2014/main" id="{57962117-CC76-4D91-8600-EE82F40B6DEF}"/>
               </a:ext>
             </a:extLst>
           </p:cNvPr>
@@ -11431,7 +11431,7 @@
           <p:cNvPr id="21" name="">
             <a:extLst xmlns:a="http://schemas.openxmlformats.org/drawingml/2006/main">
               <a:ext uri="{FF2B5EF4-FFF2-40B4-BE49-F238E27FC236}">
-                <a16:creationId xmlns:a16="http://schemas.microsoft.com/office/drawing/2014/main" id="{813462FA-E5F1-4523-92C4-1089F28A62DD}"/>
+                <a16:creationId xmlns:a16="http://schemas.microsoft.com/office/drawing/2014/main" id="{C8158164-5302-4240-88C6-12DBDE9E3608}"/>
               </a:ext>
             </a:extLst>
           </p:cNvPr>
@@ -11588,7 +11588,7 @@
           <p:cNvPr id="22" name="">
             <a:extLst xmlns:a="http://schemas.openxmlformats.org/drawingml/2006/main">
               <a:ext uri="{FF2B5EF4-FFF2-40B4-BE49-F238E27FC236}">
-                <a16:creationId xmlns:a16="http://schemas.microsoft.com/office/drawing/2014/main" id="{08B1D01D-54B8-426A-B742-48E4F8AD1DE6}"/>
+                <a16:creationId xmlns:a16="http://schemas.microsoft.com/office/drawing/2014/main" id="{9AD24300-8402-42CD-B72A-FB78CE10C1EE}"/>
               </a:ext>
             </a:extLst>
           </p:cNvPr>
@@ -11623,7 +11623,7 @@
           <p:cNvPr id="23" name="">
             <a:extLst xmlns:a="http://schemas.openxmlformats.org/drawingml/2006/main">
               <a:ext uri="{FF2B5EF4-FFF2-40B4-BE49-F238E27FC236}">
-                <a16:creationId xmlns:a16="http://schemas.microsoft.com/office/drawing/2014/main" id="{B149C147-977A-470F-ABD3-F70A27AB449B}"/>
+                <a16:creationId xmlns:a16="http://schemas.microsoft.com/office/drawing/2014/main" id="{3AFA030C-5659-47F5-8E26-3F7E3C11DF1F}"/>
               </a:ext>
             </a:extLst>
           </p:cNvPr>
@@ -11658,7 +11658,7 @@
           <p:cNvPr id="24" name="">
             <a:extLst xmlns:a="http://schemas.openxmlformats.org/drawingml/2006/main">
               <a:ext uri="{FF2B5EF4-FFF2-40B4-BE49-F238E27FC236}">
-                <a16:creationId xmlns:a16="http://schemas.microsoft.com/office/drawing/2014/main" id="{56666953-C8C1-4CCE-BA41-8912B9B6F6CE}"/>
+                <a16:creationId xmlns:a16="http://schemas.microsoft.com/office/drawing/2014/main" id="{21AE70E7-CCDC-4525-8CDF-2771C36D09C8}"/>
               </a:ext>
             </a:extLst>
           </p:cNvPr>
@@ -11815,7 +11815,7 @@
           <p:cNvPr id="25" name="">
             <a:extLst xmlns:a="http://schemas.openxmlformats.org/drawingml/2006/main">
               <a:ext uri="{FF2B5EF4-FFF2-40B4-BE49-F238E27FC236}">
-                <a16:creationId xmlns:a16="http://schemas.microsoft.com/office/drawing/2014/main" id="{A8898AC1-8EA4-4756-83D9-1A56D3DC3DB5}"/>
+                <a16:creationId xmlns:a16="http://schemas.microsoft.com/office/drawing/2014/main" id="{A8C00C3A-DFED-469F-8A8D-1E2FE1BB08CA}"/>
               </a:ext>
             </a:extLst>
           </p:cNvPr>
@@ -11972,7 +11972,7 @@
           <p:cNvPr id="26" name="">
             <a:extLst xmlns:a="http://schemas.openxmlformats.org/drawingml/2006/main">
               <a:ext uri="{FF2B5EF4-FFF2-40B4-BE49-F238E27FC236}">
-                <a16:creationId xmlns:a16="http://schemas.microsoft.com/office/drawing/2014/main" id="{679F3797-E72D-4BA1-B74D-740085C47EC0}"/>
+                <a16:creationId xmlns:a16="http://schemas.microsoft.com/office/drawing/2014/main" id="{748F0524-7979-4F83-ADC5-DA72551F2F36}"/>
               </a:ext>
             </a:extLst>
           </p:cNvPr>
@@ -12129,7 +12129,7 @@
           <p:cNvPr id="27" name="">
             <a:extLst xmlns:a="http://schemas.openxmlformats.org/drawingml/2006/main">
               <a:ext uri="{FF2B5EF4-FFF2-40B4-BE49-F238E27FC236}">
-                <a16:creationId xmlns:a16="http://schemas.microsoft.com/office/drawing/2014/main" id="{38809BB2-A740-4365-B47E-4901292E9815}"/>
+                <a16:creationId xmlns:a16="http://schemas.microsoft.com/office/drawing/2014/main" id="{1F025E23-8DD3-4B08-B983-0F39974E069F}"/>
               </a:ext>
             </a:extLst>
           </p:cNvPr>
@@ -12286,7 +12286,7 @@
           <p:cNvPr id="28" name="">
             <a:extLst xmlns:a="http://schemas.openxmlformats.org/drawingml/2006/main">
               <a:ext uri="{FF2B5EF4-FFF2-40B4-BE49-F238E27FC236}">
-                <a16:creationId xmlns:a16="http://schemas.microsoft.com/office/drawing/2014/main" id="{2C83615C-C39F-4654-A869-4A41BB0BAC79}"/>
+                <a16:creationId xmlns:a16="http://schemas.microsoft.com/office/drawing/2014/main" id="{407A95D9-B3CE-4818-BE53-B8EE304D7ECC}"/>
               </a:ext>
             </a:extLst>
           </p:cNvPr>
@@ -12321,7 +12321,7 @@
           <p:cNvPr id="29" name="">
             <a:extLst xmlns:a="http://schemas.openxmlformats.org/drawingml/2006/main">
               <a:ext uri="{FF2B5EF4-FFF2-40B4-BE49-F238E27FC236}">
-                <a16:creationId xmlns:a16="http://schemas.microsoft.com/office/drawing/2014/main" id="{6064BD52-F8F8-4E6E-B256-F4AECB9AAAC2}"/>
+                <a16:creationId xmlns:a16="http://schemas.microsoft.com/office/drawing/2014/main" id="{2C4B1377-1237-4E2A-8A47-3298867A6A23}"/>
               </a:ext>
             </a:extLst>
           </p:cNvPr>
@@ -12356,7 +12356,7 @@
           <p:cNvPr id="30" name="">
             <a:extLst xmlns:a="http://schemas.openxmlformats.org/drawingml/2006/main">
               <a:ext uri="{FF2B5EF4-FFF2-40B4-BE49-F238E27FC236}">
-                <a16:creationId xmlns:a16="http://schemas.microsoft.com/office/drawing/2014/main" id="{4935A300-5489-421E-B216-BAEB0ECFE9F7}"/>
+                <a16:creationId xmlns:a16="http://schemas.microsoft.com/office/drawing/2014/main" id="{613DD4E4-171F-48DD-938D-1415CED42874}"/>
               </a:ext>
             </a:extLst>
           </p:cNvPr>
@@ -12513,7 +12513,7 @@
           <p:cNvPr id="31" name="">
             <a:extLst xmlns:a="http://schemas.openxmlformats.org/drawingml/2006/main">
               <a:ext uri="{FF2B5EF4-FFF2-40B4-BE49-F238E27FC236}">
-                <a16:creationId xmlns:a16="http://schemas.microsoft.com/office/drawing/2014/main" id="{491177F0-11DF-4434-BF0D-2CDAC549C660}"/>
+                <a16:creationId xmlns:a16="http://schemas.microsoft.com/office/drawing/2014/main" id="{E934898A-30ED-42A6-9DB9-EBF11AC80A02}"/>
               </a:ext>
             </a:extLst>
           </p:cNvPr>
@@ -12670,7 +12670,7 @@
           <p:cNvPr id="32" name="">
             <a:extLst xmlns:a="http://schemas.openxmlformats.org/drawingml/2006/main">
               <a:ext uri="{FF2B5EF4-FFF2-40B4-BE49-F238E27FC236}">
-                <a16:creationId xmlns:a16="http://schemas.microsoft.com/office/drawing/2014/main" id="{620B7701-3EB6-4BA6-81AA-25C07E39419E}"/>
+                <a16:creationId xmlns:a16="http://schemas.microsoft.com/office/drawing/2014/main" id="{8BE0644C-75E0-4EF5-B5C7-BA68DA9589D2}"/>
               </a:ext>
             </a:extLst>
           </p:cNvPr>
@@ -12817,7 +12817,7 @@
                 <a:ea typeface="Aptos"/>
                 <a:cs typeface="Aptos"/>
               </a:rPr>
-              <a:t>digest + ledger head</a:t>
+              <a:t>receipts + ledger</a:t>
             </a:r>
           </a:p>
         </p:txBody>
@@ -12827,7 +12827,7 @@
           <p:cNvPr id="33" name="">
             <a:extLst xmlns:a="http://schemas.openxmlformats.org/drawingml/2006/main">
               <a:ext uri="{FF2B5EF4-FFF2-40B4-BE49-F238E27FC236}">
-                <a16:creationId xmlns:a16="http://schemas.microsoft.com/office/drawing/2014/main" id="{096E2EAB-6A36-4C66-B57E-C263E3237670}"/>
+                <a16:creationId xmlns:a16="http://schemas.microsoft.com/office/drawing/2014/main" id="{4B205D06-B9A6-41A7-B41F-AD1F153AE3D6}"/>
               </a:ext>
             </a:extLst>
           </p:cNvPr>
@@ -12862,7 +12862,7 @@
           <p:cNvPr id="34" name="">
             <a:extLst xmlns:a="http://schemas.openxmlformats.org/drawingml/2006/main">
               <a:ext uri="{FF2B5EF4-FFF2-40B4-BE49-F238E27FC236}">
-                <a16:creationId xmlns:a16="http://schemas.microsoft.com/office/drawing/2014/main" id="{780C275B-858E-46E3-A544-55D266CBA53B}"/>
+                <a16:creationId xmlns:a16="http://schemas.microsoft.com/office/drawing/2014/main" id="{DAA44EA2-2132-480F-B345-CA85EB6F5C7C}"/>
               </a:ext>
             </a:extLst>
           </p:cNvPr>
@@ -12882,11 +12882,11 @@
             </a:avLst>
           </a:prstGeom>
           <a:solidFill xmlns:a="http://schemas.openxmlformats.org/drawingml/2006/main">
-            <a:srgbClr val="FFBF69"/>
+            <a:srgbClr val="57D49B"/>
           </a:solidFill>
           <a:ln xmlns:a="http://schemas.openxmlformats.org/drawingml/2006/main" w="9525">
             <a:solidFill>
-              <a:srgbClr val="FFBF69"/>
+              <a:srgbClr val="57D49B"/>
             </a:solidFill>
             <a:prstDash val="solid"/>
           </a:ln>
@@ -12897,7 +12897,7 @@
           <p:cNvPr id="35" name="">
             <a:extLst xmlns:a="http://schemas.openxmlformats.org/drawingml/2006/main">
               <a:ext uri="{FF2B5EF4-FFF2-40B4-BE49-F238E27FC236}">
-                <a16:creationId xmlns:a16="http://schemas.microsoft.com/office/drawing/2014/main" id="{DA9B6C0D-0F4F-488A-A37C-CF6618E3EBD8}"/>
+                <a16:creationId xmlns:a16="http://schemas.microsoft.com/office/drawing/2014/main" id="{76C6C5A0-F1C9-4453-A48A-D3BC09D5DD79}"/>
               </a:ext>
             </a:extLst>
           </p:cNvPr>
@@ -13044,7 +13044,7 @@
                 <a:ea typeface="Aptos"/>
                 <a:cs typeface="Aptos"/>
               </a:rPr>
-              <a:t>RELEASE GATE</a:t>
+              <a:t>VERIFIED LIVE</a:t>
             </a:r>
           </a:p>
         </p:txBody>
@@ -13054,7 +13054,7 @@
           <p:cNvPr id="36" name="">
             <a:extLst xmlns:a="http://schemas.openxmlformats.org/drawingml/2006/main">
               <a:ext uri="{FF2B5EF4-FFF2-40B4-BE49-F238E27FC236}">
-                <a16:creationId xmlns:a16="http://schemas.microsoft.com/office/drawing/2014/main" id="{A089C501-0578-4B1E-8291-893E8069900A}"/>
+                <a16:creationId xmlns:a16="http://schemas.microsoft.com/office/drawing/2014/main" id="{3A6785C5-9185-4E76-99FB-D5BE182B8C1A}"/>
               </a:ext>
             </a:extLst>
           </p:cNvPr>
@@ -13066,7 +13066,7 @@
         <p:spPr>
           <a:xfrm xmlns:a="http://schemas.openxmlformats.org/drawingml/2006/main">
             <a:off x="2324100" y="5105400"/>
-            <a:ext cx="3429000" cy="323850"/>
+            <a:ext cx="4762500" cy="323850"/>
           </a:xfrm>
           <a:prstGeom xmlns:a="http://schemas.openxmlformats.org/drawingml/2006/main" prst="rect">
             <a:avLst/>
@@ -13201,7 +13201,7 @@
                 <a:ea typeface="Aptos"/>
                 <a:cs typeface="Aptos"/>
               </a:rPr>
-              <a:t>No credentials → no live claim</a:t>
+              <a:t>Zetaris → VELQIRIS → Meterless</a:t>
             </a:r>
           </a:p>
         </p:txBody>
@@ -13211,7 +13211,7 @@
           <p:cNvPr id="37" name="">
             <a:extLst xmlns:a="http://schemas.openxmlformats.org/drawingml/2006/main">
               <a:ext uri="{FF2B5EF4-FFF2-40B4-BE49-F238E27FC236}">
-                <a16:creationId xmlns:a16="http://schemas.microsoft.com/office/drawing/2014/main" id="{0C705901-D314-40CD-8757-C659F2DDB700}"/>
+                <a16:creationId xmlns:a16="http://schemas.microsoft.com/office/drawing/2014/main" id="{48DC51D1-EB39-4A35-BA49-565572E1E058}"/>
               </a:ext>
             </a:extLst>
           </p:cNvPr>
@@ -13358,7 +13358,7 @@
                 <a:ea typeface="Aptos"/>
                 <a:cs typeface="Aptos"/>
               </a:rPr>
-              <a:t>Fixtures run only with --dry-run and are labelled OFFLINE_SIMULATION in the evidence record.</a:t>
+              <a:t>The market rows are declared synthetic inputs executed live in Zetaris; no production-feed claim is made.</a:t>
             </a:r>
           </a:p>
         </p:txBody>
@@ -13368,7 +13368,7 @@
           <p:cNvPr id="38" name="">
             <a:extLst xmlns:a="http://schemas.openxmlformats.org/drawingml/2006/main">
               <a:ext uri="{FF2B5EF4-FFF2-40B4-BE49-F238E27FC236}">
-                <a16:creationId xmlns:a16="http://schemas.microsoft.com/office/drawing/2014/main" id="{54769A5E-5198-4713-B48C-3EAA40F1AAC3}"/>
+                <a16:creationId xmlns:a16="http://schemas.microsoft.com/office/drawing/2014/main" id="{C7250CE2-F2A9-4EE8-A325-1776E3115E88}"/>
               </a:ext>
             </a:extLst>
           </p:cNvPr>
@@ -13399,7 +13399,7 @@
           <p:cNvPr id="39" name="">
             <a:extLst xmlns:a="http://schemas.openxmlformats.org/drawingml/2006/main">
               <a:ext uri="{FF2B5EF4-FFF2-40B4-BE49-F238E27FC236}">
-                <a16:creationId xmlns:a16="http://schemas.microsoft.com/office/drawing/2014/main" id="{0B8DD227-F881-4859-96C5-81A6DB2A7964}"/>
+                <a16:creationId xmlns:a16="http://schemas.microsoft.com/office/drawing/2014/main" id="{D155E1D8-0D40-4BF4-B8C3-3C84186DD502}"/>
               </a:ext>
             </a:extLst>
           </p:cNvPr>
@@ -13556,7 +13556,7 @@
           <p:cNvPr id="40" name="">
             <a:extLst xmlns:a="http://schemas.openxmlformats.org/drawingml/2006/main">
               <a:ext uri="{FF2B5EF4-FFF2-40B4-BE49-F238E27FC236}">
-                <a16:creationId xmlns:a16="http://schemas.microsoft.com/office/drawing/2014/main" id="{718BAF09-694F-4308-B9A9-9F42037503A0}"/>
+                <a16:creationId xmlns:a16="http://schemas.microsoft.com/office/drawing/2014/main" id="{DDADF446-AF9D-4A20-B241-29351345BBE9}"/>
               </a:ext>
             </a:extLst>
           </p:cNvPr>
@@ -13711,7 +13711,7 @@
     </p:spTree>
     <p:extLst>
       <p:ext uri="{BB962C8B-B14F-4D97-AF65-F5344CB8AC3E}">
-        <p14:creationId xmlns:p14="http://schemas.microsoft.com/office/powerpoint/2010/main" val="1176487722"/>
+        <p14:creationId xmlns:p14="http://schemas.microsoft.com/office/powerpoint/2010/main" val="1336716940"/>
       </p:ext>
     </p:extLst>
   </p:cSld>
@@ -13742,7 +13742,7 @@
           <p:cNvPr id="33" name="">
             <a:extLst xmlns:a="http://schemas.openxmlformats.org/drawingml/2006/main">
               <a:ext uri="{FF2B5EF4-FFF2-40B4-BE49-F238E27FC236}">
-                <a16:creationId xmlns:a16="http://schemas.microsoft.com/office/drawing/2014/main" id="{21735D35-CDCE-445F-884E-F49758C4181A}"/>
+                <a16:creationId xmlns:a16="http://schemas.microsoft.com/office/drawing/2014/main" id="{FDA32BAA-E8DE-494C-9B6E-3FEF851A522C}"/>
               </a:ext>
             </a:extLst>
           </p:cNvPr>
@@ -13889,7 +13889,7 @@
                 <a:ea typeface="Aptos"/>
                 <a:cs typeface="Aptos"/>
               </a:rPr>
-              <a:t>DECISION ENGINE</a:t>
+              <a:t>ZETARIS EVIDENCE</a:t>
             </a:r>
           </a:p>
         </p:txBody>
@@ -13899,7 +13899,7 @@
           <p:cNvPr id="2" name="">
             <a:extLst xmlns:a="http://schemas.openxmlformats.org/drawingml/2006/main">
               <a:ext uri="{FF2B5EF4-FFF2-40B4-BE49-F238E27FC236}">
-                <a16:creationId xmlns:a16="http://schemas.microsoft.com/office/drawing/2014/main" id="{8568FBD6-55C9-4FD6-A25B-1D86058F8563}"/>
+                <a16:creationId xmlns:a16="http://schemas.microsoft.com/office/drawing/2014/main" id="{E49C3E44-21C1-44C9-993A-88AC8111F172}"/>
               </a:ext>
             </a:extLst>
           </p:cNvPr>
@@ -14046,7 +14046,7 @@
                 <a:ea typeface="Aptos"/>
                 <a:cs typeface="Aptos"/>
               </a:rPr>
-              <a:t>Robust consensus, explicit rejection</a:t>
+              <a:t>Live SQL, robust consensus, explicit rejection</a:t>
             </a:r>
           </a:p>
         </p:txBody>
@@ -14056,7 +14056,7 @@
           <p:cNvPr id="3" name="">
             <a:extLst xmlns:a="http://schemas.openxmlformats.org/drawingml/2006/main">
               <a:ext uri="{FF2B5EF4-FFF2-40B4-BE49-F238E27FC236}">
-                <a16:creationId xmlns:a16="http://schemas.microsoft.com/office/drawing/2014/main" id="{A0E8457C-5791-4CF5-8793-F1081A5A979A}"/>
+                <a16:creationId xmlns:a16="http://schemas.microsoft.com/office/drawing/2014/main" id="{D562B7D0-7C50-42AB-B21C-37221EB50966}"/>
               </a:ext>
             </a:extLst>
           </p:cNvPr>
@@ -14203,7 +14203,7 @@
                 <a:ea typeface="Aptos"/>
                 <a:cs typeface="Aptos"/>
               </a:rPr>
-              <a:t>The sample below is a deterministic offline fixture — useful for reproducibility, never presented as a live venue snapshot.</a:t>
+              <a:t>Four declared synthetic market rows were executed by the official local platform and returned to VELQIRIS.</a:t>
             </a:r>
           </a:p>
         </p:txBody>
@@ -14213,7 +14213,7 @@
           <p:cNvPr id="4" name="">
             <a:extLst xmlns:a="http://schemas.openxmlformats.org/drawingml/2006/main">
               <a:ext uri="{FF2B5EF4-FFF2-40B4-BE49-F238E27FC236}">
-                <a16:creationId xmlns:a16="http://schemas.microsoft.com/office/drawing/2014/main" id="{71127296-B69D-4058-9B56-06D3DEF18E9C}"/>
+                <a16:creationId xmlns:a16="http://schemas.microsoft.com/office/drawing/2014/main" id="{66C83BF7-5220-437F-9F7D-A9B5D9D43BC7}"/>
               </a:ext>
             </a:extLst>
           </p:cNvPr>
@@ -14225,7 +14225,7 @@
         <p:spPr>
           <a:xfrm xmlns:a="http://schemas.openxmlformats.org/drawingml/2006/main">
             <a:off x="609600" y="1943100"/>
-            <a:ext cx="1524000" cy="285750"/>
+            <a:ext cx="1866900" cy="285750"/>
           </a:xfrm>
           <a:prstGeom xmlns:a="http://schemas.openxmlformats.org/drawingml/2006/main" prst="roundRect">
             <a:avLst>
@@ -14233,11 +14233,11 @@
             </a:avLst>
           </a:prstGeom>
           <a:solidFill xmlns:a="http://schemas.openxmlformats.org/drawingml/2006/main">
-            <a:srgbClr val="FFBF69"/>
+            <a:srgbClr val="57D49B"/>
           </a:solidFill>
           <a:ln xmlns:a="http://schemas.openxmlformats.org/drawingml/2006/main" w="9525">
             <a:solidFill>
-              <a:srgbClr val="FFBF69"/>
+              <a:srgbClr val="57D49B"/>
             </a:solidFill>
             <a:prstDash val="solid"/>
           </a:ln>
@@ -14248,7 +14248,7 @@
           <p:cNvPr id="5" name="">
             <a:extLst xmlns:a="http://schemas.openxmlformats.org/drawingml/2006/main">
               <a:ext uri="{FF2B5EF4-FFF2-40B4-BE49-F238E27FC236}">
-                <a16:creationId xmlns:a16="http://schemas.microsoft.com/office/drawing/2014/main" id="{FF31413B-7C35-419D-A38E-DFFBE41C53B0}"/>
+                <a16:creationId xmlns:a16="http://schemas.microsoft.com/office/drawing/2014/main" id="{7798C71F-CD8A-48E5-9E04-1B0C9F7486AA}"/>
               </a:ext>
             </a:extLst>
           </p:cNvPr>
@@ -14260,7 +14260,7 @@
         <p:spPr>
           <a:xfrm xmlns:a="http://schemas.openxmlformats.org/drawingml/2006/main">
             <a:off x="609600" y="1981200"/>
-            <a:ext cx="1524000" cy="209550"/>
+            <a:ext cx="1866900" cy="209550"/>
           </a:xfrm>
           <a:prstGeom xmlns:a="http://schemas.openxmlformats.org/drawingml/2006/main" prst="rect">
             <a:avLst/>
@@ -14395,7 +14395,7 @@
                 <a:ea typeface="Aptos"/>
                 <a:cs typeface="Aptos"/>
               </a:rPr>
-              <a:t>OFFLINE SIMULATION</a:t>
+              <a:t>VERIFIED LIVE EXECUTION</a:t>
             </a:r>
           </a:p>
         </p:txBody>
@@ -14405,7 +14405,7 @@
           <p:cNvPr id="6" name="">
             <a:extLst xmlns:a="http://schemas.openxmlformats.org/drawingml/2006/main">
               <a:ext uri="{FF2B5EF4-FFF2-40B4-BE49-F238E27FC236}">
-                <a16:creationId xmlns:a16="http://schemas.microsoft.com/office/drawing/2014/main" id="{B309B206-38B5-4640-93C1-D1E478D69250}"/>
+                <a16:creationId xmlns:a16="http://schemas.microsoft.com/office/drawing/2014/main" id="{B3317B24-C4AA-4BEC-98E8-7E01F77AE43A}"/>
               </a:ext>
             </a:extLst>
           </p:cNvPr>
@@ -14440,7 +14440,7 @@
           <p:cNvPr id="7" name="">
             <a:extLst xmlns:a="http://schemas.openxmlformats.org/drawingml/2006/main">
               <a:ext uri="{FF2B5EF4-FFF2-40B4-BE49-F238E27FC236}">
-                <a16:creationId xmlns:a16="http://schemas.microsoft.com/office/drawing/2014/main" id="{209F72A7-B787-4DA8-A744-297649F1EF29}"/>
+                <a16:creationId xmlns:a16="http://schemas.microsoft.com/office/drawing/2014/main" id="{D45E454B-1CD0-485C-A7F6-CC5C4CDA6197}"/>
               </a:ext>
             </a:extLst>
           </p:cNvPr>
@@ -14597,7 +14597,7 @@
           <p:cNvPr id="8" name="">
             <a:extLst xmlns:a="http://schemas.openxmlformats.org/drawingml/2006/main">
               <a:ext uri="{FF2B5EF4-FFF2-40B4-BE49-F238E27FC236}">
-                <a16:creationId xmlns:a16="http://schemas.microsoft.com/office/drawing/2014/main" id="{7043689B-D83F-499E-A4D5-8A37057A7633}"/>
+                <a16:creationId xmlns:a16="http://schemas.microsoft.com/office/drawing/2014/main" id="{F25BBB55-FF1A-465D-A5C4-748F58B6343F}"/>
               </a:ext>
             </a:extLst>
           </p:cNvPr>
@@ -14754,7 +14754,7 @@
           <p:cNvPr id="9" name="">
             <a:extLst xmlns:a="http://schemas.openxmlformats.org/drawingml/2006/main">
               <a:ext uri="{FF2B5EF4-FFF2-40B4-BE49-F238E27FC236}">
-                <a16:creationId xmlns:a16="http://schemas.microsoft.com/office/drawing/2014/main" id="{78C0FEE7-D39D-4BEB-9E17-B63EA7E392D5}"/>
+                <a16:creationId xmlns:a16="http://schemas.microsoft.com/office/drawing/2014/main" id="{BC75B96E-7BB9-4EC2-A25D-EC9D81D56E87}"/>
               </a:ext>
             </a:extLst>
           </p:cNvPr>
@@ -14789,7 +14789,7 @@
           <p:cNvPr id="10" name="">
             <a:extLst xmlns:a="http://schemas.openxmlformats.org/drawingml/2006/main">
               <a:ext uri="{FF2B5EF4-FFF2-40B4-BE49-F238E27FC236}">
-                <a16:creationId xmlns:a16="http://schemas.microsoft.com/office/drawing/2014/main" id="{B7B3AB51-E02D-4369-91C2-D739A511424B}"/>
+                <a16:creationId xmlns:a16="http://schemas.microsoft.com/office/drawing/2014/main" id="{F15EF365-98D8-4835-9D51-B5F803F75817}"/>
               </a:ext>
             </a:extLst>
           </p:cNvPr>
@@ -14946,7 +14946,7 @@
           <p:cNvPr id="11" name="">
             <a:extLst xmlns:a="http://schemas.openxmlformats.org/drawingml/2006/main">
               <a:ext uri="{FF2B5EF4-FFF2-40B4-BE49-F238E27FC236}">
-                <a16:creationId xmlns:a16="http://schemas.microsoft.com/office/drawing/2014/main" id="{E5F5F75D-9D63-4E3F-9999-DBD2AC9A26B9}"/>
+                <a16:creationId xmlns:a16="http://schemas.microsoft.com/office/drawing/2014/main" id="{643E678C-AED4-4108-8BA8-42F2F4DCAF1C}"/>
               </a:ext>
             </a:extLst>
           </p:cNvPr>
@@ -15103,7 +15103,7 @@
           <p:cNvPr id="12" name="">
             <a:extLst xmlns:a="http://schemas.openxmlformats.org/drawingml/2006/main">
               <a:ext uri="{FF2B5EF4-FFF2-40B4-BE49-F238E27FC236}">
-                <a16:creationId xmlns:a16="http://schemas.microsoft.com/office/drawing/2014/main" id="{5DD83526-660D-4B17-A348-FDB48F2E095D}"/>
+                <a16:creationId xmlns:a16="http://schemas.microsoft.com/office/drawing/2014/main" id="{6E41D601-5791-45A5-BBD2-4FF4AD46DABF}"/>
               </a:ext>
             </a:extLst>
           </p:cNvPr>
@@ -15138,7 +15138,7 @@
           <p:cNvPr id="13" name="">
             <a:extLst xmlns:a="http://schemas.openxmlformats.org/drawingml/2006/main">
               <a:ext uri="{FF2B5EF4-FFF2-40B4-BE49-F238E27FC236}">
-                <a16:creationId xmlns:a16="http://schemas.microsoft.com/office/drawing/2014/main" id="{749BF2A2-9214-44B0-B9A9-EBB3A70B063E}"/>
+                <a16:creationId xmlns:a16="http://schemas.microsoft.com/office/drawing/2014/main" id="{7573D23E-CB85-4A2C-A321-DDA879DC0562}"/>
               </a:ext>
             </a:extLst>
           </p:cNvPr>
@@ -15295,7 +15295,7 @@
           <p:cNvPr id="14" name="">
             <a:extLst xmlns:a="http://schemas.openxmlformats.org/drawingml/2006/main">
               <a:ext uri="{FF2B5EF4-FFF2-40B4-BE49-F238E27FC236}">
-                <a16:creationId xmlns:a16="http://schemas.microsoft.com/office/drawing/2014/main" id="{A5797896-6525-4183-95C1-CE2A2B3709BF}"/>
+                <a16:creationId xmlns:a16="http://schemas.microsoft.com/office/drawing/2014/main" id="{B003E03A-A21F-45F0-B3DF-DD1C14ED3A38}"/>
               </a:ext>
             </a:extLst>
           </p:cNvPr>
@@ -15452,7 +15452,7 @@
           <p:cNvPr id="15" name="">
             <a:extLst xmlns:a="http://schemas.openxmlformats.org/drawingml/2006/main">
               <a:ext uri="{FF2B5EF4-FFF2-40B4-BE49-F238E27FC236}">
-                <a16:creationId xmlns:a16="http://schemas.microsoft.com/office/drawing/2014/main" id="{FDB7E879-A446-4260-8E3B-3E47D9C47AFC}"/>
+                <a16:creationId xmlns:a16="http://schemas.microsoft.com/office/drawing/2014/main" id="{A23CA8BA-6CC8-468E-B068-81B82B0785E9}"/>
               </a:ext>
             </a:extLst>
           </p:cNvPr>
@@ -15487,7 +15487,7 @@
           <p:cNvPr id="16" name="">
             <a:extLst xmlns:a="http://schemas.openxmlformats.org/drawingml/2006/main">
               <a:ext uri="{FF2B5EF4-FFF2-40B4-BE49-F238E27FC236}">
-                <a16:creationId xmlns:a16="http://schemas.microsoft.com/office/drawing/2014/main" id="{8DF1751E-280B-45B3-891F-F82AE4EA7299}"/>
+                <a16:creationId xmlns:a16="http://schemas.microsoft.com/office/drawing/2014/main" id="{24F09E21-2AF3-4D69-BFE5-8D8717F941FB}"/>
               </a:ext>
             </a:extLst>
           </p:cNvPr>
@@ -15644,7 +15644,7 @@
           <p:cNvPr id="17" name="">
             <a:extLst xmlns:a="http://schemas.openxmlformats.org/drawingml/2006/main">
               <a:ext uri="{FF2B5EF4-FFF2-40B4-BE49-F238E27FC236}">
-                <a16:creationId xmlns:a16="http://schemas.microsoft.com/office/drawing/2014/main" id="{74C52FA0-A4F5-4D7D-985E-2FC5146891E4}"/>
+                <a16:creationId xmlns:a16="http://schemas.microsoft.com/office/drawing/2014/main" id="{75981258-1683-4C87-88AB-CDF06686DBEF}"/>
               </a:ext>
             </a:extLst>
           </p:cNvPr>
@@ -15801,7 +15801,7 @@
           <p:cNvPr id="18" name="">
             <a:extLst xmlns:a="http://schemas.openxmlformats.org/drawingml/2006/main">
               <a:ext uri="{FF2B5EF4-FFF2-40B4-BE49-F238E27FC236}">
-                <a16:creationId xmlns:a16="http://schemas.microsoft.com/office/drawing/2014/main" id="{1D30BE06-CDAC-44DA-9C7D-1DB5EB3B21AA}"/>
+                <a16:creationId xmlns:a16="http://schemas.microsoft.com/office/drawing/2014/main" id="{C1D0F904-2FDE-4B62-A785-6EA82288B7FC}"/>
               </a:ext>
             </a:extLst>
           </p:cNvPr>
@@ -15958,7 +15958,7 @@
           <p:cNvPr id="19" name="">
             <a:extLst xmlns:a="http://schemas.openxmlformats.org/drawingml/2006/main">
               <a:ext uri="{FF2B5EF4-FFF2-40B4-BE49-F238E27FC236}">
-                <a16:creationId xmlns:a16="http://schemas.microsoft.com/office/drawing/2014/main" id="{A7B42EC6-D3FF-4B79-B911-667E6BBCCFBE}"/>
+                <a16:creationId xmlns:a16="http://schemas.microsoft.com/office/drawing/2014/main" id="{C134B0A2-CF60-40C1-9EF3-F458017669E0}"/>
               </a:ext>
             </a:extLst>
           </p:cNvPr>
@@ -16115,7 +16115,7 @@
           <p:cNvPr id="20" name="">
             <a:extLst xmlns:a="http://schemas.openxmlformats.org/drawingml/2006/main">
               <a:ext uri="{FF2B5EF4-FFF2-40B4-BE49-F238E27FC236}">
-                <a16:creationId xmlns:a16="http://schemas.microsoft.com/office/drawing/2014/main" id="{61A839CA-7682-4CD2-85C5-41FF904C64FF}"/>
+                <a16:creationId xmlns:a16="http://schemas.microsoft.com/office/drawing/2014/main" id="{38B12122-1F04-47FD-AE49-03B1F12BB587}"/>
               </a:ext>
             </a:extLst>
           </p:cNvPr>
@@ -16150,7 +16150,7 @@
           <p:cNvPr id="21" name="">
             <a:extLst xmlns:a="http://schemas.openxmlformats.org/drawingml/2006/main">
               <a:ext uri="{FF2B5EF4-FFF2-40B4-BE49-F238E27FC236}">
-                <a16:creationId xmlns:a16="http://schemas.microsoft.com/office/drawing/2014/main" id="{B892BF1E-9D46-4812-B485-8907B4FEFA6D}"/>
+                <a16:creationId xmlns:a16="http://schemas.microsoft.com/office/drawing/2014/main" id="{C15A2E5E-9E9A-46B2-88B1-ACF494A64EAD}"/>
               </a:ext>
             </a:extLst>
           </p:cNvPr>
@@ -16307,7 +16307,7 @@
           <p:cNvPr id="22" name="">
             <a:extLst xmlns:a="http://schemas.openxmlformats.org/drawingml/2006/main">
               <a:ext uri="{FF2B5EF4-FFF2-40B4-BE49-F238E27FC236}">
-                <a16:creationId xmlns:a16="http://schemas.microsoft.com/office/drawing/2014/main" id="{FC9983B0-DF60-4CFA-907F-4366A34A8F4D}"/>
+                <a16:creationId xmlns:a16="http://schemas.microsoft.com/office/drawing/2014/main" id="{D540379A-F9A2-4DB4-97F6-90DD1438889B}"/>
               </a:ext>
             </a:extLst>
           </p:cNvPr>
@@ -16342,7 +16342,7 @@
           <p:cNvPr id="23" name="">
             <a:extLst xmlns:a="http://schemas.openxmlformats.org/drawingml/2006/main">
               <a:ext uri="{FF2B5EF4-FFF2-40B4-BE49-F238E27FC236}">
-                <a16:creationId xmlns:a16="http://schemas.microsoft.com/office/drawing/2014/main" id="{11F41A51-00D2-498F-BB25-76FDF2507C4E}"/>
+                <a16:creationId xmlns:a16="http://schemas.microsoft.com/office/drawing/2014/main" id="{9596C8EF-5A88-498B-B17F-62F65963CD44}"/>
               </a:ext>
             </a:extLst>
           </p:cNvPr>
@@ -16499,7 +16499,7 @@
           <p:cNvPr id="24" name="">
             <a:extLst xmlns:a="http://schemas.openxmlformats.org/drawingml/2006/main">
               <a:ext uri="{FF2B5EF4-FFF2-40B4-BE49-F238E27FC236}">
-                <a16:creationId xmlns:a16="http://schemas.microsoft.com/office/drawing/2014/main" id="{07545AF1-7622-4A95-AFC4-DF99F00FB50F}"/>
+                <a16:creationId xmlns:a16="http://schemas.microsoft.com/office/drawing/2014/main" id="{F6A3C444-D777-43F6-A463-B1AD1FD1C664}"/>
               </a:ext>
             </a:extLst>
           </p:cNvPr>
@@ -16534,7 +16534,7 @@
           <p:cNvPr id="25" name="">
             <a:extLst xmlns:a="http://schemas.openxmlformats.org/drawingml/2006/main">
               <a:ext uri="{FF2B5EF4-FFF2-40B4-BE49-F238E27FC236}">
-                <a16:creationId xmlns:a16="http://schemas.microsoft.com/office/drawing/2014/main" id="{9C1E0DEF-58D6-4267-A339-11D6ADC40FA8}"/>
+                <a16:creationId xmlns:a16="http://schemas.microsoft.com/office/drawing/2014/main" id="{6FFC5CDE-6C43-4C24-90E9-2AE25A0ECA44}"/>
               </a:ext>
             </a:extLst>
           </p:cNvPr>
@@ -16691,7 +16691,7 @@
           <p:cNvPr id="26" name="">
             <a:extLst xmlns:a="http://schemas.openxmlformats.org/drawingml/2006/main">
               <a:ext uri="{FF2B5EF4-FFF2-40B4-BE49-F238E27FC236}">
-                <a16:creationId xmlns:a16="http://schemas.microsoft.com/office/drawing/2014/main" id="{B8F6CA85-A9CC-465E-A17E-692980F87A2D}"/>
+                <a16:creationId xmlns:a16="http://schemas.microsoft.com/office/drawing/2014/main" id="{087A9806-065C-4618-AB2D-45233EAB8849}"/>
               </a:ext>
             </a:extLst>
           </p:cNvPr>
@@ -16726,7 +16726,7 @@
           <p:cNvPr id="27" name="">
             <a:extLst xmlns:a="http://schemas.openxmlformats.org/drawingml/2006/main">
               <a:ext uri="{FF2B5EF4-FFF2-40B4-BE49-F238E27FC236}">
-                <a16:creationId xmlns:a16="http://schemas.microsoft.com/office/drawing/2014/main" id="{7FAD90B7-E5D3-49E0-8475-6E4EAC14ECA1}"/>
+                <a16:creationId xmlns:a16="http://schemas.microsoft.com/office/drawing/2014/main" id="{09878BB4-210D-46DD-A2F5-17CD114728E1}"/>
               </a:ext>
             </a:extLst>
           </p:cNvPr>
@@ -16883,7 +16883,7 @@
           <p:cNvPr id="28" name="">
             <a:extLst xmlns:a="http://schemas.openxmlformats.org/drawingml/2006/main">
               <a:ext uri="{FF2B5EF4-FFF2-40B4-BE49-F238E27FC236}">
-                <a16:creationId xmlns:a16="http://schemas.microsoft.com/office/drawing/2014/main" id="{701628AA-E328-4604-8F9E-5BC66328088A}"/>
+                <a16:creationId xmlns:a16="http://schemas.microsoft.com/office/drawing/2014/main" id="{A10FD496-4E19-4F9D-92BD-45769CBC0D60}"/>
               </a:ext>
             </a:extLst>
           </p:cNvPr>
@@ -16918,7 +16918,7 @@
           <p:cNvPr id="29" name="">
             <a:extLst xmlns:a="http://schemas.openxmlformats.org/drawingml/2006/main">
               <a:ext uri="{FF2B5EF4-FFF2-40B4-BE49-F238E27FC236}">
-                <a16:creationId xmlns:a16="http://schemas.microsoft.com/office/drawing/2014/main" id="{F4B430CB-4B33-45A4-BFF9-982331701CCB}"/>
+                <a16:creationId xmlns:a16="http://schemas.microsoft.com/office/drawing/2014/main" id="{E401A4E3-3CC9-4CBF-B5DF-317899B2FA8E}"/>
               </a:ext>
             </a:extLst>
           </p:cNvPr>
@@ -17065,7 +17065,7 @@
                 <a:ea typeface="Aptos"/>
                 <a:cs typeface="Aptos"/>
               </a:rPr>
-              <a:t>Every result is sealed with a SHA‑256 integrity digest.</a:t>
+              <a:t>SHA‑256 is an integrity digest, not a digital signature.</a:t>
             </a:r>
           </a:p>
         </p:txBody>
@@ -17075,7 +17075,7 @@
           <p:cNvPr id="30" name="">
             <a:extLst xmlns:a="http://schemas.openxmlformats.org/drawingml/2006/main">
               <a:ext uri="{FF2B5EF4-FFF2-40B4-BE49-F238E27FC236}">
-                <a16:creationId xmlns:a16="http://schemas.microsoft.com/office/drawing/2014/main" id="{5AEAFF47-E754-421C-B661-3BAAA7C7684C}"/>
+                <a16:creationId xmlns:a16="http://schemas.microsoft.com/office/drawing/2014/main" id="{5FFF2A3A-37CD-4BFF-89CD-3FF812FC6643}"/>
               </a:ext>
             </a:extLst>
           </p:cNvPr>
@@ -17106,7 +17106,7 @@
           <p:cNvPr id="31" name="">
             <a:extLst xmlns:a="http://schemas.openxmlformats.org/drawingml/2006/main">
               <a:ext uri="{FF2B5EF4-FFF2-40B4-BE49-F238E27FC236}">
-                <a16:creationId xmlns:a16="http://schemas.microsoft.com/office/drawing/2014/main" id="{7636B51F-1080-4A33-9539-71FAA3BB41C1}"/>
+                <a16:creationId xmlns:a16="http://schemas.microsoft.com/office/drawing/2014/main" id="{FF6CF825-8D64-477D-9B37-725E4C18B057}"/>
               </a:ext>
             </a:extLst>
           </p:cNvPr>
@@ -17263,7 +17263,7 @@
           <p:cNvPr id="32" name="">
             <a:extLst xmlns:a="http://schemas.openxmlformats.org/drawingml/2006/main">
               <a:ext uri="{FF2B5EF4-FFF2-40B4-BE49-F238E27FC236}">
-                <a16:creationId xmlns:a16="http://schemas.microsoft.com/office/drawing/2014/main" id="{3999AA50-9F94-4F99-B2C2-67843A84038F}"/>
+                <a16:creationId xmlns:a16="http://schemas.microsoft.com/office/drawing/2014/main" id="{88AA3780-C883-44D0-AE94-407C124B3729}"/>
               </a:ext>
             </a:extLst>
           </p:cNvPr>
@@ -17418,7 +17418,7 @@
     </p:spTree>
     <p:extLst>
       <p:ext uri="{BB962C8B-B14F-4D97-AF65-F5344CB8AC3E}">
-        <p14:creationId xmlns:p14="http://schemas.microsoft.com/office/powerpoint/2010/main" val="1926473638"/>
+        <p14:creationId xmlns:p14="http://schemas.microsoft.com/office/powerpoint/2010/main" val="1769325731"/>
       </p:ext>
     </p:extLst>
   </p:cSld>
@@ -17449,7 +17449,7 @@
           <p:cNvPr id="31" name="">
             <a:extLst xmlns:a="http://schemas.openxmlformats.org/drawingml/2006/main">
               <a:ext uri="{FF2B5EF4-FFF2-40B4-BE49-F238E27FC236}">
-                <a16:creationId xmlns:a16="http://schemas.microsoft.com/office/drawing/2014/main" id="{C72CC3C8-D66C-49DA-B1A0-BD2803A25CC4}"/>
+                <a16:creationId xmlns:a16="http://schemas.microsoft.com/office/drawing/2014/main" id="{3796E35C-2433-44BE-8261-33C2FEEF9265}"/>
               </a:ext>
             </a:extLst>
           </p:cNvPr>
@@ -17606,7 +17606,7 @@
           <p:cNvPr id="2" name="">
             <a:extLst xmlns:a="http://schemas.openxmlformats.org/drawingml/2006/main">
               <a:ext uri="{FF2B5EF4-FFF2-40B4-BE49-F238E27FC236}">
-                <a16:creationId xmlns:a16="http://schemas.microsoft.com/office/drawing/2014/main" id="{F67C8AD5-03A9-42CE-9C73-406E85895794}"/>
+                <a16:creationId xmlns:a16="http://schemas.microsoft.com/office/drawing/2014/main" id="{007B4357-10E8-43A0-A4CA-08A3E48ECC65}"/>
               </a:ext>
             </a:extLst>
           </p:cNvPr>
@@ -17753,7 +17753,7 @@
                 <a:ea typeface="Aptos"/>
                 <a:cs typeface="Aptos"/>
               </a:rPr>
-              <a:t>H‑MEM turns a result into durable, auditable context</a:t>
+              <a:t>Official H‑MEM reference: store, retrieve, audit</a:t>
             </a:r>
           </a:p>
         </p:txBody>
@@ -17763,7 +17763,7 @@
           <p:cNvPr id="3" name="">
             <a:extLst xmlns:a="http://schemas.openxmlformats.org/drawingml/2006/main">
               <a:ext uri="{FF2B5EF4-FFF2-40B4-BE49-F238E27FC236}">
-                <a16:creationId xmlns:a16="http://schemas.microsoft.com/office/drawing/2014/main" id="{EA8F2896-CE97-4E60-AB6F-5CE36BB8C7E6}"/>
+                <a16:creationId xmlns:a16="http://schemas.microsoft.com/office/drawing/2014/main" id="{3B1330E2-E557-45DF-82D3-6F3700DA0900}"/>
               </a:ext>
             </a:extLst>
           </p:cNvPr>
@@ -17910,7 +17910,7 @@
                 <a:ea typeface="Aptos"/>
                 <a:cs typeface="Aptos"/>
               </a:rPr>
-              <a:t>The release implements the exact profile it uses — and names the services it does not claim.</a:t>
+              <a:t>The upstream implementation and conformance vectors are vendored with commit provenance and Apache-2.0 licensing.</a:t>
             </a:r>
           </a:p>
         </p:txBody>
@@ -17920,7 +17920,7 @@
           <p:cNvPr id="4" name="">
             <a:extLst xmlns:a="http://schemas.openxmlformats.org/drawingml/2006/main">
               <a:ext uri="{FF2B5EF4-FFF2-40B4-BE49-F238E27FC236}">
-                <a16:creationId xmlns:a16="http://schemas.microsoft.com/office/drawing/2014/main" id="{ACF67097-43BE-4755-AA4F-30DB554DC676}"/>
+                <a16:creationId xmlns:a16="http://schemas.microsoft.com/office/drawing/2014/main" id="{A349DD3D-BF24-427C-B9BF-DDAEB2E271A8}"/>
               </a:ext>
             </a:extLst>
           </p:cNvPr>
@@ -17955,7 +17955,7 @@
           <p:cNvPr id="5" name="">
             <a:extLst xmlns:a="http://schemas.openxmlformats.org/drawingml/2006/main">
               <a:ext uri="{FF2B5EF4-FFF2-40B4-BE49-F238E27FC236}">
-                <a16:creationId xmlns:a16="http://schemas.microsoft.com/office/drawing/2014/main" id="{E894ABF8-997C-49A2-ABF2-AAF8B954C1E7}"/>
+                <a16:creationId xmlns:a16="http://schemas.microsoft.com/office/drawing/2014/main" id="{385EAC8E-C771-4CD5-BA35-A6226E68C8D6}"/>
               </a:ext>
             </a:extLst>
           </p:cNvPr>
@@ -17990,7 +17990,7 @@
           <p:cNvPr id="6" name="">
             <a:extLst xmlns:a="http://schemas.openxmlformats.org/drawingml/2006/main">
               <a:ext uri="{FF2B5EF4-FFF2-40B4-BE49-F238E27FC236}">
-                <a16:creationId xmlns:a16="http://schemas.microsoft.com/office/drawing/2014/main" id="{7C313935-104B-416B-90EC-1EA0426BC452}"/>
+                <a16:creationId xmlns:a16="http://schemas.microsoft.com/office/drawing/2014/main" id="{C5C6534E-FF3A-4C0D-96A7-CCAD550C19B3}"/>
               </a:ext>
             </a:extLst>
           </p:cNvPr>
@@ -18147,7 +18147,7 @@
           <p:cNvPr id="7" name="">
             <a:extLst xmlns:a="http://schemas.openxmlformats.org/drawingml/2006/main">
               <a:ext uri="{FF2B5EF4-FFF2-40B4-BE49-F238E27FC236}">
-                <a16:creationId xmlns:a16="http://schemas.microsoft.com/office/drawing/2014/main" id="{434A38C6-38B9-48A6-AEB7-3F18B8EF7C86}"/>
+                <a16:creationId xmlns:a16="http://schemas.microsoft.com/office/drawing/2014/main" id="{D3AB1EB1-ED99-4BAA-A538-F5AC583175A6}"/>
               </a:ext>
             </a:extLst>
           </p:cNvPr>
@@ -18304,7 +18304,7 @@
           <p:cNvPr id="8" name="">
             <a:extLst xmlns:a="http://schemas.openxmlformats.org/drawingml/2006/main">
               <a:ext uri="{FF2B5EF4-FFF2-40B4-BE49-F238E27FC236}">
-                <a16:creationId xmlns:a16="http://schemas.microsoft.com/office/drawing/2014/main" id="{CA51B48E-B4D3-4491-8F7D-911EF0C87A32}"/>
+                <a16:creationId xmlns:a16="http://schemas.microsoft.com/office/drawing/2014/main" id="{4528F923-53FD-4041-B9C6-239667460F06}"/>
               </a:ext>
             </a:extLst>
           </p:cNvPr>
@@ -18461,7 +18461,7 @@
           <p:cNvPr id="9" name="">
             <a:extLst xmlns:a="http://schemas.openxmlformats.org/drawingml/2006/main">
               <a:ext uri="{FF2B5EF4-FFF2-40B4-BE49-F238E27FC236}">
-                <a16:creationId xmlns:a16="http://schemas.microsoft.com/office/drawing/2014/main" id="{B1606CF7-414E-456A-9F5A-B5FC80FAD393}"/>
+                <a16:creationId xmlns:a16="http://schemas.microsoft.com/office/drawing/2014/main" id="{E0DD4289-BE79-4BB0-BD8C-6067323D7E5D}"/>
               </a:ext>
             </a:extLst>
           </p:cNvPr>
@@ -18496,7 +18496,7 @@
           <p:cNvPr id="10" name="">
             <a:extLst xmlns:a="http://schemas.openxmlformats.org/drawingml/2006/main">
               <a:ext uri="{FF2B5EF4-FFF2-40B4-BE49-F238E27FC236}">
-                <a16:creationId xmlns:a16="http://schemas.microsoft.com/office/drawing/2014/main" id="{6BBE29AA-76C9-45A3-A083-B29AEF61F043}"/>
+                <a16:creationId xmlns:a16="http://schemas.microsoft.com/office/drawing/2014/main" id="{D22EC46C-7A28-4671-A623-00AC4B214ABB}"/>
               </a:ext>
             </a:extLst>
           </p:cNvPr>
@@ -18531,7 +18531,7 @@
           <p:cNvPr id="11" name="">
             <a:extLst xmlns:a="http://schemas.openxmlformats.org/drawingml/2006/main">
               <a:ext uri="{FF2B5EF4-FFF2-40B4-BE49-F238E27FC236}">
-                <a16:creationId xmlns:a16="http://schemas.microsoft.com/office/drawing/2014/main" id="{6159CC23-F250-4ED3-A5C8-A3C8616B66B4}"/>
+                <a16:creationId xmlns:a16="http://schemas.microsoft.com/office/drawing/2014/main" id="{F24A19C4-3EDD-4759-97E6-4CEA1DB160A1}"/>
               </a:ext>
             </a:extLst>
           </p:cNvPr>
@@ -18688,7 +18688,7 @@
           <p:cNvPr id="12" name="">
             <a:extLst xmlns:a="http://schemas.openxmlformats.org/drawingml/2006/main">
               <a:ext uri="{FF2B5EF4-FFF2-40B4-BE49-F238E27FC236}">
-                <a16:creationId xmlns:a16="http://schemas.microsoft.com/office/drawing/2014/main" id="{D45F2820-1A77-4FB1-B065-02E757E9DAAB}"/>
+                <a16:creationId xmlns:a16="http://schemas.microsoft.com/office/drawing/2014/main" id="{743908A7-A834-46B1-BF61-E8988F65211F}"/>
               </a:ext>
             </a:extLst>
           </p:cNvPr>
@@ -18845,7 +18845,7 @@
           <p:cNvPr id="13" name="">
             <a:extLst xmlns:a="http://schemas.openxmlformats.org/drawingml/2006/main">
               <a:ext uri="{FF2B5EF4-FFF2-40B4-BE49-F238E27FC236}">
-                <a16:creationId xmlns:a16="http://schemas.microsoft.com/office/drawing/2014/main" id="{76FBCE98-9E9E-4CA2-ADC6-6273BC012D2E}"/>
+                <a16:creationId xmlns:a16="http://schemas.microsoft.com/office/drawing/2014/main" id="{75E88FAE-AC5E-4846-97E2-4712E03FE30A}"/>
               </a:ext>
             </a:extLst>
           </p:cNvPr>
@@ -19002,7 +19002,7 @@
           <p:cNvPr id="14" name="">
             <a:extLst xmlns:a="http://schemas.openxmlformats.org/drawingml/2006/main">
               <a:ext uri="{FF2B5EF4-FFF2-40B4-BE49-F238E27FC236}">
-                <a16:creationId xmlns:a16="http://schemas.microsoft.com/office/drawing/2014/main" id="{5DC075F1-BD03-457E-A028-0502D4F90CDB}"/>
+                <a16:creationId xmlns:a16="http://schemas.microsoft.com/office/drawing/2014/main" id="{E6FD5968-8B03-4B5C-8EB4-80F01F2C899A}"/>
               </a:ext>
             </a:extLst>
           </p:cNvPr>
@@ -19037,7 +19037,7 @@
           <p:cNvPr id="15" name="">
             <a:extLst xmlns:a="http://schemas.openxmlformats.org/drawingml/2006/main">
               <a:ext uri="{FF2B5EF4-FFF2-40B4-BE49-F238E27FC236}">
-                <a16:creationId xmlns:a16="http://schemas.microsoft.com/office/drawing/2014/main" id="{C2B1CF36-6DCD-4CF3-B32E-A7212B128252}"/>
+                <a16:creationId xmlns:a16="http://schemas.microsoft.com/office/drawing/2014/main" id="{C6BAFBE3-D4A3-4AD5-A5D0-15A5E26175CC}"/>
               </a:ext>
             </a:extLst>
           </p:cNvPr>
@@ -19072,7 +19072,7 @@
           <p:cNvPr id="16" name="">
             <a:extLst xmlns:a="http://schemas.openxmlformats.org/drawingml/2006/main">
               <a:ext uri="{FF2B5EF4-FFF2-40B4-BE49-F238E27FC236}">
-                <a16:creationId xmlns:a16="http://schemas.microsoft.com/office/drawing/2014/main" id="{99732A38-4B01-4FD7-96E2-FC23338FA4A6}"/>
+                <a16:creationId xmlns:a16="http://schemas.microsoft.com/office/drawing/2014/main" id="{FD7DC516-0F7E-49AD-8B6E-F07A73989112}"/>
               </a:ext>
             </a:extLst>
           </p:cNvPr>
@@ -19229,7 +19229,7 @@
           <p:cNvPr id="17" name="">
             <a:extLst xmlns:a="http://schemas.openxmlformats.org/drawingml/2006/main">
               <a:ext uri="{FF2B5EF4-FFF2-40B4-BE49-F238E27FC236}">
-                <a16:creationId xmlns:a16="http://schemas.microsoft.com/office/drawing/2014/main" id="{DD387455-E198-4C14-8694-E6D70FF1B92C}"/>
+                <a16:creationId xmlns:a16="http://schemas.microsoft.com/office/drawing/2014/main" id="{8FD6A904-5C48-43A5-8F01-3B05558DEDD6}"/>
               </a:ext>
             </a:extLst>
           </p:cNvPr>
@@ -19386,7 +19386,7 @@
           <p:cNvPr id="18" name="">
             <a:extLst xmlns:a="http://schemas.openxmlformats.org/drawingml/2006/main">
               <a:ext uri="{FF2B5EF4-FFF2-40B4-BE49-F238E27FC236}">
-                <a16:creationId xmlns:a16="http://schemas.microsoft.com/office/drawing/2014/main" id="{79222453-B96D-4EC2-AD84-B3D298D0F8B5}"/>
+                <a16:creationId xmlns:a16="http://schemas.microsoft.com/office/drawing/2014/main" id="{DE06E238-EF5A-4158-8521-B4DA417AA04E}"/>
               </a:ext>
             </a:extLst>
           </p:cNvPr>
@@ -19533,7 +19533,7 @@
                 <a:ea typeface="Aptos"/>
                 <a:cs typeface="Aptos"/>
               </a:rPr>
-              <a:t>append-only · hash-chained · tamper-evident</a:t>
+              <a:t>append-only · persistent · inspectable</a:t>
             </a:r>
           </a:p>
         </p:txBody>
@@ -19543,7 +19543,7 @@
           <p:cNvPr id="19" name="">
             <a:extLst xmlns:a="http://schemas.openxmlformats.org/drawingml/2006/main">
               <a:ext uri="{FF2B5EF4-FFF2-40B4-BE49-F238E27FC236}">
-                <a16:creationId xmlns:a16="http://schemas.microsoft.com/office/drawing/2014/main" id="{BEBB8A99-5895-439B-9BE6-44DE040C8228}"/>
+                <a16:creationId xmlns:a16="http://schemas.microsoft.com/office/drawing/2014/main" id="{7807F078-5A66-4E1E-9181-6EA022CB97B8}"/>
               </a:ext>
             </a:extLst>
           </p:cNvPr>
@@ -19578,7 +19578,7 @@
           <p:cNvPr id="20" name="">
             <a:extLst xmlns:a="http://schemas.openxmlformats.org/drawingml/2006/main">
               <a:ext uri="{FF2B5EF4-FFF2-40B4-BE49-F238E27FC236}">
-                <a16:creationId xmlns:a16="http://schemas.microsoft.com/office/drawing/2014/main" id="{D1E60FDC-EE4C-4206-99B4-40F6E6F5EB47}"/>
+                <a16:creationId xmlns:a16="http://schemas.microsoft.com/office/drawing/2014/main" id="{713D72C2-FF28-4DB8-B4C3-041B75ECF5B4}"/>
               </a:ext>
             </a:extLst>
           </p:cNvPr>
@@ -19735,7 +19735,7 @@
           <p:cNvPr id="21" name="">
             <a:extLst xmlns:a="http://schemas.openxmlformats.org/drawingml/2006/main">
               <a:ext uri="{FF2B5EF4-FFF2-40B4-BE49-F238E27FC236}">
-                <a16:creationId xmlns:a16="http://schemas.microsoft.com/office/drawing/2014/main" id="{967ABE3F-8919-48E3-9872-35A599EBE1E7}"/>
+                <a16:creationId xmlns:a16="http://schemas.microsoft.com/office/drawing/2014/main" id="{1170B82A-96FE-447D-9A62-82B959DAF71E}"/>
               </a:ext>
             </a:extLst>
           </p:cNvPr>
@@ -19892,7 +19892,7 @@
           <p:cNvPr id="22" name="">
             <a:extLst xmlns:a="http://schemas.openxmlformats.org/drawingml/2006/main">
               <a:ext uri="{FF2B5EF4-FFF2-40B4-BE49-F238E27FC236}">
-                <a16:creationId xmlns:a16="http://schemas.microsoft.com/office/drawing/2014/main" id="{823CAF0C-7E08-4604-9588-44FBC88898FE}"/>
+                <a16:creationId xmlns:a16="http://schemas.microsoft.com/office/drawing/2014/main" id="{F939BA12-4A49-4BC7-AAAB-23EFA1BA24CB}"/>
               </a:ext>
             </a:extLst>
           </p:cNvPr>
@@ -20039,7 +20039,7 @@
                 <a:ea typeface="Aptos"/>
                 <a:cs typeface="Aptos"/>
               </a:rPr>
-              <a:t>Meterless H-MEM</a:t>
+              <a:t>official H‑MEM reference</a:t>
             </a:r>
           </a:p>
         </p:txBody>
@@ -20049,7 +20049,7 @@
           <p:cNvPr id="23" name="">
             <a:extLst xmlns:a="http://schemas.openxmlformats.org/drawingml/2006/main">
               <a:ext uri="{FF2B5EF4-FFF2-40B4-BE49-F238E27FC236}">
-                <a16:creationId xmlns:a16="http://schemas.microsoft.com/office/drawing/2014/main" id="{C07A1355-0E4A-40B5-AB76-C756809240D8}"/>
+                <a16:creationId xmlns:a16="http://schemas.microsoft.com/office/drawing/2014/main" id="{8F9B6A7B-8672-48BE-A5EC-E2A2D99E6F78}"/>
               </a:ext>
             </a:extLst>
           </p:cNvPr>
@@ -20206,7 +20206,7 @@
           <p:cNvPr id="24" name="">
             <a:extLst xmlns:a="http://schemas.openxmlformats.org/drawingml/2006/main">
               <a:ext uri="{FF2B5EF4-FFF2-40B4-BE49-F238E27FC236}">
-                <a16:creationId xmlns:a16="http://schemas.microsoft.com/office/drawing/2014/main" id="{687C00CA-829D-485B-B428-6B4EAF3514CC}"/>
+                <a16:creationId xmlns:a16="http://schemas.microsoft.com/office/drawing/2014/main" id="{C8BAE812-1FE6-43F5-8346-6AEAD05F0AB2}"/>
               </a:ext>
             </a:extLst>
           </p:cNvPr>
@@ -20353,7 +20353,7 @@
                 <a:ea typeface="Aptos"/>
                 <a:cs typeface="Aptos"/>
               </a:rPr>
-              <a:t>52815d12eeedc8e1f770…</a:t>
+              <a:t>588971f2a06fb9efb260…</a:t>
             </a:r>
           </a:p>
         </p:txBody>
@@ -20363,7 +20363,7 @@
           <p:cNvPr id="25" name="">
             <a:extLst xmlns:a="http://schemas.openxmlformats.org/drawingml/2006/main">
               <a:ext uri="{FF2B5EF4-FFF2-40B4-BE49-F238E27FC236}">
-                <a16:creationId xmlns:a16="http://schemas.microsoft.com/office/drawing/2014/main" id="{028E6894-B04E-49FC-9BEB-8BF8E4A97068}"/>
+                <a16:creationId xmlns:a16="http://schemas.microsoft.com/office/drawing/2014/main" id="{CEF62B05-47E2-4412-A805-63213AEE7120}"/>
               </a:ext>
             </a:extLst>
           </p:cNvPr>
@@ -20520,7 +20520,7 @@
           <p:cNvPr id="26" name="">
             <a:extLst xmlns:a="http://schemas.openxmlformats.org/drawingml/2006/main">
               <a:ext uri="{FF2B5EF4-FFF2-40B4-BE49-F238E27FC236}">
-                <a16:creationId xmlns:a16="http://schemas.microsoft.com/office/drawing/2014/main" id="{98A3B1F5-B159-4C29-974A-CDB8A432B2A1}"/>
+                <a16:creationId xmlns:a16="http://schemas.microsoft.com/office/drawing/2014/main" id="{A46F19B2-A2F1-42E1-A043-3D8C00C0486D}"/>
               </a:ext>
             </a:extLst>
           </p:cNvPr>
@@ -20667,7 +20667,7 @@
                 <a:ea typeface="Aptos"/>
                 <a:cs typeface="Aptos"/>
               </a:rPr>
-              <a:t>5 H‑MEM + end-to-end</a:t>
+              <a:t>13 / 13 conformance</a:t>
             </a:r>
           </a:p>
         </p:txBody>
@@ -20677,7 +20677,7 @@
           <p:cNvPr id="27" name="">
             <a:extLst xmlns:a="http://schemas.openxmlformats.org/drawingml/2006/main">
               <a:ext uri="{FF2B5EF4-FFF2-40B4-BE49-F238E27FC236}">
-                <a16:creationId xmlns:a16="http://schemas.microsoft.com/office/drawing/2014/main" id="{940C7F15-50CF-4DF7-99ED-387F6256C2E5}"/>
+                <a16:creationId xmlns:a16="http://schemas.microsoft.com/office/drawing/2014/main" id="{2DE63EC1-B44D-401D-A7A8-7E0676835AC3}"/>
               </a:ext>
             </a:extLst>
           </p:cNvPr>
@@ -20824,7 +20824,7 @@
                 <a:ea typeface="Aptos"/>
                 <a:cs typeface="Aptos"/>
               </a:rPr>
-              <a:t>Scope boundary: dreaming, sleep and conflict resolution are not claimed in this hackathon profile.</a:t>
+              <a:t>Runtime receipt: 2 memories stored · 2 retrieved · 4 append-only ledger events.</a:t>
             </a:r>
           </a:p>
         </p:txBody>
@@ -20834,7 +20834,7 @@
           <p:cNvPr id="28" name="">
             <a:extLst xmlns:a="http://schemas.openxmlformats.org/drawingml/2006/main">
               <a:ext uri="{FF2B5EF4-FFF2-40B4-BE49-F238E27FC236}">
-                <a16:creationId xmlns:a16="http://schemas.microsoft.com/office/drawing/2014/main" id="{F92B610F-75CE-4ED2-BFEB-761735A1ED5A}"/>
+                <a16:creationId xmlns:a16="http://schemas.microsoft.com/office/drawing/2014/main" id="{A2BD61BB-817F-4E03-A59E-5E6E3C468238}"/>
               </a:ext>
             </a:extLst>
           </p:cNvPr>
@@ -20865,7 +20865,7 @@
           <p:cNvPr id="29" name="">
             <a:extLst xmlns:a="http://schemas.openxmlformats.org/drawingml/2006/main">
               <a:ext uri="{FF2B5EF4-FFF2-40B4-BE49-F238E27FC236}">
-                <a16:creationId xmlns:a16="http://schemas.microsoft.com/office/drawing/2014/main" id="{BC2C145B-2EE3-4639-990A-BB13D7B4D75B}"/>
+                <a16:creationId xmlns:a16="http://schemas.microsoft.com/office/drawing/2014/main" id="{738A38E1-3EB6-47CB-8970-C58BF5B5FBDC}"/>
               </a:ext>
             </a:extLst>
           </p:cNvPr>
@@ -21022,7 +21022,7 @@
           <p:cNvPr id="30" name="">
             <a:extLst xmlns:a="http://schemas.openxmlformats.org/drawingml/2006/main">
               <a:ext uri="{FF2B5EF4-FFF2-40B4-BE49-F238E27FC236}">
-                <a16:creationId xmlns:a16="http://schemas.microsoft.com/office/drawing/2014/main" id="{8A76EF7A-A164-4301-8723-9B66692328BE}"/>
+                <a16:creationId xmlns:a16="http://schemas.microsoft.com/office/drawing/2014/main" id="{6B84B936-2EA0-4C2E-B005-65A722876B70}"/>
               </a:ext>
             </a:extLst>
           </p:cNvPr>
@@ -21177,7 +21177,7 @@
     </p:spTree>
     <p:extLst>
       <p:ext uri="{BB962C8B-B14F-4D97-AF65-F5344CB8AC3E}">
-        <p14:creationId xmlns:p14="http://schemas.microsoft.com/office/powerpoint/2010/main" val="518547796"/>
+        <p14:creationId xmlns:p14="http://schemas.microsoft.com/office/powerpoint/2010/main" val="1594535154"/>
       </p:ext>
     </p:extLst>
   </p:cSld>
@@ -21208,7 +21208,7 @@
           <p:cNvPr id="32" name="">
             <a:extLst xmlns:a="http://schemas.openxmlformats.org/drawingml/2006/main">
               <a:ext uri="{FF2B5EF4-FFF2-40B4-BE49-F238E27FC236}">
-                <a16:creationId xmlns:a16="http://schemas.microsoft.com/office/drawing/2014/main" id="{6D6B326E-86A7-40A3-AB35-44B6F74849E2}"/>
+                <a16:creationId xmlns:a16="http://schemas.microsoft.com/office/drawing/2014/main" id="{4F809F8F-B838-494B-9E09-D3E7A35B716E}"/>
               </a:ext>
             </a:extLst>
           </p:cNvPr>
@@ -21365,7 +21365,7 @@
           <p:cNvPr id="2" name="">
             <a:extLst xmlns:a="http://schemas.openxmlformats.org/drawingml/2006/main">
               <a:ext uri="{FF2B5EF4-FFF2-40B4-BE49-F238E27FC236}">
-                <a16:creationId xmlns:a16="http://schemas.microsoft.com/office/drawing/2014/main" id="{0050EB53-50B2-4AFE-A67E-845807E4D6D1}"/>
+                <a16:creationId xmlns:a16="http://schemas.microsoft.com/office/drawing/2014/main" id="{8CF047E4-C138-440A-9936-9283CAECBF37}"/>
               </a:ext>
             </a:extLst>
           </p:cNvPr>
@@ -21512,7 +21512,7 @@
                 <a:ea typeface="Aptos"/>
                 <a:cs typeface="Aptos"/>
               </a:rPr>
-              <a:t>Claim boundaries are part of the product</a:t>
+              <a:t>Every public claim has a repository receipt</a:t>
             </a:r>
           </a:p>
         </p:txBody>
@@ -21522,7 +21522,7 @@
           <p:cNvPr id="3" name="">
             <a:extLst xmlns:a="http://schemas.openxmlformats.org/drawingml/2006/main">
               <a:ext uri="{FF2B5EF4-FFF2-40B4-BE49-F238E27FC236}">
-                <a16:creationId xmlns:a16="http://schemas.microsoft.com/office/drawing/2014/main" id="{C9CA6726-DD4A-4266-B89C-26136065466F}"/>
+                <a16:creationId xmlns:a16="http://schemas.microsoft.com/office/drawing/2014/main" id="{E978D81B-3573-45DA-9CC7-B043F95722A1}"/>
               </a:ext>
             </a:extLst>
           </p:cNvPr>
@@ -21669,7 +21669,7 @@
                 <a:ea typeface="Aptos"/>
                 <a:cs typeface="Aptos"/>
               </a:rPr>
-              <a:t>A strong submission distinguishes what is proven, what is simulated and what remains blocked.</a:t>
+              <a:t>The release distinguishes live execution, declared synthetic inputs and capabilities that are not claimed.</a:t>
             </a:r>
           </a:p>
         </p:txBody>
@@ -21679,7 +21679,7 @@
           <p:cNvPr id="4" name="">
             <a:extLst xmlns:a="http://schemas.openxmlformats.org/drawingml/2006/main">
               <a:ext uri="{FF2B5EF4-FFF2-40B4-BE49-F238E27FC236}">
-                <a16:creationId xmlns:a16="http://schemas.microsoft.com/office/drawing/2014/main" id="{FD94EFD1-0BBA-4E7A-9D8F-F087DC2ADE01}"/>
+                <a16:creationId xmlns:a16="http://schemas.microsoft.com/office/drawing/2014/main" id="{928DC326-4633-42B1-8FD4-7B8475B5CF2D}"/>
               </a:ext>
             </a:extLst>
           </p:cNvPr>
@@ -21714,7 +21714,7 @@
           <p:cNvPr id="5" name="">
             <a:extLst xmlns:a="http://schemas.openxmlformats.org/drawingml/2006/main">
               <a:ext uri="{FF2B5EF4-FFF2-40B4-BE49-F238E27FC236}">
-                <a16:creationId xmlns:a16="http://schemas.microsoft.com/office/drawing/2014/main" id="{4891E7E9-BE97-4994-86C6-D7B1DCCBA2F6}"/>
+                <a16:creationId xmlns:a16="http://schemas.microsoft.com/office/drawing/2014/main" id="{4C1DD682-D0EC-4D5A-AAD5-C19221D21A1B}"/>
               </a:ext>
             </a:extLst>
           </p:cNvPr>
@@ -21861,7 +21861,7 @@
                 <a:ea typeface="Aptos"/>
                 <a:cs typeface="Aptos"/>
               </a:rPr>
-              <a:t>Local test suite</a:t>
+              <a:t>Official Zetaris verifier</a:t>
             </a:r>
           </a:p>
         </p:txBody>
@@ -21871,7 +21871,7 @@
           <p:cNvPr id="6" name="">
             <a:extLst xmlns:a="http://schemas.openxmlformats.org/drawingml/2006/main">
               <a:ext uri="{FF2B5EF4-FFF2-40B4-BE49-F238E27FC236}">
-                <a16:creationId xmlns:a16="http://schemas.microsoft.com/office/drawing/2014/main" id="{659704D2-9811-4DF5-A5B6-A90E7A3A73D7}"/>
+                <a16:creationId xmlns:a16="http://schemas.microsoft.com/office/drawing/2014/main" id="{DEEC810A-9163-4E56-8675-C6CE79562DA6}"/>
               </a:ext>
             </a:extLst>
           </p:cNvPr>
@@ -22018,7 +22018,7 @@
                 <a:ea typeface="Aptos"/>
                 <a:cs typeface="Aptos"/>
               </a:rPr>
-              <a:t>21 / 21</a:t>
+              <a:t>UI · API · driver · Spark</a:t>
             </a:r>
           </a:p>
         </p:txBody>
@@ -22028,7 +22028,7 @@
           <p:cNvPr id="7" name="">
             <a:extLst xmlns:a="http://schemas.openxmlformats.org/drawingml/2006/main">
               <a:ext uri="{FF2B5EF4-FFF2-40B4-BE49-F238E27FC236}">
-                <a16:creationId xmlns:a16="http://schemas.microsoft.com/office/drawing/2014/main" id="{B7838C30-06EB-4C27-BDEE-FED0B37C68D1}"/>
+                <a16:creationId xmlns:a16="http://schemas.microsoft.com/office/drawing/2014/main" id="{BDD46AF5-E5C4-47E0-ADD5-DB1FCBDDD403}"/>
               </a:ext>
             </a:extLst>
           </p:cNvPr>
@@ -22063,7 +22063,7 @@
           <p:cNvPr id="8" name="">
             <a:extLst xmlns:a="http://schemas.openxmlformats.org/drawingml/2006/main">
               <a:ext uri="{FF2B5EF4-FFF2-40B4-BE49-F238E27FC236}">
-                <a16:creationId xmlns:a16="http://schemas.microsoft.com/office/drawing/2014/main" id="{9D62E96B-C480-412A-950D-E9FC9AAFB823}"/>
+                <a16:creationId xmlns:a16="http://schemas.microsoft.com/office/drawing/2014/main" id="{BBA89427-503E-4656-9CA8-F5D4AC2B18B9}"/>
               </a:ext>
             </a:extLst>
           </p:cNvPr>
@@ -22210,7 +22210,7 @@
                 <a:ea typeface="Aptos"/>
                 <a:cs typeface="Aptos"/>
               </a:rPr>
-              <a:t>VERIFIED</a:t>
+              <a:t>9 / 9</a:t>
             </a:r>
           </a:p>
         </p:txBody>
@@ -22220,7 +22220,7 @@
           <p:cNvPr id="9" name="">
             <a:extLst xmlns:a="http://schemas.openxmlformats.org/drawingml/2006/main">
               <a:ext uri="{FF2B5EF4-FFF2-40B4-BE49-F238E27FC236}">
-                <a16:creationId xmlns:a16="http://schemas.microsoft.com/office/drawing/2014/main" id="{176A95C2-A43E-4285-9AA2-315BD2F8E79A}"/>
+                <a16:creationId xmlns:a16="http://schemas.microsoft.com/office/drawing/2014/main" id="{68AD4385-54BC-412A-A0FF-A2ED51868D6B}"/>
               </a:ext>
             </a:extLst>
           </p:cNvPr>
@@ -22255,7 +22255,7 @@
           <p:cNvPr id="10" name="">
             <a:extLst xmlns:a="http://schemas.openxmlformats.org/drawingml/2006/main">
               <a:ext uri="{FF2B5EF4-FFF2-40B4-BE49-F238E27FC236}">
-                <a16:creationId xmlns:a16="http://schemas.microsoft.com/office/drawing/2014/main" id="{7A82AB1A-8A12-4DD7-9AA6-B5EB08085055}"/>
+                <a16:creationId xmlns:a16="http://schemas.microsoft.com/office/drawing/2014/main" id="{831477A2-EA31-4175-97BE-0D357CA5D968}"/>
               </a:ext>
             </a:extLst>
           </p:cNvPr>
@@ -22402,7 +22402,7 @@
                 <a:ea typeface="Aptos"/>
                 <a:cs typeface="Aptos"/>
               </a:rPr>
-              <a:t>Meterless H‑MEM profile</a:t>
+              <a:t>Live Zetaris scenario</a:t>
             </a:r>
           </a:p>
         </p:txBody>
@@ -22412,7 +22412,7 @@
           <p:cNvPr id="11" name="">
             <a:extLst xmlns:a="http://schemas.openxmlformats.org/drawingml/2006/main">
               <a:ext uri="{FF2B5EF4-FFF2-40B4-BE49-F238E27FC236}">
-                <a16:creationId xmlns:a16="http://schemas.microsoft.com/office/drawing/2014/main" id="{7D166F05-AC79-4E8D-B2CF-784764195B8B}"/>
+                <a16:creationId xmlns:a16="http://schemas.microsoft.com/office/drawing/2014/main" id="{CFC5B1C7-8CE7-4297-89E5-1F67970D71C9}"/>
               </a:ext>
             </a:extLst>
           </p:cNvPr>
@@ -22559,7 +22559,7 @@
                 <a:ea typeface="Aptos"/>
                 <a:cs typeface="Aptos"/>
               </a:rPr>
-              <a:t>capture · retrieve · ledger</a:t>
+              <a:t>4 rows + fresh request ID</a:t>
             </a:r>
           </a:p>
         </p:txBody>
@@ -22569,7 +22569,7 @@
           <p:cNvPr id="12" name="">
             <a:extLst xmlns:a="http://schemas.openxmlformats.org/drawingml/2006/main">
               <a:ext uri="{FF2B5EF4-FFF2-40B4-BE49-F238E27FC236}">
-                <a16:creationId xmlns:a16="http://schemas.microsoft.com/office/drawing/2014/main" id="{5F245668-235E-4F09-B5C9-20C9B266D874}"/>
+                <a16:creationId xmlns:a16="http://schemas.microsoft.com/office/drawing/2014/main" id="{7476BC40-DF8F-4C49-BE26-37E3F2F53FEA}"/>
               </a:ext>
             </a:extLst>
           </p:cNvPr>
@@ -22604,7 +22604,7 @@
           <p:cNvPr id="13" name="">
             <a:extLst xmlns:a="http://schemas.openxmlformats.org/drawingml/2006/main">
               <a:ext uri="{FF2B5EF4-FFF2-40B4-BE49-F238E27FC236}">
-                <a16:creationId xmlns:a16="http://schemas.microsoft.com/office/drawing/2014/main" id="{C2B6A958-2554-4D92-993C-53FA8BEF8048}"/>
+                <a16:creationId xmlns:a16="http://schemas.microsoft.com/office/drawing/2014/main" id="{EABC791F-2CF2-4946-B2ED-F82CFA188CB3}"/>
               </a:ext>
             </a:extLst>
           </p:cNvPr>
@@ -22761,7 +22761,7 @@
           <p:cNvPr id="14" name="">
             <a:extLst xmlns:a="http://schemas.openxmlformats.org/drawingml/2006/main">
               <a:ext uri="{FF2B5EF4-FFF2-40B4-BE49-F238E27FC236}">
-                <a16:creationId xmlns:a16="http://schemas.microsoft.com/office/drawing/2014/main" id="{BC9791C3-E39C-47C7-8A8A-C4C3F08F1A05}"/>
+                <a16:creationId xmlns:a16="http://schemas.microsoft.com/office/drawing/2014/main" id="{E8FD47AD-BBF7-4C36-9371-7C8B44BE0E71}"/>
               </a:ext>
             </a:extLst>
           </p:cNvPr>
@@ -22796,7 +22796,7 @@
           <p:cNvPr id="15" name="">
             <a:extLst xmlns:a="http://schemas.openxmlformats.org/drawingml/2006/main">
               <a:ext uri="{FF2B5EF4-FFF2-40B4-BE49-F238E27FC236}">
-                <a16:creationId xmlns:a16="http://schemas.microsoft.com/office/drawing/2014/main" id="{26B05A4D-2D57-407D-8B51-C20D8019F027}"/>
+                <a16:creationId xmlns:a16="http://schemas.microsoft.com/office/drawing/2014/main" id="{EB9B038A-DAF8-484A-8535-20C5D930CC31}"/>
               </a:ext>
             </a:extLst>
           </p:cNvPr>
@@ -22943,7 +22943,7 @@
                 <a:ea typeface="Aptos"/>
                 <a:cs typeface="Aptos"/>
               </a:rPr>
-              <a:t>SHA‑256 evidence digest</a:t>
+              <a:t>Official Meterless conformance</a:t>
             </a:r>
           </a:p>
         </p:txBody>
@@ -22953,7 +22953,7 @@
           <p:cNvPr id="16" name="">
             <a:extLst xmlns:a="http://schemas.openxmlformats.org/drawingml/2006/main">
               <a:ext uri="{FF2B5EF4-FFF2-40B4-BE49-F238E27FC236}">
-                <a16:creationId xmlns:a16="http://schemas.microsoft.com/office/drawing/2014/main" id="{B5490CD9-06BF-47E5-ACE4-64FAD44B2786}"/>
+                <a16:creationId xmlns:a16="http://schemas.microsoft.com/office/drawing/2014/main" id="{89A48689-4FB6-4021-A1A7-9D7EA3E1285A}"/>
               </a:ext>
             </a:extLst>
           </p:cNvPr>
@@ -23100,7 +23100,7 @@
                 <a:ea typeface="Aptos"/>
                 <a:cs typeface="Aptos"/>
               </a:rPr>
-              <a:t>payload integrity</a:t>
+              <a:t>reference engine + vectors</a:t>
             </a:r>
           </a:p>
         </p:txBody>
@@ -23110,7 +23110,7 @@
           <p:cNvPr id="17" name="">
             <a:extLst xmlns:a="http://schemas.openxmlformats.org/drawingml/2006/main">
               <a:ext uri="{FF2B5EF4-FFF2-40B4-BE49-F238E27FC236}">
-                <a16:creationId xmlns:a16="http://schemas.microsoft.com/office/drawing/2014/main" id="{0FD7CC2E-ACC3-4ADB-947B-5BCB33D10202}"/>
+                <a16:creationId xmlns:a16="http://schemas.microsoft.com/office/drawing/2014/main" id="{3044CA17-8CFE-4088-A345-1F4C532FAD83}"/>
               </a:ext>
             </a:extLst>
           </p:cNvPr>
@@ -23145,7 +23145,7 @@
           <p:cNvPr id="18" name="">
             <a:extLst xmlns:a="http://schemas.openxmlformats.org/drawingml/2006/main">
               <a:ext uri="{FF2B5EF4-FFF2-40B4-BE49-F238E27FC236}">
-                <a16:creationId xmlns:a16="http://schemas.microsoft.com/office/drawing/2014/main" id="{4155AF4D-C291-40B8-8701-698D8395596A}"/>
+                <a16:creationId xmlns:a16="http://schemas.microsoft.com/office/drawing/2014/main" id="{ECD26AF1-D7AE-4754-B1EE-BBAAA6F4F23B}"/>
               </a:ext>
             </a:extLst>
           </p:cNvPr>
@@ -23292,7 +23292,7 @@
                 <a:ea typeface="Aptos"/>
                 <a:cs typeface="Aptos"/>
               </a:rPr>
-              <a:t>VERIFIED</a:t>
+              <a:t>13 / 13</a:t>
             </a:r>
           </a:p>
         </p:txBody>
@@ -23302,7 +23302,7 @@
           <p:cNvPr id="19" name="">
             <a:extLst xmlns:a="http://schemas.openxmlformats.org/drawingml/2006/main">
               <a:ext uri="{FF2B5EF4-FFF2-40B4-BE49-F238E27FC236}">
-                <a16:creationId xmlns:a16="http://schemas.microsoft.com/office/drawing/2014/main" id="{346A9C04-0D25-4E8E-873F-8C5CE180B1D9}"/>
+                <a16:creationId xmlns:a16="http://schemas.microsoft.com/office/drawing/2014/main" id="{813A61C1-9C7F-45BE-B61C-E7AB5B42BC92}"/>
               </a:ext>
             </a:extLst>
           </p:cNvPr>
@@ -23337,7 +23337,7 @@
           <p:cNvPr id="20" name="">
             <a:extLst xmlns:a="http://schemas.openxmlformats.org/drawingml/2006/main">
               <a:ext uri="{FF2B5EF4-FFF2-40B4-BE49-F238E27FC236}">
-                <a16:creationId xmlns:a16="http://schemas.microsoft.com/office/drawing/2014/main" id="{A5D34880-691D-44BB-953A-8920AC434FFC}"/>
+                <a16:creationId xmlns:a16="http://schemas.microsoft.com/office/drawing/2014/main" id="{9D25D0BE-7E1E-41D3-B6E4-D3C02D247D92}"/>
               </a:ext>
             </a:extLst>
           </p:cNvPr>
@@ -23484,7 +23484,7 @@
                 <a:ea typeface="Aptos"/>
                 <a:cs typeface="Aptos"/>
               </a:rPr>
-              <a:t>Live Zetaris query</a:t>
+              <a:t>Python project suite</a:t>
             </a:r>
           </a:p>
         </p:txBody>
@@ -23494,7 +23494,7 @@
           <p:cNvPr id="21" name="">
             <a:extLst xmlns:a="http://schemas.openxmlformats.org/drawingml/2006/main">
               <a:ext uri="{FF2B5EF4-FFF2-40B4-BE49-F238E27FC236}">
-                <a16:creationId xmlns:a16="http://schemas.microsoft.com/office/drawing/2014/main" id="{CB9CAD84-07B4-405B-B982-1AF2A2B7BF82}"/>
+                <a16:creationId xmlns:a16="http://schemas.microsoft.com/office/drawing/2014/main" id="{167F13D2-5835-45A9-ABEC-2DF8AAFC2169}"/>
               </a:ext>
             </a:extLst>
           </p:cNvPr>
@@ -23641,7 +23641,7 @@
                 <a:ea typeface="Aptos"/>
                 <a:cs typeface="Aptos"/>
               </a:rPr>
-              <a:t>credential + receipt required</a:t>
+              <a:t>unit + integration behavior</a:t>
             </a:r>
           </a:p>
         </p:txBody>
@@ -23651,7 +23651,7 @@
           <p:cNvPr id="22" name="">
             <a:extLst xmlns:a="http://schemas.openxmlformats.org/drawingml/2006/main">
               <a:ext uri="{FF2B5EF4-FFF2-40B4-BE49-F238E27FC236}">
-                <a16:creationId xmlns:a16="http://schemas.microsoft.com/office/drawing/2014/main" id="{5CB4C0C0-6062-4C5B-8BF9-E7C64DBA4112}"/>
+                <a16:creationId xmlns:a16="http://schemas.microsoft.com/office/drawing/2014/main" id="{92190432-6ABD-450A-9DC3-333EC791ECB2}"/>
               </a:ext>
             </a:extLst>
           </p:cNvPr>
@@ -23671,11 +23671,11 @@
             </a:avLst>
           </a:prstGeom>
           <a:solidFill xmlns:a="http://schemas.openxmlformats.org/drawingml/2006/main">
-            <a:srgbClr val="FFBF69"/>
+            <a:srgbClr val="57D49B"/>
           </a:solidFill>
           <a:ln xmlns:a="http://schemas.openxmlformats.org/drawingml/2006/main" w="9525">
             <a:solidFill>
-              <a:srgbClr val="FFBF69"/>
+              <a:srgbClr val="57D49B"/>
             </a:solidFill>
             <a:prstDash val="solid"/>
           </a:ln>
@@ -23686,7 +23686,7 @@
           <p:cNvPr id="23" name="">
             <a:extLst xmlns:a="http://schemas.openxmlformats.org/drawingml/2006/main">
               <a:ext uri="{FF2B5EF4-FFF2-40B4-BE49-F238E27FC236}">
-                <a16:creationId xmlns:a16="http://schemas.microsoft.com/office/drawing/2014/main" id="{AE2F01B0-F02A-4318-9938-A873B33E17F3}"/>
+                <a16:creationId xmlns:a16="http://schemas.microsoft.com/office/drawing/2014/main" id="{28C045C6-F8F0-45F9-A088-607707387117}"/>
               </a:ext>
             </a:extLst>
           </p:cNvPr>
@@ -23833,7 +23833,7 @@
                 <a:ea typeface="Aptos"/>
                 <a:cs typeface="Aptos"/>
               </a:rPr>
-              <a:t>PENDING</a:t>
+              <a:t>24 / 24</a:t>
             </a:r>
           </a:p>
         </p:txBody>
@@ -23843,7 +23843,7 @@
           <p:cNvPr id="24" name="">
             <a:extLst xmlns:a="http://schemas.openxmlformats.org/drawingml/2006/main">
               <a:ext uri="{FF2B5EF4-FFF2-40B4-BE49-F238E27FC236}">
-                <a16:creationId xmlns:a16="http://schemas.microsoft.com/office/drawing/2014/main" id="{72B2B409-7FEE-4450-99EC-F098C9AACA74}"/>
+                <a16:creationId xmlns:a16="http://schemas.microsoft.com/office/drawing/2014/main" id="{B7C04986-5DAC-4764-964C-73476AB908A7}"/>
               </a:ext>
             </a:extLst>
           </p:cNvPr>
@@ -23878,7 +23878,7 @@
           <p:cNvPr id="25" name="">
             <a:extLst xmlns:a="http://schemas.openxmlformats.org/drawingml/2006/main">
               <a:ext uri="{FF2B5EF4-FFF2-40B4-BE49-F238E27FC236}">
-                <a16:creationId xmlns:a16="http://schemas.microsoft.com/office/drawing/2014/main" id="{2EF15DC8-F9B6-455E-866A-D43250AE5FEF}"/>
+                <a16:creationId xmlns:a16="http://schemas.microsoft.com/office/drawing/2014/main" id="{CD8DA10C-93C5-4120-80FC-633B77EFEED6}"/>
               </a:ext>
             </a:extLst>
           </p:cNvPr>
@@ -24025,7 +24025,7 @@
                 <a:ea typeface="Aptos"/>
                 <a:cs typeface="Aptos"/>
               </a:rPr>
-              <a:t>External model output</a:t>
+              <a:t>Production feeds / external model</a:t>
             </a:r>
           </a:p>
         </p:txBody>
@@ -24035,7 +24035,7 @@
           <p:cNvPr id="26" name="">
             <a:extLst xmlns:a="http://schemas.openxmlformats.org/drawingml/2006/main">
               <a:ext uri="{FF2B5EF4-FFF2-40B4-BE49-F238E27FC236}">
-                <a16:creationId xmlns:a16="http://schemas.microsoft.com/office/drawing/2014/main" id="{E2EB0AFE-7FD8-4869-BBCB-0ACDF8133CE7}"/>
+                <a16:creationId xmlns:a16="http://schemas.microsoft.com/office/drawing/2014/main" id="{ED83FC1E-0A43-4D54-BA1E-4FCEADE56518}"/>
               </a:ext>
             </a:extLst>
           </p:cNvPr>
@@ -24182,7 +24182,7 @@
                 <a:ea typeface="Aptos"/>
                 <a:cs typeface="Aptos"/>
               </a:rPr>
-              <a:t>optional adapter, no live claim</a:t>
+              <a:t>outside this verified release</a:t>
             </a:r>
           </a:p>
         </p:txBody>
@@ -24192,7 +24192,7 @@
           <p:cNvPr id="27" name="">
             <a:extLst xmlns:a="http://schemas.openxmlformats.org/drawingml/2006/main">
               <a:ext uri="{FF2B5EF4-FFF2-40B4-BE49-F238E27FC236}">
-                <a16:creationId xmlns:a16="http://schemas.microsoft.com/office/drawing/2014/main" id="{6F25AF20-C73C-47A6-85FB-E2B1F55C4588}"/>
+                <a16:creationId xmlns:a16="http://schemas.microsoft.com/office/drawing/2014/main" id="{8755153B-B7B3-46DF-876F-A3446DF31B8E}"/>
               </a:ext>
             </a:extLst>
           </p:cNvPr>
@@ -24227,7 +24227,7 @@
           <p:cNvPr id="28" name="">
             <a:extLst xmlns:a="http://schemas.openxmlformats.org/drawingml/2006/main">
               <a:ext uri="{FF2B5EF4-FFF2-40B4-BE49-F238E27FC236}">
-                <a16:creationId xmlns:a16="http://schemas.microsoft.com/office/drawing/2014/main" id="{948BFE70-65FB-488F-8DC6-181E04643DB8}"/>
+                <a16:creationId xmlns:a16="http://schemas.microsoft.com/office/drawing/2014/main" id="{E67A2E8E-A980-4CB3-AD08-47FD46E4FB47}"/>
               </a:ext>
             </a:extLst>
           </p:cNvPr>
@@ -24384,7 +24384,7 @@
           <p:cNvPr id="29" name="">
             <a:extLst xmlns:a="http://schemas.openxmlformats.org/drawingml/2006/main">
               <a:ext uri="{FF2B5EF4-FFF2-40B4-BE49-F238E27FC236}">
-                <a16:creationId xmlns:a16="http://schemas.microsoft.com/office/drawing/2014/main" id="{76B71438-EC59-450E-A519-C083262914F7}"/>
+                <a16:creationId xmlns:a16="http://schemas.microsoft.com/office/drawing/2014/main" id="{F341B085-4DFB-4FCF-A53A-718B54475B34}"/>
               </a:ext>
             </a:extLst>
           </p:cNvPr>
@@ -24415,7 +24415,7 @@
           <p:cNvPr id="30" name="">
             <a:extLst xmlns:a="http://schemas.openxmlformats.org/drawingml/2006/main">
               <a:ext uri="{FF2B5EF4-FFF2-40B4-BE49-F238E27FC236}">
-                <a16:creationId xmlns:a16="http://schemas.microsoft.com/office/drawing/2014/main" id="{E991D058-B700-420C-9CCF-66F0ED84F8DA}"/>
+                <a16:creationId xmlns:a16="http://schemas.microsoft.com/office/drawing/2014/main" id="{0FDBDC37-B9F9-4F11-91CF-0C18A6BA7AEF}"/>
               </a:ext>
             </a:extLst>
           </p:cNvPr>
@@ -24572,7 +24572,7 @@
           <p:cNvPr id="31" name="">
             <a:extLst xmlns:a="http://schemas.openxmlformats.org/drawingml/2006/main">
               <a:ext uri="{FF2B5EF4-FFF2-40B4-BE49-F238E27FC236}">
-                <a16:creationId xmlns:a16="http://schemas.microsoft.com/office/drawing/2014/main" id="{485BB4A4-BC65-454D-B731-AD3B82F05FDC}"/>
+                <a16:creationId xmlns:a16="http://schemas.microsoft.com/office/drawing/2014/main" id="{5F2CD7A3-9C6A-4672-9747-FA82EF5157C2}"/>
               </a:ext>
             </a:extLst>
           </p:cNvPr>
@@ -24727,7 +24727,7 @@
     </p:spTree>
     <p:extLst>
       <p:ext uri="{BB962C8B-B14F-4D97-AF65-F5344CB8AC3E}">
-        <p14:creationId xmlns:p14="http://schemas.microsoft.com/office/powerpoint/2010/main" val="283142137"/>
+        <p14:creationId xmlns:p14="http://schemas.microsoft.com/office/powerpoint/2010/main" val="1712458400"/>
       </p:ext>
     </p:extLst>
   </p:cSld>
@@ -24758,7 +24758,7 @@
           <p:cNvPr id="25" name="">
             <a:extLst xmlns:a="http://schemas.openxmlformats.org/drawingml/2006/main">
               <a:ext uri="{FF2B5EF4-FFF2-40B4-BE49-F238E27FC236}">
-                <a16:creationId xmlns:a16="http://schemas.microsoft.com/office/drawing/2014/main" id="{7717E067-D8E0-4437-BE70-EB4315695DFA}"/>
+                <a16:creationId xmlns:a16="http://schemas.microsoft.com/office/drawing/2014/main" id="{98D96CBE-7839-48B6-B67F-70E8E6A98D55}"/>
               </a:ext>
             </a:extLst>
           </p:cNvPr>
@@ -24905,7 +24905,7 @@
                 <a:ea typeface="Aptos"/>
                 <a:cs typeface="Aptos"/>
               </a:rPr>
-              <a:t>DEMO</a:t>
+              <a:t>RELEASE</a:t>
             </a:r>
           </a:p>
         </p:txBody>
@@ -24915,7 +24915,7 @@
           <p:cNvPr id="2" name="">
             <a:extLst xmlns:a="http://schemas.openxmlformats.org/drawingml/2006/main">
               <a:ext uri="{FF2B5EF4-FFF2-40B4-BE49-F238E27FC236}">
-                <a16:creationId xmlns:a16="http://schemas.microsoft.com/office/drawing/2014/main" id="{3E700549-AF53-465B-A77B-88242FFCE545}"/>
+                <a16:creationId xmlns:a16="http://schemas.microsoft.com/office/drawing/2014/main" id="{D4E0D940-9102-4DF2-8705-331F825100E9}"/>
               </a:ext>
             </a:extLst>
           </p:cNvPr>
@@ -25062,7 +25062,7 @@
                 <a:ea typeface="Aptos"/>
                 <a:cs typeface="Aptos"/>
               </a:rPr>
-              <a:t>Run the proof in two commands</a:t>
+              <a:t>Inspect the proof, not a promise</a:t>
             </a:r>
           </a:p>
         </p:txBody>
@@ -25072,7 +25072,7 @@
           <p:cNvPr id="3" name="">
             <a:extLst xmlns:a="http://schemas.openxmlformats.org/drawingml/2006/main">
               <a:ext uri="{FF2B5EF4-FFF2-40B4-BE49-F238E27FC236}">
-                <a16:creationId xmlns:a16="http://schemas.microsoft.com/office/drawing/2014/main" id="{6FB15141-1822-44D6-94DC-5F82FBA858D1}"/>
+                <a16:creationId xmlns:a16="http://schemas.microsoft.com/office/drawing/2014/main" id="{1B6D00EC-83C8-4FFB-A822-6A8F0B2052C0}"/>
               </a:ext>
             </a:extLst>
           </p:cNvPr>
@@ -25219,7 +25219,7 @@
                 <a:ea typeface="Aptos"/>
                 <a:cs typeface="Aptos"/>
               </a:rPr>
-              <a:t>No hidden notebook, no silent fallback, no unverifiable integration claim.</a:t>
+              <a:t>Source, receipts, tests, deck and demo are published together in the event-specific repository.</a:t>
             </a:r>
           </a:p>
         </p:txBody>
@@ -25229,7 +25229,7 @@
           <p:cNvPr id="4" name="">
             <a:extLst xmlns:a="http://schemas.openxmlformats.org/drawingml/2006/main">
               <a:ext uri="{FF2B5EF4-FFF2-40B4-BE49-F238E27FC236}">
-                <a16:creationId xmlns:a16="http://schemas.microsoft.com/office/drawing/2014/main" id="{FF66CB2E-0542-413F-8075-437DB259F755}"/>
+                <a16:creationId xmlns:a16="http://schemas.microsoft.com/office/drawing/2014/main" id="{1FE82C54-918E-4089-8DC9-3A757D2AAD31}"/>
               </a:ext>
             </a:extLst>
           </p:cNvPr>
@@ -25264,7 +25264,7 @@
           <p:cNvPr id="5" name="">
             <a:extLst xmlns:a="http://schemas.openxmlformats.org/drawingml/2006/main">
               <a:ext uri="{FF2B5EF4-FFF2-40B4-BE49-F238E27FC236}">
-                <a16:creationId xmlns:a16="http://schemas.microsoft.com/office/drawing/2014/main" id="{87C16B86-A6EC-4670-9946-75D574B147A4}"/>
+                <a16:creationId xmlns:a16="http://schemas.microsoft.com/office/drawing/2014/main" id="{FF766237-893F-4BF2-9CBC-A3383126234F}"/>
               </a:ext>
             </a:extLst>
           </p:cNvPr>
@@ -25421,7 +25421,7 @@
           <p:cNvPr id="6" name="">
             <a:extLst xmlns:a="http://schemas.openxmlformats.org/drawingml/2006/main">
               <a:ext uri="{FF2B5EF4-FFF2-40B4-BE49-F238E27FC236}">
-                <a16:creationId xmlns:a16="http://schemas.microsoft.com/office/drawing/2014/main" id="{D3211956-D509-4030-A84F-B736983FA402}"/>
+                <a16:creationId xmlns:a16="http://schemas.microsoft.com/office/drawing/2014/main" id="{A99609C8-572E-44D2-A689-FC935858BE57}"/>
               </a:ext>
             </a:extLst>
           </p:cNvPr>
@@ -25568,7 +25568,7 @@
                 <a:ea typeface="Aptos"/>
                 <a:cs typeface="Aptos"/>
               </a:rPr>
-              <a:t>21 tests · 0 failures · 0 errors</a:t>
+              <a:t>24 tests · 0 failures · 0 errors</a:t>
             </a:r>
           </a:p>
         </p:txBody>
@@ -25578,7 +25578,7 @@
           <p:cNvPr id="7" name="">
             <a:extLst xmlns:a="http://schemas.openxmlformats.org/drawingml/2006/main">
               <a:ext uri="{FF2B5EF4-FFF2-40B4-BE49-F238E27FC236}">
-                <a16:creationId xmlns:a16="http://schemas.microsoft.com/office/drawing/2014/main" id="{18AEE5E6-9A6A-40FA-B890-F0713D2B9905}"/>
+                <a16:creationId xmlns:a16="http://schemas.microsoft.com/office/drawing/2014/main" id="{EC2E0722-00DA-4629-963D-A811CECC10F9}"/>
               </a:ext>
             </a:extLst>
           </p:cNvPr>
@@ -25725,7 +25725,7 @@
                 <a:ea typeface="Aptos"/>
                 <a:cs typeface="Aptos"/>
               </a:rPr>
-              <a:t>$ python3 agent/cli.py --dry-run</a:t>
+              <a:t>$ jq . evidence/*.json</a:t>
             </a:r>
           </a:p>
         </p:txBody>
@@ -25735,7 +25735,7 @@
           <p:cNvPr id="8" name="">
             <a:extLst xmlns:a="http://schemas.openxmlformats.org/drawingml/2006/main">
               <a:ext uri="{FF2B5EF4-FFF2-40B4-BE49-F238E27FC236}">
-                <a16:creationId xmlns:a16="http://schemas.microsoft.com/office/drawing/2014/main" id="{B32941B9-3931-482D-A104-59BB962AE4E8}"/>
+                <a16:creationId xmlns:a16="http://schemas.microsoft.com/office/drawing/2014/main" id="{48D016BC-302C-4E8E-9E21-C0A231426D0A}"/>
               </a:ext>
             </a:extLst>
           </p:cNvPr>
@@ -25882,7 +25882,7 @@
                 <a:ea typeface="Aptos"/>
                 <a:cs typeface="Aptos"/>
               </a:rPr>
-              <a:t>OFFLINE_SIMULATION + H‑MEM receipt + SHA‑256 digest</a:t>
+              <a:t>Zetaris 9/9 · Meterless 13/13 · redaction-safe receipts</a:t>
             </a:r>
           </a:p>
         </p:txBody>
@@ -25892,7 +25892,7 @@
           <p:cNvPr id="9" name="">
             <a:extLst xmlns:a="http://schemas.openxmlformats.org/drawingml/2006/main">
               <a:ext uri="{FF2B5EF4-FFF2-40B4-BE49-F238E27FC236}">
-                <a16:creationId xmlns:a16="http://schemas.microsoft.com/office/drawing/2014/main" id="{5CC309BF-1224-4D89-949A-4120B2EE3838}"/>
+                <a16:creationId xmlns:a16="http://schemas.microsoft.com/office/drawing/2014/main" id="{F0DD5B22-EFE0-477B-A551-1B1D429E55C5}"/>
               </a:ext>
             </a:extLst>
           </p:cNvPr>
@@ -25927,7 +25927,7 @@
           <p:cNvPr id="10" name="">
             <a:extLst xmlns:a="http://schemas.openxmlformats.org/drawingml/2006/main">
               <a:ext uri="{FF2B5EF4-FFF2-40B4-BE49-F238E27FC236}">
-                <a16:creationId xmlns:a16="http://schemas.microsoft.com/office/drawing/2014/main" id="{46CA505A-C9B8-4AC2-9839-660B04CF11E7}"/>
+                <a16:creationId xmlns:a16="http://schemas.microsoft.com/office/drawing/2014/main" id="{90B29411-F23E-4AC3-999A-245170889854}"/>
               </a:ext>
             </a:extLst>
           </p:cNvPr>
@@ -26084,7 +26084,7 @@
           <p:cNvPr id="11" name="">
             <a:extLst xmlns:a="http://schemas.openxmlformats.org/drawingml/2006/main">
               <a:ext uri="{FF2B5EF4-FFF2-40B4-BE49-F238E27FC236}">
-                <a16:creationId xmlns:a16="http://schemas.microsoft.com/office/drawing/2014/main" id="{5A69B679-E1DE-4140-9485-6602DCE77BAB}"/>
+                <a16:creationId xmlns:a16="http://schemas.microsoft.com/office/drawing/2014/main" id="{4BD520C9-4B9A-41C1-AD77-B071D1B06B54}"/>
               </a:ext>
             </a:extLst>
           </p:cNvPr>
@@ -26119,7 +26119,7 @@
           <p:cNvPr id="12" name="">
             <a:extLst xmlns:a="http://schemas.openxmlformats.org/drawingml/2006/main">
               <a:ext uri="{FF2B5EF4-FFF2-40B4-BE49-F238E27FC236}">
-                <a16:creationId xmlns:a16="http://schemas.microsoft.com/office/drawing/2014/main" id="{65BF27FA-3FCC-4308-85A3-429FB29CE143}"/>
+                <a16:creationId xmlns:a16="http://schemas.microsoft.com/office/drawing/2014/main" id="{662928D8-2656-44FD-B843-6F3BA0F2004D}"/>
               </a:ext>
             </a:extLst>
           </p:cNvPr>
@@ -26276,7 +26276,7 @@
           <p:cNvPr id="13" name="">
             <a:extLst xmlns:a="http://schemas.openxmlformats.org/drawingml/2006/main">
               <a:ext uri="{FF2B5EF4-FFF2-40B4-BE49-F238E27FC236}">
-                <a16:creationId xmlns:a16="http://schemas.microsoft.com/office/drawing/2014/main" id="{1CF5CD3E-D1C6-466B-9DEC-27FB5EE04917}"/>
+                <a16:creationId xmlns:a16="http://schemas.microsoft.com/office/drawing/2014/main" id="{893F454C-DD27-415A-A2C3-52D4357ED0A8}"/>
               </a:ext>
             </a:extLst>
           </p:cNvPr>
@@ -26311,7 +26311,7 @@
           <p:cNvPr id="14" name="">
             <a:extLst xmlns:a="http://schemas.openxmlformats.org/drawingml/2006/main">
               <a:ext uri="{FF2B5EF4-FFF2-40B4-BE49-F238E27FC236}">
-                <a16:creationId xmlns:a16="http://schemas.microsoft.com/office/drawing/2014/main" id="{43F8CEAE-2CC7-4095-AAEB-5D6373C92018}"/>
+                <a16:creationId xmlns:a16="http://schemas.microsoft.com/office/drawing/2014/main" id="{DEC133E1-92EC-4FFF-A757-40B676EAA832}"/>
               </a:ext>
             </a:extLst>
           </p:cNvPr>
@@ -26340,7 +26340,7 @@
             <a:defPPr algn="l">
               <a:defRPr sz="1275" b="0">
                 <a:solidFill>
-                  <a:srgbClr val="FFBF69"/>
+                  <a:srgbClr val="57D49B"/>
                 </a:solidFill>
                 <a:latin typeface="Aptos"/>
                 <a:ea typeface="Aptos"/>
@@ -26350,7 +26350,7 @@
             <a:lvl1pPr algn="l">
               <a:defRPr sz="1275" b="0">
                 <a:solidFill>
-                  <a:srgbClr val="FFBF69"/>
+                  <a:srgbClr val="57D49B"/>
                 </a:solidFill>
                 <a:latin typeface="Aptos"/>
                 <a:ea typeface="Aptos"/>
@@ -26360,7 +26360,7 @@
             <a:lvl2pPr algn="l">
               <a:defRPr sz="1275" b="0">
                 <a:solidFill>
-                  <a:srgbClr val="FFBF69"/>
+                  <a:srgbClr val="57D49B"/>
                 </a:solidFill>
                 <a:latin typeface="Aptos"/>
                 <a:ea typeface="Aptos"/>
@@ -26370,7 +26370,7 @@
             <a:lvl3pPr algn="l">
               <a:defRPr sz="1275" b="0">
                 <a:solidFill>
-                  <a:srgbClr val="FFBF69"/>
+                  <a:srgbClr val="57D49B"/>
                 </a:solidFill>
                 <a:latin typeface="Aptos"/>
                 <a:ea typeface="Aptos"/>
@@ -26380,7 +26380,7 @@
             <a:lvl4pPr algn="l">
               <a:defRPr sz="1275" b="0">
                 <a:solidFill>
-                  <a:srgbClr val="FFBF69"/>
+                  <a:srgbClr val="57D49B"/>
                 </a:solidFill>
                 <a:latin typeface="Aptos"/>
                 <a:ea typeface="Aptos"/>
@@ -26390,7 +26390,7 @@
             <a:lvl5pPr algn="l">
               <a:defRPr sz="1275" b="0">
                 <a:solidFill>
-                  <a:srgbClr val="FFBF69"/>
+                  <a:srgbClr val="57D49B"/>
                 </a:solidFill>
                 <a:latin typeface="Aptos"/>
                 <a:ea typeface="Aptos"/>
@@ -26400,7 +26400,7 @@
             <a:lvl6pPr algn="l">
               <a:defRPr sz="1275" b="0">
                 <a:solidFill>
-                  <a:srgbClr val="FFBF69"/>
+                  <a:srgbClr val="57D49B"/>
                 </a:solidFill>
                 <a:latin typeface="Aptos"/>
                 <a:ea typeface="Aptos"/>
@@ -26410,7 +26410,7 @@
             <a:lvl7pPr algn="l">
               <a:defRPr sz="1275" b="0">
                 <a:solidFill>
-                  <a:srgbClr val="FFBF69"/>
+                  <a:srgbClr val="57D49B"/>
                 </a:solidFill>
                 <a:latin typeface="Aptos"/>
                 <a:ea typeface="Aptos"/>
@@ -26420,7 +26420,7 @@
             <a:lvl8pPr algn="l">
               <a:defRPr sz="1275" b="0">
                 <a:solidFill>
-                  <a:srgbClr val="FFBF69"/>
+                  <a:srgbClr val="57D49B"/>
                 </a:solidFill>
                 <a:latin typeface="Aptos"/>
                 <a:ea typeface="Aptos"/>
@@ -26430,7 +26430,7 @@
             <a:lvl9pPr algn="l">
               <a:defRPr sz="1275" b="0">
                 <a:solidFill>
-                  <a:srgbClr val="FFBF69"/>
+                  <a:srgbClr val="57D49B"/>
                 </a:solidFill>
                 <a:latin typeface="Aptos"/>
                 <a:ea typeface="Aptos"/>
@@ -26442,7 +26442,7 @@
             <a:pPr algn="l">
               <a:defRPr sz="1275" b="0">
                 <a:solidFill>
-                  <a:srgbClr val="FFBF69"/>
+                  <a:srgbClr val="57D49B"/>
                 </a:solidFill>
                 <a:latin typeface="Aptos"/>
                 <a:ea typeface="Aptos"/>
@@ -26452,7 +26452,7 @@
             <a:r>
               <a:rPr sz="1275" b="0">
                 <a:solidFill>
-                  <a:srgbClr val="FFBF69"/>
+                  <a:srgbClr val="57D49B"/>
                 </a:solidFill>
                 <a:latin typeface="Aptos"/>
                 <a:ea typeface="Aptos"/>
@@ -26468,7 +26468,7 @@
           <p:cNvPr id="15" name="">
             <a:extLst xmlns:a="http://schemas.openxmlformats.org/drawingml/2006/main">
               <a:ext uri="{FF2B5EF4-FFF2-40B4-BE49-F238E27FC236}">
-                <a16:creationId xmlns:a16="http://schemas.microsoft.com/office/drawing/2014/main" id="{6A114BD8-0C38-4332-BDCC-8FA56A3187E5}"/>
+                <a16:creationId xmlns:a16="http://schemas.microsoft.com/office/drawing/2014/main" id="{74A6BD1B-0784-4523-812F-1515504C1C8B}"/>
               </a:ext>
             </a:extLst>
           </p:cNvPr>
@@ -26503,7 +26503,7 @@
           <p:cNvPr id="16" name="">
             <a:extLst xmlns:a="http://schemas.openxmlformats.org/drawingml/2006/main">
               <a:ext uri="{FF2B5EF4-FFF2-40B4-BE49-F238E27FC236}">
-                <a16:creationId xmlns:a16="http://schemas.microsoft.com/office/drawing/2014/main" id="{04AC0A94-F40D-4AA4-9265-F8A1209F5AF9}"/>
+                <a16:creationId xmlns:a16="http://schemas.microsoft.com/office/drawing/2014/main" id="{1D36853C-3314-414A-8233-0C5CE2E33F8A}"/>
               </a:ext>
             </a:extLst>
           </p:cNvPr>
@@ -26532,7 +26532,7 @@
             <a:defPPr algn="l">
               <a:defRPr sz="1275" b="0">
                 <a:solidFill>
-                  <a:srgbClr val="FFBF69"/>
+                  <a:srgbClr val="57D49B"/>
                 </a:solidFill>
                 <a:latin typeface="Aptos"/>
                 <a:ea typeface="Aptos"/>
@@ -26542,7 +26542,7 @@
             <a:lvl1pPr algn="l">
               <a:defRPr sz="1275" b="0">
                 <a:solidFill>
-                  <a:srgbClr val="FFBF69"/>
+                  <a:srgbClr val="57D49B"/>
                 </a:solidFill>
                 <a:latin typeface="Aptos"/>
                 <a:ea typeface="Aptos"/>
@@ -26552,7 +26552,7 @@
             <a:lvl2pPr algn="l">
               <a:defRPr sz="1275" b="0">
                 <a:solidFill>
-                  <a:srgbClr val="FFBF69"/>
+                  <a:srgbClr val="57D49B"/>
                 </a:solidFill>
                 <a:latin typeface="Aptos"/>
                 <a:ea typeface="Aptos"/>
@@ -26562,7 +26562,7 @@
             <a:lvl3pPr algn="l">
               <a:defRPr sz="1275" b="0">
                 <a:solidFill>
-                  <a:srgbClr val="FFBF69"/>
+                  <a:srgbClr val="57D49B"/>
                 </a:solidFill>
                 <a:latin typeface="Aptos"/>
                 <a:ea typeface="Aptos"/>
@@ -26572,7 +26572,7 @@
             <a:lvl4pPr algn="l">
               <a:defRPr sz="1275" b="0">
                 <a:solidFill>
-                  <a:srgbClr val="FFBF69"/>
+                  <a:srgbClr val="57D49B"/>
                 </a:solidFill>
                 <a:latin typeface="Aptos"/>
                 <a:ea typeface="Aptos"/>
@@ -26582,7 +26582,7 @@
             <a:lvl5pPr algn="l">
               <a:defRPr sz="1275" b="0">
                 <a:solidFill>
-                  <a:srgbClr val="FFBF69"/>
+                  <a:srgbClr val="57D49B"/>
                 </a:solidFill>
                 <a:latin typeface="Aptos"/>
                 <a:ea typeface="Aptos"/>
@@ -26592,7 +26592,7 @@
             <a:lvl6pPr algn="l">
               <a:defRPr sz="1275" b="0">
                 <a:solidFill>
-                  <a:srgbClr val="FFBF69"/>
+                  <a:srgbClr val="57D49B"/>
                 </a:solidFill>
                 <a:latin typeface="Aptos"/>
                 <a:ea typeface="Aptos"/>
@@ -26602,7 +26602,7 @@
             <a:lvl7pPr algn="l">
               <a:defRPr sz="1275" b="0">
                 <a:solidFill>
-                  <a:srgbClr val="FFBF69"/>
+                  <a:srgbClr val="57D49B"/>
                 </a:solidFill>
                 <a:latin typeface="Aptos"/>
                 <a:ea typeface="Aptos"/>
@@ -26612,7 +26612,7 @@
             <a:lvl8pPr algn="l">
               <a:defRPr sz="1275" b="0">
                 <a:solidFill>
-                  <a:srgbClr val="FFBF69"/>
+                  <a:srgbClr val="57D49B"/>
                 </a:solidFill>
                 <a:latin typeface="Aptos"/>
                 <a:ea typeface="Aptos"/>
@@ -26622,7 +26622,7 @@
             <a:lvl9pPr algn="l">
               <a:defRPr sz="1275" b="0">
                 <a:solidFill>
-                  <a:srgbClr val="FFBF69"/>
+                  <a:srgbClr val="57D49B"/>
                 </a:solidFill>
                 <a:latin typeface="Aptos"/>
                 <a:ea typeface="Aptos"/>
@@ -26634,7 +26634,7 @@
             <a:pPr algn="l">
               <a:defRPr sz="1275" b="0">
                 <a:solidFill>
-                  <a:srgbClr val="FFBF69"/>
+                  <a:srgbClr val="57D49B"/>
                 </a:solidFill>
                 <a:latin typeface="Aptos"/>
                 <a:ea typeface="Aptos"/>
@@ -26644,13 +26644,13 @@
             <a:r>
               <a:rPr sz="1275" b="0">
                 <a:solidFill>
-                  <a:srgbClr val="FFBF69"/>
+                  <a:srgbClr val="57D49B"/>
                 </a:solidFill>
                 <a:latin typeface="Aptos"/>
                 <a:ea typeface="Aptos"/>
                 <a:cs typeface="Aptos"/>
               </a:rPr>
-              <a:t>Live Zetaris receipt</a:t>
+              <a:t>Live sponsor receipts</a:t>
             </a:r>
           </a:p>
         </p:txBody>
@@ -26660,7 +26660,7 @@
           <p:cNvPr id="17" name="">
             <a:extLst xmlns:a="http://schemas.openxmlformats.org/drawingml/2006/main">
               <a:ext uri="{FF2B5EF4-FFF2-40B4-BE49-F238E27FC236}">
-                <a16:creationId xmlns:a16="http://schemas.microsoft.com/office/drawing/2014/main" id="{5297FE9C-1D01-406D-9840-1817DE022F30}"/>
+                <a16:creationId xmlns:a16="http://schemas.microsoft.com/office/drawing/2014/main" id="{2394BF8D-4F80-49BA-B3F8-F364E13A2EED}"/>
               </a:ext>
             </a:extLst>
           </p:cNvPr>
@@ -26695,7 +26695,7 @@
           <p:cNvPr id="18" name="">
             <a:extLst xmlns:a="http://schemas.openxmlformats.org/drawingml/2006/main">
               <a:ext uri="{FF2B5EF4-FFF2-40B4-BE49-F238E27FC236}">
-                <a16:creationId xmlns:a16="http://schemas.microsoft.com/office/drawing/2014/main" id="{EBB814AA-33AE-4DFB-88BF-4E9A46A0CB59}"/>
+                <a16:creationId xmlns:a16="http://schemas.microsoft.com/office/drawing/2014/main" id="{5A62AA19-B389-44F0-AD96-63E202BAA001}"/>
               </a:ext>
             </a:extLst>
           </p:cNvPr>
@@ -26852,7 +26852,7 @@
           <p:cNvPr id="19" name="">
             <a:extLst xmlns:a="http://schemas.openxmlformats.org/drawingml/2006/main">
               <a:ext uri="{FF2B5EF4-FFF2-40B4-BE49-F238E27FC236}">
-                <a16:creationId xmlns:a16="http://schemas.microsoft.com/office/drawing/2014/main" id="{59B33394-D4DE-4301-B639-57A048A64F35}"/>
+                <a16:creationId xmlns:a16="http://schemas.microsoft.com/office/drawing/2014/main" id="{36C49BF9-C5B8-4BBB-9445-E117D34CBA1E}"/>
               </a:ext>
             </a:extLst>
           </p:cNvPr>
@@ -27009,7 +27009,7 @@
           <p:cNvPr id="20" name="">
             <a:extLst xmlns:a="http://schemas.openxmlformats.org/drawingml/2006/main">
               <a:ext uri="{FF2B5EF4-FFF2-40B4-BE49-F238E27FC236}">
-                <a16:creationId xmlns:a16="http://schemas.microsoft.com/office/drawing/2014/main" id="{BA36F8B6-8EFC-49D2-85FD-96ADF66F6F01}"/>
+                <a16:creationId xmlns:a16="http://schemas.microsoft.com/office/drawing/2014/main" id="{4D32A2CB-28A0-47DF-A93A-C0A342EBD9A7}"/>
               </a:ext>
             </a:extLst>
           </p:cNvPr>
@@ -27044,7 +27044,7 @@
           <p:cNvPr id="21" name="">
             <a:extLst xmlns:a="http://schemas.openxmlformats.org/drawingml/2006/main">
               <a:ext uri="{FF2B5EF4-FFF2-40B4-BE49-F238E27FC236}">
-                <a16:creationId xmlns:a16="http://schemas.microsoft.com/office/drawing/2014/main" id="{33CE0FBD-BB57-4D10-9C2A-E529EA697F07}"/>
+                <a16:creationId xmlns:a16="http://schemas.microsoft.com/office/drawing/2014/main" id="{8D9DC702-EC45-41E8-B388-9F22486D92FA}"/>
               </a:ext>
             </a:extLst>
           </p:cNvPr>
@@ -27201,7 +27201,7 @@
           <p:cNvPr id="22" name="">
             <a:extLst xmlns:a="http://schemas.openxmlformats.org/drawingml/2006/main">
               <a:ext uri="{FF2B5EF4-FFF2-40B4-BE49-F238E27FC236}">
-                <a16:creationId xmlns:a16="http://schemas.microsoft.com/office/drawing/2014/main" id="{F4A6B3A6-0220-4F2C-8C3A-243B1C767164}"/>
+                <a16:creationId xmlns:a16="http://schemas.microsoft.com/office/drawing/2014/main" id="{54149A48-A7F4-4DE0-85F4-A6CA75B98143}"/>
               </a:ext>
             </a:extLst>
           </p:cNvPr>
@@ -27232,7 +27232,7 @@
           <p:cNvPr id="23" name="">
             <a:extLst xmlns:a="http://schemas.openxmlformats.org/drawingml/2006/main">
               <a:ext uri="{FF2B5EF4-FFF2-40B4-BE49-F238E27FC236}">
-                <a16:creationId xmlns:a16="http://schemas.microsoft.com/office/drawing/2014/main" id="{F755234D-C2F6-434E-846F-A13378360C55}"/>
+                <a16:creationId xmlns:a16="http://schemas.microsoft.com/office/drawing/2014/main" id="{E6149B51-031C-4832-A8B9-CA5DEA82C861}"/>
               </a:ext>
             </a:extLst>
           </p:cNvPr>
@@ -27389,7 +27389,7 @@
           <p:cNvPr id="24" name="">
             <a:extLst xmlns:a="http://schemas.openxmlformats.org/drawingml/2006/main">
               <a:ext uri="{FF2B5EF4-FFF2-40B4-BE49-F238E27FC236}">
-                <a16:creationId xmlns:a16="http://schemas.microsoft.com/office/drawing/2014/main" id="{107A0E09-7C67-4776-9C06-E73FE532D5FA}"/>
+                <a16:creationId xmlns:a16="http://schemas.microsoft.com/office/drawing/2014/main" id="{1C6071C5-9C41-4745-8EBE-9B0555B58985}"/>
               </a:ext>
             </a:extLst>
           </p:cNvPr>
@@ -27544,7 +27544,7 @@
     </p:spTree>
     <p:extLst>
       <p:ext uri="{BB962C8B-B14F-4D97-AF65-F5344CB8AC3E}">
-        <p14:creationId xmlns:p14="http://schemas.microsoft.com/office/powerpoint/2010/main" val="1189937809"/>
+        <p14:creationId xmlns:p14="http://schemas.microsoft.com/office/powerpoint/2010/main" val="496461384"/>
       </p:ext>
     </p:extLst>
   </p:cSld>

</xml_diff>